<commit_message>
docs: adjust presentation deck to be business-oriented and non-technical for senior officials
</commit_message>
<xml_diff>
--- a/resources/HR_Portal_Presentation.pptx
+++ b/resources/HR_Portal_Presentation.pptx
@@ -12,7 +12,6 @@
     <p:sldId id="260" r:id="rId11"/>
     <p:sldId id="261" r:id="rId12"/>
     <p:sldId id="262" r:id="rId13"/>
-    <p:sldId id="263" r:id="rId14"/>
   </p:sldIdLst>
   <p:sldSz cx="12191695" cy="6858000" type="screen4x3"/>
   <p:notesSz cx="6858000" cy="9144000"/>
@@ -3134,7 +3133,7 @@
               </a:defRPr>
             </a:pPr>
             <a:r>
-              <a:t>HR Portal: Recruitment &amp; Smart Analytics</a:t>
+              <a:t>Smart Recruitment Portal &amp; Roster Analytics</a:t>
             </a:r>
           </a:p>
           <a:p>
@@ -3150,7 +3149,7 @@
               </a:defRPr>
             </a:pPr>
             <a:r>
-              <a:t>Automated application tracking, candidate dossiers, and optimized multi-degree exports</a:t>
+              <a:t>Streamlining applicant tracking, structured data validation, and clean decision-ready reporting</a:t>
             </a:r>
           </a:p>
           <a:p>
@@ -3166,7 +3165,7 @@
               </a:defRPr>
             </a:pPr>
             <a:r>
-              <a:t>Comprehensive Presentation Deck  •  Project System Overview</a:t>
+              <a:t>Operational Overview Presentation  •  Solutions &amp; Business Benefits</a:t>
             </a:r>
           </a:p>
         </p:txBody>
@@ -3228,7 +3227,7 @@
               </a:defRPr>
             </a:pPr>
             <a:r>
-              <a:t>Project Focus: Recruitment Efficiency</a:t>
+              <a:t>The Core Challenge: Spreadsheet Delimiter Bottleneck</a:t>
             </a:r>
           </a:p>
         </p:txBody>
@@ -3264,7 +3263,7 @@
               </a:defRPr>
             </a:pPr>
             <a:r>
-              <a:t>THE RECRUITMENT CHALLENGE</a:t>
+              <a:t>LEGACY PROCESS ISSUES</a:t>
             </a:r>
           </a:p>
           <a:p>
@@ -3283,7 +3282,7 @@
               </a:defRPr>
             </a:pPr>
             <a:r>
-              <a:t>Delimiter Clumping &amp; Horizontal Sprawl</a:t>
+              <a:t>Messy Data &amp; Broken Layouts</a:t>
             </a:r>
           </a:p>
           <a:p>
@@ -3299,7 +3298,7 @@
               </a:defRPr>
             </a:pPr>
             <a:r>
-              <a:t>• Delimited data clumped into single spreadsheet cells (e.g. multiple publications in one string), breaking automated parsing.</a:t>
+              <a:t>• Multiple qualifications/jobs clumped into single cells with commas or semicolons, making search and sorting impossible.</a:t>
             </a:r>
           </a:p>
           <a:p>
@@ -3315,7 +3314,7 @@
               </a:defRPr>
             </a:pPr>
             <a:r>
-              <a:t>• Infinite columns repeating horizontally (e.g. UG1, UG2, Work1, Work2) leading to massive empty spaces.</a:t>
+              <a:t>• Spreadsheets stretching infinitely to the right with redundant blank columns, causing 'horizontal scrolling fatigue'.</a:t>
             </a:r>
           </a:p>
           <a:p>
@@ -3331,7 +3330,7 @@
               </a:defRPr>
             </a:pPr>
             <a:r>
-              <a:t>• Inconsistent academic scoring formats (e.g., mix of percentage text, varying decimal precision, and trailing 'Percentage' words).</a:t>
+              <a:t>• Scores formatted inconsistently (mix of '9.2 CGPA', '82.0 Percentage', and raw numbers), breaking comparisons.</a:t>
             </a:r>
           </a:p>
           <a:p>
@@ -3347,7 +3346,7 @@
               </a:defRPr>
             </a:pPr>
             <a:r>
-              <a:t>• Disorganized candidate metadata lacking clean age/gender tracking.</a:t>
+              <a:t>• Crucial age and contact fields missing, outdated, or hard to read.</a:t>
             </a:r>
           </a:p>
         </p:txBody>
@@ -3377,13 +3376,13 @@
             <a:pPr>
               <a:defRPr sz="1400" b="1">
                 <a:solidFill>
-                  <a:srgbClr val="22C55E"/>
-                </a:solidFill>
-                <a:latin typeface="Arial"/>
-              </a:defRPr>
-            </a:pPr>
-            <a:r>
-              <a:t>THE PORTAL SOLUTION</a:t>
+                  <a:srgbClr val="64748B"/>
+                </a:solidFill>
+                <a:latin typeface="Arial"/>
+              </a:defRPr>
+            </a:pPr>
+            <a:r>
+              <a:t>OPERATIONAL IMPACT</a:t>
             </a:r>
           </a:p>
           <a:p>
@@ -3402,7 +3401,7 @@
               </a:defRPr>
             </a:pPr>
             <a:r>
-              <a:t>Normalized Multi-Row System</a:t>
+              <a:t>Hiring Delays &amp; Loss of Talent</a:t>
             </a:r>
           </a:p>
           <a:p>
@@ -3418,7 +3417,7 @@
               </a:defRPr>
             </a:pPr>
             <a:r>
-              <a:t>• Structured multi-row candidate blocks in Excel: multiple degrees/jobs are written as clean vertical rows mapped to one candidate.</a:t>
+              <a:t>• Hiring managers waste hours manually separating rows to review candidate academic histories.</a:t>
             </a:r>
           </a:p>
           <a:p>
@@ -3434,7 +3433,7 @@
               </a:defRPr>
             </a:pPr>
             <a:r>
-              <a:t>• Clean boundary text clipping via wrap_text control to prevent text from overflowing to adjacent empty columns.</a:t>
+              <a:t>• Critical candidates are missed because their Ph.D. or publication details are buried inside long text blocks.</a:t>
             </a:r>
           </a:p>
           <a:p>
@@ -3450,7 +3449,7 @@
               </a:defRPr>
             </a:pPr>
             <a:r>
-              <a:t>• Universal score normalizer: Bachelor/Master/PhD scores print as '79%' or '8.2 CGPA', with integer rounding. Schooling displays raw numbers.</a:t>
+              <a:t>• Difficulty in summarizing applicant metrics for senior leadership.</a:t>
             </a:r>
           </a:p>
           <a:p>
@@ -3466,7 +3465,7 @@
               </a:defRPr>
             </a:pPr>
             <a:r>
-              <a:t>• Full candidates analytics dashboard with fast filters.</a:t>
+              <a:t>• Prone to manual errors during data copy-paste cycles.</a:t>
             </a:r>
           </a:p>
         </p:txBody>
@@ -3528,7 +3527,7 @@
               </a:defRPr>
             </a:pPr>
             <a:r>
-              <a:t>Candidate Experience: Standardized Intake</a:t>
+              <a:t>Candidate Experience: Clean Intake Channels</a:t>
             </a:r>
           </a:p>
         </p:txBody>
@@ -3567,7 +3566,7 @@
               </a:defRPr>
             </a:pPr>
             <a:r>
-              <a:t>The applicant-facing interface ensures all inputs are structured at the point of ingestion.</a:t>
+              <a:t>The system starts with a structured candidate-facing application experience.</a:t>
             </a:r>
           </a:p>
           <a:p>
@@ -3583,7 +3582,7 @@
               </a:defRPr>
             </a:pPr>
             <a:r>
-              <a:t>Job Listings Portal: </a:t>
+              <a:t>Structured Job Board: </a:t>
             </a:r>
             <a:r>
               <a:rPr sz="1500" b="0">
@@ -3592,7 +3591,7 @@
                 </a:solidFill>
                 <a:latin typeface="Arial"/>
               </a:rPr>
-              <a:t>Candidates view open job vacancies with transparent information regarding divisions (e.g. DAKSHIN), descriptions, deadlines, and tracking states.</a:t>
+              <a:t>Applicants view open vacancies, filter by divisions, check submission deadlines, and follow application progress.</a:t>
             </a:r>
           </a:p>
           <a:p>
@@ -3608,7 +3607,7 @@
               </a:defRPr>
             </a:pPr>
             <a:r>
-              <a:t>Dynamic Academic Forms: </a:t>
+              <a:t>Multi-Degree Academic Fields: </a:t>
             </a:r>
             <a:r>
               <a:rPr sz="1500" b="0">
@@ -3617,7 +3616,7 @@
                 </a:solidFill>
                 <a:latin typeface="Arial"/>
               </a:rPr>
-              <a:t>Supports flexible education levels (Undergraduate, Postgraduate, Doctorate/PhD). Prompts for specific fields like Degree Name/Thesis Title, University, Passing Year, Score Type, and Score Value.</a:t>
+              <a:t>Allows candidate to input multiple educational levels (Undergraduate, Postgraduate, PhD/Doctorate) with uniform structure (University, Degree name/Thesis, Scores, and Passing Year).</a:t>
             </a:r>
           </a:p>
           <a:p>
@@ -3633,7 +3632,7 @@
               </a:defRPr>
             </a:pPr>
             <a:r>
-              <a:t>Comprehensive Work &amp; Publications Form: </a:t>
+              <a:t>Work &amp; Publications Tracking: </a:t>
             </a:r>
             <a:r>
               <a:rPr sz="1500" b="0">
@@ -3642,7 +3641,7 @@
                 </a:solidFill>
                 <a:latin typeface="Arial"/>
               </a:rPr>
-              <a:t>Applicants list professional tenures (Company, Role, Start, End Dates) and research contributions (Publications, Book Chapters, Papers, Google Scholar links).</a:t>
+              <a:t>Dedicated entries for professional work histories and academic contributions (Publications, Book chapters, Research papers).</a:t>
             </a:r>
           </a:p>
           <a:p>
@@ -3658,7 +3657,7 @@
               </a:defRPr>
             </a:pPr>
             <a:r>
-              <a:t>Validation at Ingestion: </a:t>
+              <a:t>Validation at Point of Entry: </a:t>
             </a:r>
             <a:r>
               <a:rPr sz="1500" b="0">
@@ -3667,7 +3666,7 @@
                 </a:solidFill>
                 <a:latin typeface="Arial"/>
               </a:rPr>
-              <a:t>Eliminates parsing errors by validating scoring formats and enforcing relational integrity on the frontend before submitting to PostgreSQL.</a:t>
+              <a:t>Forces consistent score type selection (CGPA vs. Percentage) and prevents typing errors before submission.</a:t>
             </a:r>
           </a:p>
         </p:txBody>
@@ -3729,7 +3728,7 @@
               </a:defRPr>
             </a:pPr>
             <a:r>
-              <a:t>HR Operations &amp; Specialized Filtering</a:t>
+              <a:t>HR Operations &amp; Smarter Filtering</a:t>
             </a:r>
           </a:p>
         </p:txBody>
@@ -3743,7 +3742,7 @@
         <p:spPr>
           <a:xfrm>
             <a:off x="731520" y="1645920"/>
-            <a:ext cx="5120640" cy="4389120"/>
+            <a:ext cx="10698480" cy="4389120"/>
           </a:xfrm>
           <a:prstGeom prst="rect">
             <a:avLst/>
@@ -3758,9 +3757,25 @@
           <a:p>
             <a:pPr>
               <a:spcAft>
-                <a:spcPts val="1500"/>
+                <a:spcPts val="2000"/>
               </a:spcAft>
-              <a:defRPr sz="1400" b="1">
+              <a:defRPr sz="1800">
+                <a:solidFill>
+                  <a:srgbClr val="64748B"/>
+                </a:solidFill>
+                <a:latin typeface="Arial"/>
+              </a:defRPr>
+            </a:pPr>
+            <a:r>
+              <a:t>Streamlining HR decision-making with direct operational intelligence.</a:t>
+            </a:r>
+          </a:p>
+          <a:p>
+            <a:pPr>
+              <a:spcBef>
+                <a:spcPts val="1200"/>
+              </a:spcBef>
+              <a:defRPr sz="1600" b="1">
                 <a:solidFill>
                   <a:srgbClr val="4F46E5"/>
                 </a:solidFill>
@@ -3768,196 +3783,91 @@
               </a:defRPr>
             </a:pPr>
             <a:r>
-              <a:t>HR DASHBOARD CAPABILITIES</a:t>
-            </a:r>
-          </a:p>
-          <a:p>
-            <a:pPr>
-              <a:spcAft>
+              <a:t>Job Posting Lifecycle: </a:t>
+            </a:r>
+            <a:r>
+              <a:rPr sz="1500" b="0">
+                <a:solidFill>
+                  <a:srgbClr val="1E293B"/>
+                </a:solidFill>
+                <a:latin typeface="Arial"/>
+              </a:rPr>
+              <a:t>Easily create, edit, close, or soft-delete job postings. System automatically closes applications when deadlines are reached.</a:t>
+            </a:r>
+          </a:p>
+          <a:p>
+            <a:pPr>
+              <a:spcBef>
                 <a:spcPts val="1200"/>
-              </a:spcAft>
-              <a:defRPr sz="1500" b="1">
-                <a:solidFill>
-                  <a:srgbClr val="0F172A"/>
-                </a:solidFill>
-                <a:latin typeface="Arial"/>
-              </a:defRPr>
-            </a:pPr>
-            <a:r>
-              <a:t>• Job Posting Management: </a:t>
-            </a:r>
-            <a:r>
-              <a:rPr sz="1400" b="0">
+              </a:spcBef>
+              <a:defRPr sz="1600" b="1">
+                <a:solidFill>
+                  <a:srgbClr val="4F46E5"/>
+                </a:solidFill>
+                <a:latin typeface="Arial"/>
+              </a:defRPr>
+            </a:pPr>
+            <a:r>
+              <a:t>Instant Specialized Filtering: </a:t>
+            </a:r>
+            <a:r>
+              <a:rPr sz="1500" b="0">
                 <a:solidFill>
                   <a:srgbClr val="1E293B"/>
                 </a:solidFill>
                 <a:latin typeface="Arial"/>
               </a:rPr>
-              <a:t>HR administrators can dynamically create, edit, close, or delete job postings with auto-closing dates.</a:t>
-            </a:r>
-          </a:p>
-          <a:p>
-            <a:pPr>
-              <a:spcAft>
+              <a:t>Filter applicants dynamically. Find candidates based on specific criteria (e.g. only Ph.D. degrees, minimum 2 years experience, specific universities, or publication topics) instantly.</a:t>
+            </a:r>
+          </a:p>
+          <a:p>
+            <a:pPr>
+              <a:spcBef>
                 <a:spcPts val="1200"/>
-              </a:spcAft>
-              <a:defRPr sz="1500" b="1">
-                <a:solidFill>
-                  <a:srgbClr val="0F172A"/>
-                </a:solidFill>
-                <a:latin typeface="Arial"/>
-              </a:defRPr>
-            </a:pPr>
-            <a:r>
-              <a:t>• Candidate Analytics View: </a:t>
-            </a:r>
-            <a:r>
-              <a:rPr sz="1400" b="0">
+              </a:spcBef>
+              <a:defRPr sz="1600" b="1">
+                <a:solidFill>
+                  <a:srgbClr val="4F46E5"/>
+                </a:solidFill>
+                <a:latin typeface="Arial"/>
+              </a:defRPr>
+            </a:pPr>
+            <a:r>
+              <a:t>Applicant Demographics &amp; Summary: </a:t>
+            </a:r>
+            <a:r>
+              <a:rPr sz="1500" b="0">
                 <a:solidFill>
                   <a:srgbClr val="1E293B"/>
                 </a:solidFill>
                 <a:latin typeface="Arial"/>
               </a:rPr>
-              <a:t>Displays applicant counts, average experience, gender distributions, and qualifications on a per-job basis.</a:t>
-            </a:r>
-          </a:p>
-          <a:p>
-            <a:pPr>
-              <a:spcAft>
+              <a:t>HR gets real-time metrics showing total applicants, average experience levels, and gender distribution.</a:t>
+            </a:r>
+          </a:p>
+          <a:p>
+            <a:pPr>
+              <a:spcBef>
                 <a:spcPts val="1200"/>
-              </a:spcAft>
-              <a:defRPr sz="1500" b="1">
-                <a:solidFill>
-                  <a:srgbClr val="0F172A"/>
-                </a:solidFill>
-                <a:latin typeface="Arial"/>
-              </a:defRPr>
-            </a:pPr>
-            <a:r>
-              <a:t>• Specialized Filters: </a:t>
-            </a:r>
-            <a:r>
-              <a:rPr sz="1400" b="0">
+              </a:spcBef>
+              <a:defRPr sz="1600" b="1">
+                <a:solidFill>
+                  <a:srgbClr val="4F46E5"/>
+                </a:solidFill>
+                <a:latin typeface="Arial"/>
+              </a:defRPr>
+            </a:pPr>
+            <a:r>
+              <a:t>Operational Sub-Row Indicators: </a:t>
+            </a:r>
+            <a:r>
+              <a:rPr sz="1500" b="0">
                 <a:solidFill>
                   <a:srgbClr val="1E293B"/>
                 </a:solidFill>
                 <a:latin typeface="Arial"/>
               </a:rPr>
-              <a:t>Enables real-time filtering of applicant rosters based on highest degree levels, experience ranges, specific universities, and publication keywords.</a:t>
-            </a:r>
-          </a:p>
-        </p:txBody>
-      </p:sp>
-      <p:sp>
-        <p:nvSpPr>
-          <p:cNvPr id="4" name="TextBox 3"/>
-          <p:cNvSpPr txBox="1"/>
-          <p:nvPr/>
-        </p:nvSpPr>
-        <p:spPr>
-          <a:xfrm>
-            <a:off x="6217920" y="1645920"/>
-            <a:ext cx="5120640" cy="4389120"/>
-          </a:xfrm>
-          <a:prstGeom prst="rect">
-            <a:avLst/>
-          </a:prstGeom>
-          <a:noFill/>
-        </p:spPr>
-        <p:txBody>
-          <a:bodyPr wrap="square">
-            <a:spAutoFit/>
-          </a:bodyPr>
-          <a:lstStyle/>
-          <a:p>
-            <a:pPr>
-              <a:spcAft>
-                <a:spcPts val="1500"/>
-              </a:spcAft>
-              <a:defRPr sz="1400" b="1">
-                <a:solidFill>
-                  <a:srgbClr val="4F46E5"/>
-                </a:solidFill>
-                <a:latin typeface="Arial"/>
-              </a:defRPr>
-            </a:pPr>
-            <a:r>
-              <a:t>OPERATIONAL METADATA</a:t>
-            </a:r>
-          </a:p>
-          <a:p>
-            <a:pPr>
-              <a:spcAft>
-                <a:spcPts val="1200"/>
-              </a:spcAft>
-              <a:defRPr sz="1500" b="1">
-                <a:solidFill>
-                  <a:srgbClr val="0F172A"/>
-                </a:solidFill>
-                <a:latin typeface="Arial"/>
-              </a:defRPr>
-            </a:pPr>
-            <a:r>
-              <a:t>• Metadata Sub-row: </a:t>
-            </a:r>
-            <a:r>
-              <a:rPr sz="1400" b="0">
-                <a:solidFill>
-                  <a:srgbClr val="1E293B"/>
-                </a:solidFill>
-                <a:latin typeface="Arial"/>
-              </a:rPr>
-              <a:t>Under the applicant's name, the system displays essential descriptors like 'Male • 31 Yrs • Delhi' dynamically.</a:t>
-            </a:r>
-          </a:p>
-          <a:p>
-            <a:pPr>
-              <a:spcAft>
-                <a:spcPts val="1200"/>
-              </a:spcAft>
-              <a:defRPr sz="1500" b="1">
-                <a:solidFill>
-                  <a:srgbClr val="0F172A"/>
-                </a:solidFill>
-                <a:latin typeface="Arial"/>
-              </a:defRPr>
-            </a:pPr>
-            <a:r>
-              <a:t>• Dynamic Age Calculation: </a:t>
-            </a:r>
-            <a:r>
-              <a:rPr sz="1400" b="0">
-                <a:solidFill>
-                  <a:srgbClr val="1E293B"/>
-                </a:solidFill>
-                <a:latin typeface="Arial"/>
-              </a:rPr>
-              <a:t>Computed on the backend based on the date of birth (DOB) relative to the current local time, avoiding static outdated entries.</a:t>
-            </a:r>
-          </a:p>
-          <a:p>
-            <a:pPr>
-              <a:spcAft>
-                <a:spcPts val="1200"/>
-              </a:spcAft>
-              <a:defRPr sz="1500" b="1">
-                <a:solidFill>
-                  <a:srgbClr val="0F172A"/>
-                </a:solidFill>
-                <a:latin typeface="Arial"/>
-              </a:defRPr>
-            </a:pPr>
-            <a:r>
-              <a:t>• Graceful Loading Separators: </a:t>
-            </a:r>
-            <a:r>
-              <a:rPr sz="1400" b="0">
-                <a:solidFill>
-                  <a:srgbClr val="1E293B"/>
-                </a:solidFill>
-                <a:latin typeface="Arial"/>
-              </a:rPr>
-              <a:t>Eliminates template rendering bugs (e.g. displaying raw bullet points when fields are null on load) by using conditional template strings.</a:t>
+              <a:t>Roster cards display key metadata like 'Male • 31 Yrs • Delhi' directly on initial load using fast backend age calculation.</a:t>
             </a:r>
           </a:p>
         </p:txBody>
@@ -4019,7 +3929,7 @@
               </a:defRPr>
             </a:pPr>
             <a:r>
-              <a:t>HR Portal: Candidate Dossier View</a:t>
+              <a:t>HR Portal: Candidate Dossier Modal</a:t>
             </a:r>
           </a:p>
         </p:txBody>
@@ -4058,7 +3968,7 @@
               </a:defRPr>
             </a:pPr>
             <a:r>
-              <a:t>Modular Candidate Dossier</a:t>
+              <a:t>At-a-Glance Professional Profiles</a:t>
             </a:r>
           </a:p>
           <a:p>
@@ -4074,7 +3984,7 @@
               </a:defRPr>
             </a:pPr>
             <a:r>
-              <a:t>• A centralized candidate dossier popup modal accessible instantly from the applicant roster.</a:t>
+              <a:t>• Single-click popup dossier: HR reviews applicant details without leaving the tracking list.</a:t>
             </a:r>
           </a:p>
           <a:p>
@@ -4090,7 +4000,7 @@
               </a:defRPr>
             </a:pPr>
             <a:r>
-              <a:t>• Displays contact channels (Email, Mobile) and location metadata at a glance.</a:t>
+              <a:t>• Displays calculated operational age and candidate contact info.</a:t>
             </a:r>
           </a:p>
           <a:p>
@@ -4106,7 +4016,7 @@
               </a:defRPr>
             </a:pPr>
             <a:r>
-              <a:t>• Sections are dynamically mapped for Academic Profiles (Undergrad, Postgrad, PhD) and Work &amp; Publications.</a:t>
+              <a:t>• Segments data into distinct, readable cards for Higher Education levels, Publications, and Work Experience.</a:t>
             </a:r>
           </a:p>
           <a:p>
@@ -4122,7 +4032,7 @@
               </a:defRPr>
             </a:pPr>
             <a:r>
-              <a:t>• Links out to external resources (LinkedIn profiles, Google Scholar profiles) and handles direct CV preview and downloads.</a:t>
+              <a:t>• Includes links to LinkedIn, Google Scholar, and direct CV download/preview.</a:t>
             </a:r>
           </a:p>
         </p:txBody>
@@ -4208,7 +4118,7 @@
               </a:defRPr>
             </a:pPr>
             <a:r>
-              <a:t>Optimized Excel Exporting (No Delimiter Clumping)</a:t>
+              <a:t>Optimized Excel Roster Exports</a:t>
             </a:r>
           </a:p>
         </p:txBody>
@@ -4247,7 +4157,7 @@
               </a:defRPr>
             </a:pPr>
             <a:r>
-              <a:t>Grouped Roster Rows</a:t>
+              <a:t>Grouped Stacked Rows</a:t>
             </a:r>
           </a:p>
           <a:p>
@@ -4263,7 +4173,7 @@
               </a:defRPr>
             </a:pPr>
             <a:r>
-              <a:t>• Roster maps multiple qualifications and work histories into clean stacked rows under a single candidate.</a:t>
+              <a:t>• Solves delimited clumping: Multiple degrees, publications, or work experiences are written as stacked vertical rows mapped to one candidate.</a:t>
             </a:r>
           </a:p>
           <a:p>
@@ -4279,7 +4189,7 @@
               </a:defRPr>
             </a:pPr>
             <a:r>
-              <a:t>• Primary candidate details (Name, Contact, Total Experience) are merged vertically across these sub-rows, matching standard database relational logic.</a:t>
+              <a:t>• Candidate's primary identifiers (Name, Contact Info, Total Experience) are merged vertically for that applicant's row group.</a:t>
             </a:r>
           </a:p>
           <a:p>
@@ -4295,7 +4205,7 @@
               </a:defRPr>
             </a:pPr>
             <a:r>
-              <a:t>• Avoids clumping entries with commas or creating infinite duplicate columns.</a:t>
+              <a:t>• Maintains database structure in Excel without breaking automated filters.</a:t>
             </a:r>
           </a:p>
         </p:txBody>
@@ -4334,7 +4244,7 @@
               </a:defRPr>
             </a:pPr>
             <a:r>
-              <a:t>Layout &amp; Aesthetics</a:t>
+              <a:t>Visual Layout &amp; Borders</a:t>
             </a:r>
           </a:p>
           <a:p>
@@ -4350,7 +4260,7 @@
               </a:defRPr>
             </a:pPr>
             <a:r>
-              <a:t>• Horizontal Boundary Clipping: Uses 'wrap_text=True' combined with fixed row heights (26px for single-row candidate, 28px for headers) to clip overflow text at cell borders cleanly.</a:t>
+              <a:t>• Horizontal Boundary Clipping: Text wraps inside cell boundaries and cuts off cleanly instead of spilling over neighboring empty columns.</a:t>
             </a:r>
           </a:p>
           <a:p>
@@ -4366,7 +4276,7 @@
               </a:defRPr>
             </a:pPr>
             <a:r>
-              <a:t>• Medium blue vertical borders separate major spreadsheet segments (e.g., Graduation, PG, PhD, Publications, Work).</a:t>
+              <a:t>• Medium blue vertical borders separate major sections (e.g. Graduation, PG, PhD, Publications, Work).</a:t>
             </a:r>
           </a:p>
           <a:p>
@@ -4382,7 +4292,7 @@
               </a:defRPr>
             </a:pPr>
             <a:r>
-              <a:t>• Headers are set in high-contrast solid blue with white bold text.</a:t>
+              <a:t>• Row height optimization: Single-row applicants have row heights set to 26px, headers to 28px, maintaining vertical rhythm.</a:t>
             </a:r>
           </a:p>
         </p:txBody>
@@ -4421,7 +4331,7 @@
               </a:defRPr>
             </a:pPr>
             <a:r>
-              <a:t>Score Normalization</a:t>
+              <a:t>Clean Normalization</a:t>
             </a:r>
           </a:p>
           <a:p>
@@ -4437,7 +4347,7 @@
               </a:defRPr>
             </a:pPr>
             <a:r>
-              <a:t>• Higher education scores are dynamically formatted as percentages ('79%') or CGPA ('8.2 CGPA').</a:t>
+              <a:t>• Higher education scores automatically display as '79%' or '8.2 CGPA'.</a:t>
             </a:r>
           </a:p>
           <a:p>
@@ -4453,7 +4363,7 @@
               </a:defRPr>
             </a:pPr>
             <a:r>
-              <a:t>• Decimal '.0' is stripped for all integer-equivalent scores (renders clean '8 CGPA' and '79%').</a:t>
+              <a:t>• Integer-equivalent scores strip trailing '.0' (renders clean '8 CGPA' and '79%').</a:t>
             </a:r>
           </a:p>
           <a:p>
@@ -4469,7 +4379,7 @@
               </a:defRPr>
             </a:pPr>
             <a:r>
-              <a:t>• Class X &amp; Class XII columns display raw numbers (e.g. '97' or '80.5') with no suffix, and default to empty cells if missing.</a:t>
+              <a:t>• Class X &amp; XII scores output raw numbers (e.g. '97' or '80.5') with no suffix, matching standard metrics.</a:t>
             </a:r>
           </a:p>
           <a:p>
@@ -4485,7 +4395,7 @@
               </a:defRPr>
             </a:pPr>
             <a:r>
-              <a:t>• Candidate status column is fully removed from exports for confidentiality.</a:t>
+              <a:t>• Confidentiality: Candidacy status columns are excluded from final report sheets.</a:t>
             </a:r>
           </a:p>
         </p:txBody>
@@ -4499,207 +4409,6 @@
 </file>
 
 <file path=ppt/slides/slide7.xml><?xml version="1.0" encoding="utf-8"?>
-<p:sld xmlns:a="http://schemas.openxmlformats.org/drawingml/2006/main" xmlns:p="http://schemas.openxmlformats.org/presentationml/2006/main" xmlns:r="http://schemas.openxmlformats.org/officeDocument/2006/relationships">
-  <p:cSld>
-    <p:bg>
-      <p:bgPr>
-        <a:solidFill>
-          <a:srgbClr val="F8FAFC"/>
-        </a:solidFill>
-        <a:effectLst/>
-      </p:bgPr>
-    </p:bg>
-    <p:spTree>
-      <p:nvGrpSpPr>
-        <p:cNvPr id="1" name=""/>
-        <p:cNvGrpSpPr/>
-        <p:nvPr/>
-      </p:nvGrpSpPr>
-      <p:grpSpPr/>
-      <p:sp>
-        <p:nvSpPr>
-          <p:cNvPr id="2" name="TextBox 1"/>
-          <p:cNvSpPr txBox="1"/>
-          <p:nvPr/>
-        </p:nvSpPr>
-        <p:spPr>
-          <a:xfrm>
-            <a:off x="731520" y="457200"/>
-            <a:ext cx="10698480" cy="731520"/>
-          </a:xfrm>
-          <a:prstGeom prst="rect">
-            <a:avLst/>
-          </a:prstGeom>
-          <a:noFill/>
-        </p:spPr>
-        <p:txBody>
-          <a:bodyPr wrap="square" lIns="0" tIns="0">
-            <a:spAutoFit/>
-          </a:bodyPr>
-          <a:lstStyle/>
-          <a:p>
-            <a:pPr>
-              <a:defRPr sz="3600" b="1">
-                <a:solidFill>
-                  <a:srgbClr val="0F172A"/>
-                </a:solidFill>
-                <a:latin typeface="Arial"/>
-              </a:defRPr>
-            </a:pPr>
-            <a:r>
-              <a:t>Developer Workflow &amp; Seeding Automation</a:t>
-            </a:r>
-          </a:p>
-        </p:txBody>
-      </p:sp>
-      <p:sp>
-        <p:nvSpPr>
-          <p:cNvPr id="3" name="TextBox 2"/>
-          <p:cNvSpPr txBox="1"/>
-          <p:nvPr/>
-        </p:nvSpPr>
-        <p:spPr>
-          <a:xfrm>
-            <a:off x="731520" y="1645920"/>
-            <a:ext cx="10698480" cy="4389120"/>
-          </a:xfrm>
-          <a:prstGeom prst="rect">
-            <a:avLst/>
-          </a:prstGeom>
-          <a:noFill/>
-        </p:spPr>
-        <p:txBody>
-          <a:bodyPr wrap="square">
-            <a:spAutoFit/>
-          </a:bodyPr>
-          <a:lstStyle/>
-          <a:p>
-            <a:pPr>
-              <a:spcAft>
-                <a:spcPts val="2000"/>
-              </a:spcAft>
-              <a:defRPr sz="1800">
-                <a:solidFill>
-                  <a:srgbClr val="64748B"/>
-                </a:solidFill>
-                <a:latin typeface="Arial"/>
-              </a:defRPr>
-            </a:pPr>
-            <a:r>
-              <a:t>Automated scripting ensures database parity across Local and Vercel environments.</a:t>
-            </a:r>
-          </a:p>
-          <a:p>
-            <a:pPr>
-              <a:spcBef>
-                <a:spcPts val="1200"/>
-              </a:spcBef>
-              <a:defRPr sz="1600" b="1">
-                <a:solidFill>
-                  <a:srgbClr val="4F46E5"/>
-                </a:solidFill>
-                <a:latin typeface="Arial"/>
-              </a:defRPr>
-            </a:pPr>
-            <a:r>
-              <a:t>Automated Seeding Endpoints: </a:t>
-            </a:r>
-            <a:r>
-              <a:rPr sz="1500" b="0">
-                <a:solidFill>
-                  <a:srgbClr val="1E293B"/>
-                </a:solidFill>
-                <a:latin typeface="Arial"/>
-              </a:rPr>
-              <a:t>Created debug endpoint '/api/v1/debug/fix-dakshin-candidates' to clear and populate mock applicant pools cleanly. Randomizes schooling percentages and assigns correct gender based on names.</a:t>
-            </a:r>
-          </a:p>
-          <a:p>
-            <a:pPr>
-              <a:spcBef>
-                <a:spcPts val="1200"/>
-              </a:spcBef>
-              <a:defRPr sz="1600" b="1">
-                <a:solidFill>
-                  <a:srgbClr val="4F46E5"/>
-                </a:solidFill>
-                <a:latin typeface="Arial"/>
-              </a:defRPr>
-            </a:pPr>
-            <a:r>
-              <a:t>Trigger Scripts: </a:t>
-            </a:r>
-            <a:r>
-              <a:rPr sz="1500" b="0">
-                <a:solidFill>
-                  <a:srgbClr val="1E293B"/>
-                </a:solidFill>
-                <a:latin typeface="Arial"/>
-              </a:rPr>
-              <a:t>Python execution scripts (e.g. 'trigger_vercel_migration.py') are used locally to invoke endpoints on the remote production Vercel database.</a:t>
-            </a:r>
-          </a:p>
-          <a:p>
-            <a:pPr>
-              <a:spcBef>
-                <a:spcPts val="1200"/>
-              </a:spcBef>
-              <a:defRPr sz="1600" b="1">
-                <a:solidFill>
-                  <a:srgbClr val="4F46E5"/>
-                </a:solidFill>
-                <a:latin typeface="Arial"/>
-              </a:defRPr>
-            </a:pPr>
-            <a:r>
-              <a:t>Verification Checks: </a:t>
-            </a:r>
-            <a:r>
-              <a:rPr sz="1500" b="0">
-                <a:solidFill>
-                  <a:srgbClr val="1E293B"/>
-                </a:solidFill>
-                <a:latin typeface="Arial"/>
-              </a:rPr>
-              <a:t>Automated Excel validation scripts ('validate_excel.py') verify spreadsheet structures, border styles, and cell values programmatically after code updates.</a:t>
-            </a:r>
-          </a:p>
-          <a:p>
-            <a:pPr>
-              <a:spcBef>
-                <a:spcPts val="1200"/>
-              </a:spcBef>
-              <a:defRPr sz="1600" b="1">
-                <a:solidFill>
-                  <a:srgbClr val="4F46E5"/>
-                </a:solidFill>
-                <a:latin typeface="Arial"/>
-              </a:defRPr>
-            </a:pPr>
-            <a:r>
-              <a:t>CI/CD Deployment: </a:t>
-            </a:r>
-            <a:r>
-              <a:rPr sz="1500" b="0">
-                <a:solidFill>
-                  <a:srgbClr val="1E293B"/>
-                </a:solidFill>
-                <a:latin typeface="Arial"/>
-              </a:rPr>
-              <a:t>Committing changes triggers immediate build and deployment on Vercel, with automated backend hot-reloading.</a:t>
-            </a:r>
-          </a:p>
-        </p:txBody>
-      </p:sp>
-    </p:spTree>
-  </p:cSld>
-  <p:clrMapOvr>
-    <a:masterClrMapping/>
-  </p:clrMapOvr>
-</p:sld>
-</file>
-
-<file path=ppt/slides/slide8.xml><?xml version="1.0" encoding="utf-8"?>
 <p:sld xmlns:a="http://schemas.openxmlformats.org/drawingml/2006/main" xmlns:p="http://schemas.openxmlformats.org/presentationml/2006/main" xmlns:r="http://schemas.openxmlformats.org/officeDocument/2006/relationships">
   <p:cSld>
     <p:bg>
@@ -4748,7 +4457,7 @@
               </a:defRPr>
             </a:pPr>
             <a:r>
-              <a:t>Technical Architecture &amp; System Stack</a:t>
+              <a:t>Strategic Value Add &amp; Benefits</a:t>
             </a:r>
           </a:p>
         </p:txBody>
@@ -4788,7 +4497,7 @@
               </a:defRPr>
             </a:pPr>
             <a:r>
-              <a:t>Frontend Application: </a:t>
+              <a:t>Time Saved in Review: </a:t>
             </a:r>
             <a:r>
               <a:rPr sz="1500" b="0">
@@ -4797,7 +4506,7 @@
                 </a:solidFill>
                 <a:latin typeface="Arial"/>
               </a:rPr>
-              <a:t>Next.js / React, TailwindCSS, and Vanilla CSS. Implements responsive UI boards, conditional dossier dialogs, and fast filter states.</a:t>
+              <a:t>Hiring managers can scan and review candidate histories in a single, well-styled spreadsheet. No manual data alignment or formatting is required.</a:t>
             </a:r>
           </a:p>
           <a:p>
@@ -4813,7 +4522,7 @@
               </a:defRPr>
             </a:pPr>
             <a:r>
-              <a:t>Backend Services: </a:t>
+              <a:t>Elimination of Data Gaps: </a:t>
             </a:r>
             <a:r>
               <a:rPr sz="1500" b="0">
@@ -4822,7 +4531,7 @@
                 </a:solidFill>
                 <a:latin typeface="Arial"/>
               </a:rPr>
-              <a:t>FastAPI (Python-based framework) handling REST API requests, background job tasks, and metadata calculations.</a:t>
+              <a:t>Structured intake fields and background calculations ensure candidate information is complete, clean, and consistent from day one.</a:t>
             </a:r>
           </a:p>
           <a:p>
@@ -4838,7 +4547,7 @@
               </a:defRPr>
             </a:pPr>
             <a:r>
-              <a:t>Database Engine: </a:t>
+              <a:t>Enhanced Decision Support: </a:t>
             </a:r>
             <a:r>
               <a:rPr sz="1500" b="0">
@@ -4847,7 +4556,7 @@
                 </a:solidFill>
                 <a:latin typeface="Arial"/>
               </a:rPr>
-              <a:t>PostgreSQL database hosted securely on Vercel, mapped with SQLAlchemy ORM models (Candidates, Schooling, HigherEducation, Publications, Work).</a:t>
+              <a:t>Advanced filters allow instant shortlisting of candidates matching high-level requirements (e.g., finding all applicants with PhD qualifications and specific research experience).</a:t>
             </a:r>
           </a:p>
           <a:p>
@@ -4863,7 +4572,7 @@
               </a:defRPr>
             </a:pPr>
             <a:r>
-              <a:t>Spreadsheet Engines: </a:t>
+              <a:t>Ready-to-Present Formats: </a:t>
             </a:r>
             <a:r>
               <a:rPr sz="1500" b="0">
@@ -4872,7 +4581,7 @@
                 </a:solidFill>
                 <a:latin typeface="Arial"/>
               </a:rPr>
-              <a:t>Openpyxl library used on the backend to dynamically style, merge, format, and generate structured candidate rosters.</a:t>
+              <a:t>Reports are styled with proper dividers, clipped text, and formatted scores, making them ready to share with senior management and board members immediately.</a:t>
             </a:r>
           </a:p>
         </p:txBody>

</xml_diff>

<commit_message>
docs: integrate user screenshots into the recruitment portal presentation deck
</commit_message>
<xml_diff>
--- a/resources/HR_Portal_Presentation.pptx
+++ b/resources/HR_Portal_Presentation.pptx
@@ -12,6 +12,9 @@
     <p:sldId id="260" r:id="rId11"/>
     <p:sldId id="261" r:id="rId12"/>
     <p:sldId id="262" r:id="rId13"/>
+    <p:sldId id="263" r:id="rId14"/>
+    <p:sldId id="264" r:id="rId15"/>
+    <p:sldId id="265" r:id="rId16"/>
   </p:sldIdLst>
   <p:sldSz cx="12191695" cy="6858000" type="screen4x3"/>
   <p:notesSz cx="6858000" cy="9144000"/>
@@ -3133,7 +3136,7 @@
               </a:defRPr>
             </a:pPr>
             <a:r>
-              <a:t>Smart Recruitment Portal &amp; Roster Analytics</a:t>
+              <a:t>RIS Recruitment Portal &amp; Smart Roster</a:t>
             </a:r>
           </a:p>
           <a:p>
@@ -3149,7 +3152,7 @@
               </a:defRPr>
             </a:pPr>
             <a:r>
-              <a:t>Streamlining applicant tracking, structured data validation, and clean decision-ready reporting</a:t>
+              <a:t>Streamlining candidate experiences, structured job creations, and database-accurate exports</a:t>
             </a:r>
           </a:p>
           <a:p>
@@ -3165,7 +3168,193 @@
               </a:defRPr>
             </a:pPr>
             <a:r>
-              <a:t>Operational Overview Presentation  •  Solutions &amp; Business Benefits</a:t>
+              <a:t>Operational Overview &amp; Live Features Walkthrough</a:t>
+            </a:r>
+          </a:p>
+        </p:txBody>
+      </p:sp>
+    </p:spTree>
+  </p:cSld>
+  <p:clrMapOvr>
+    <a:masterClrMapping/>
+  </p:clrMapOvr>
+</p:sld>
+</file>
+
+<file path=ppt/slides/slide10.xml><?xml version="1.0" encoding="utf-8"?>
+<p:sld xmlns:a="http://schemas.openxmlformats.org/drawingml/2006/main" xmlns:p="http://schemas.openxmlformats.org/presentationml/2006/main" xmlns:r="http://schemas.openxmlformats.org/officeDocument/2006/relationships">
+  <p:cSld>
+    <p:bg>
+      <p:bgPr>
+        <a:solidFill>
+          <a:srgbClr val="0F172A"/>
+        </a:solidFill>
+        <a:effectLst/>
+      </p:bgPr>
+    </p:bg>
+    <p:spTree>
+      <p:nvGrpSpPr>
+        <p:cNvPr id="1" name=""/>
+        <p:cNvGrpSpPr/>
+        <p:nvPr/>
+      </p:nvGrpSpPr>
+      <p:grpSpPr/>
+      <p:sp>
+        <p:nvSpPr>
+          <p:cNvPr id="2" name="TextBox 1"/>
+          <p:cNvSpPr txBox="1"/>
+          <p:nvPr/>
+        </p:nvSpPr>
+        <p:spPr>
+          <a:xfrm>
+            <a:off x="731520" y="457200"/>
+            <a:ext cx="10698480" cy="731520"/>
+          </a:xfrm>
+          <a:prstGeom prst="rect">
+            <a:avLst/>
+          </a:prstGeom>
+          <a:noFill/>
+        </p:spPr>
+        <p:txBody>
+          <a:bodyPr wrap="square" lIns="0" tIns="0">
+            <a:spAutoFit/>
+          </a:bodyPr>
+          <a:lstStyle/>
+          <a:p>
+            <a:pPr>
+              <a:defRPr sz="3200" b="1">
+                <a:solidFill>
+                  <a:srgbClr val="FFFFFF"/>
+                </a:solidFill>
+                <a:latin typeface="Arial"/>
+              </a:defRPr>
+            </a:pPr>
+            <a:r>
+              <a:t>Smart Recruitment Portal: Key Takeaways</a:t>
+            </a:r>
+          </a:p>
+        </p:txBody>
+      </p:sp>
+      <p:sp>
+        <p:nvSpPr>
+          <p:cNvPr id="3" name="TextBox 2"/>
+          <p:cNvSpPr txBox="1"/>
+          <p:nvPr/>
+        </p:nvSpPr>
+        <p:spPr>
+          <a:xfrm>
+            <a:off x="731520" y="1645920"/>
+            <a:ext cx="10698480" cy="4389120"/>
+          </a:xfrm>
+          <a:prstGeom prst="rect">
+            <a:avLst/>
+          </a:prstGeom>
+          <a:noFill/>
+        </p:spPr>
+        <p:txBody>
+          <a:bodyPr wrap="square">
+            <a:spAutoFit/>
+          </a:bodyPr>
+          <a:lstStyle/>
+          <a:p/>
+          <a:p>
+            <a:pPr>
+              <a:spcBef>
+                <a:spcPts val="1800"/>
+              </a:spcBef>
+              <a:defRPr sz="1600" b="1">
+                <a:solidFill>
+                  <a:srgbClr val="C2CDDB"/>
+                </a:solidFill>
+                <a:latin typeface="Arial"/>
+              </a:defRPr>
+            </a:pPr>
+            <a:r>
+              <a:t>Time Saved in Review: </a:t>
+            </a:r>
+            <a:r>
+              <a:rPr sz="1500" b="0">
+                <a:solidFill>
+                  <a:srgbClr val="E2E8F0"/>
+                </a:solidFill>
+                <a:latin typeface="Arial"/>
+              </a:rPr>
+              <a:t>HR and hiring managers scan, filter, and review candidates directly from the portal, eliminating manual CV tracking files.</a:t>
+            </a:r>
+          </a:p>
+          <a:p>
+            <a:pPr>
+              <a:spcBef>
+                <a:spcPts val="1800"/>
+              </a:spcBef>
+              <a:defRPr sz="1600" b="1">
+                <a:solidFill>
+                  <a:srgbClr val="C2CDDB"/>
+                </a:solidFill>
+                <a:latin typeface="Arial"/>
+              </a:defRPr>
+            </a:pPr>
+            <a:r>
+              <a:t>Elimination of Data Gaps: </a:t>
+            </a:r>
+            <a:r>
+              <a:rPr sz="1500" b="0">
+                <a:solidFill>
+                  <a:srgbClr val="E2E8F0"/>
+                </a:solidFill>
+                <a:latin typeface="Arial"/>
+              </a:rPr>
+              <a:t>Structured inputs and form validations ensure candidate information is complete, clean, and database-aligned on submission.</a:t>
+            </a:r>
+          </a:p>
+          <a:p>
+            <a:pPr>
+              <a:spcBef>
+                <a:spcPts val="1800"/>
+              </a:spcBef>
+              <a:defRPr sz="1600" b="1">
+                <a:solidFill>
+                  <a:srgbClr val="C2CDDB"/>
+                </a:solidFill>
+                <a:latin typeface="Arial"/>
+              </a:defRPr>
+            </a:pPr>
+            <a:r>
+              <a:t>Advanced Roster Exports: </a:t>
+            </a:r>
+            <a:r>
+              <a:rPr sz="1500" b="0">
+                <a:solidFill>
+                  <a:srgbClr val="E2E8F0"/>
+                </a:solidFill>
+                <a:latin typeface="Arial"/>
+              </a:rPr>
+              <a:t>Generates presentation-ready spreadsheets with grouped stacked layouts, visual border dividers, and clean academic score normalization.</a:t>
+            </a:r>
+          </a:p>
+          <a:p>
+            <a:pPr>
+              <a:spcBef>
+                <a:spcPts val="1800"/>
+              </a:spcBef>
+              <a:defRPr sz="1600" b="1">
+                <a:solidFill>
+                  <a:srgbClr val="C2CDDB"/>
+                </a:solidFill>
+                <a:latin typeface="Arial"/>
+              </a:defRPr>
+            </a:pPr>
+            <a:r>
+              <a:t>Confidential &amp; Board Ready: </a:t>
+            </a:r>
+            <a:r>
+              <a:rPr sz="1500" b="0">
+                <a:solidFill>
+                  <a:srgbClr val="E2E8F0"/>
+                </a:solidFill>
+                <a:latin typeface="Arial"/>
+              </a:rPr>
+              <a:t>Roster filters, search functionality, and standardized exports are structured to be shared directly with senior board members and stakeholders.</a:t>
             </a:r>
           </a:p>
         </p:txBody>
@@ -3219,7 +3408,7 @@
           <a:lstStyle/>
           <a:p>
             <a:pPr>
-              <a:defRPr sz="3600" b="1">
+              <a:defRPr sz="3200" b="1">
                 <a:solidFill>
                   <a:srgbClr val="0F172A"/>
                 </a:solidFill>
@@ -3227,7 +3416,7 @@
               </a:defRPr>
             </a:pPr>
             <a:r>
-              <a:t>The Core Challenge: Spreadsheet Delimiter Bottleneck</a:t>
+              <a:t>The Operational Problem We Solved</a:t>
             </a:r>
           </a:p>
         </p:txBody>
@@ -3263,7 +3452,7 @@
               </a:defRPr>
             </a:pPr>
             <a:r>
-              <a:t>LEGACY PROCESS ISSUES</a:t>
+              <a:t>THE RECRUITMENT BOTTLENECK</a:t>
             </a:r>
           </a:p>
           <a:p>
@@ -3282,7 +3471,7 @@
               </a:defRPr>
             </a:pPr>
             <a:r>
-              <a:t>Messy Data &amp; Broken Layouts</a:t>
+              <a:t>Messy Data &amp; Loss of Focus</a:t>
             </a:r>
           </a:p>
           <a:p>
@@ -3298,7 +3487,7 @@
               </a:defRPr>
             </a:pPr>
             <a:r>
-              <a:t>• Multiple qualifications/jobs clumped into single cells with commas or semicolons, making search and sorting impossible.</a:t>
+              <a:t>• Qualifications, publications, and works clumped into single cells with commas, breaking searchability.</a:t>
             </a:r>
           </a:p>
           <a:p>
@@ -3314,7 +3503,7 @@
               </a:defRPr>
             </a:pPr>
             <a:r>
-              <a:t>• Spreadsheets stretching infinitely to the right with redundant blank columns, causing 'horizontal scrolling fatigue'.</a:t>
+              <a:t>• Spreadsheets stretching infinitely to the right with empty column chains (UG1, UG2, Work1, Work2), making rosters unreadable.</a:t>
             </a:r>
           </a:p>
           <a:p>
@@ -3330,7 +3519,7 @@
               </a:defRPr>
             </a:pPr>
             <a:r>
-              <a:t>• Scores formatted inconsistently (mix of '9.2 CGPA', '82.0 Percentage', and raw numbers), breaking comparisons.</a:t>
+              <a:t>• Scores formatted inconsistently (mix of '9.0 CGPA', '79.0 Percentage', and default 0.0 entries).</a:t>
             </a:r>
           </a:p>
           <a:p>
@@ -3346,7 +3535,7 @@
               </a:defRPr>
             </a:pPr>
             <a:r>
-              <a:t>• Crucial age and contact fields missing, outdated, or hard to read.</a:t>
+              <a:t>• Manual resume downloading and copy-pasting causing hiring delays.</a:t>
             </a:r>
           </a:p>
         </p:txBody>
@@ -3376,13 +3565,13 @@
             <a:pPr>
               <a:defRPr sz="1400" b="1">
                 <a:solidFill>
-                  <a:srgbClr val="64748B"/>
+                  <a:srgbClr val="22C55E"/>
                 </a:solidFill>
                 <a:latin typeface="Arial"/>
               </a:defRPr>
             </a:pPr>
             <a:r>
-              <a:t>OPERATIONAL IMPACT</a:t>
+              <a:t>THE INTEGRATED PORTAL APPROACH</a:t>
             </a:r>
           </a:p>
           <a:p>
@@ -3401,7 +3590,7 @@
               </a:defRPr>
             </a:pPr>
             <a:r>
-              <a:t>Hiring Delays &amp; Loss of Talent</a:t>
+              <a:t>Clean Intake to Clean Output</a:t>
             </a:r>
           </a:p>
           <a:p>
@@ -3417,7 +3606,7 @@
               </a:defRPr>
             </a:pPr>
             <a:r>
-              <a:t>• Hiring managers waste hours manually separating rows to review candidate academic histories.</a:t>
+              <a:t>• Structured Application Intake: Candidates input individual degrees, scores, and timelines dynamically.</a:t>
             </a:r>
           </a:p>
           <a:p>
@@ -3433,7 +3622,7 @@
               </a:defRPr>
             </a:pPr>
             <a:r>
-              <a:t>• Critical candidates are missed because their Ph.D. or publication details are buried inside long text blocks.</a:t>
+              <a:t>• Operational HR Dashboards: Instantly review applicant lists, apply filters, and access dossier profile sheets.</a:t>
             </a:r>
           </a:p>
           <a:p>
@@ -3449,7 +3638,7 @@
               </a:defRPr>
             </a:pPr>
             <a:r>
-              <a:t>• Difficulty in summarizing applicant metrics for senior leadership.</a:t>
+              <a:t>• Grouped Stacked Excel Roster: Candidate qualifications are stacked vertically with merged basic details.</a:t>
             </a:r>
           </a:p>
           <a:p>
@@ -3465,7 +3654,7 @@
               </a:defRPr>
             </a:pPr>
             <a:r>
-              <a:t>• Prone to manual errors during data copy-paste cycles.</a:t>
+              <a:t>• Strict score normalization (clean '%' and 'CGPA' suffixes, stripping trailing decimals).</a:t>
             </a:r>
           </a:p>
         </p:txBody>
@@ -3519,7 +3708,7 @@
           <a:lstStyle/>
           <a:p>
             <a:pPr>
-              <a:defRPr sz="3600" b="1">
+              <a:defRPr sz="3200" b="1">
                 <a:solidFill>
                   <a:srgbClr val="0F172A"/>
                 </a:solidFill>
@@ -3527,7 +3716,7 @@
               </a:defRPr>
             </a:pPr>
             <a:r>
-              <a:t>Candidate Experience: Clean Intake Channels</a:t>
+              <a:t>Candidate Interface: Open Positions Board</a:t>
             </a:r>
           </a:p>
         </p:txBody>
@@ -3540,8 +3729,8 @@
         </p:nvSpPr>
         <p:spPr>
           <a:xfrm>
-            <a:off x="731520" y="1645920"/>
-            <a:ext cx="10698480" cy="4389120"/>
+            <a:off x="731520" y="1463040"/>
+            <a:ext cx="4754880" cy="4572000"/>
           </a:xfrm>
           <a:prstGeom prst="rect">
             <a:avLst/>
@@ -3549,128 +3738,136 @@
           <a:noFill/>
         </p:spPr>
         <p:txBody>
-          <a:bodyPr wrap="square">
+          <a:bodyPr wrap="square" lIns="0" tIns="0">
             <a:spAutoFit/>
           </a:bodyPr>
           <a:lstStyle/>
           <a:p>
             <a:pPr>
               <a:spcAft>
-                <a:spcPts val="2000"/>
+                <a:spcPts val="1200"/>
               </a:spcAft>
-              <a:defRPr sz="1800">
-                <a:solidFill>
-                  <a:srgbClr val="64748B"/>
+              <a:defRPr b="1" sz="1400">
+                <a:solidFill>
+                  <a:srgbClr val="0F172A"/>
                 </a:solidFill>
                 <a:latin typeface="Arial"/>
               </a:defRPr>
             </a:pPr>
             <a:r>
-              <a:t>The system starts with a structured candidate-facing application experience.</a:t>
+              <a:t>• Explore Opportunities: </a:t>
+            </a:r>
+            <a:r>
+              <a:rPr b="0" sz="1300">
+                <a:solidFill>
+                  <a:srgbClr val="1E293B"/>
+                </a:solidFill>
+                <a:latin typeface="Arial"/>
+              </a:rPr>
+              <a:t>Candidates land on a clean, modern interface listing open vacancies at RIS.</a:t>
             </a:r>
           </a:p>
           <a:p>
             <a:pPr>
-              <a:spcBef>
+              <a:spcAft>
                 <a:spcPts val="1200"/>
-              </a:spcBef>
-              <a:defRPr sz="1600" b="1">
-                <a:solidFill>
-                  <a:srgbClr val="4F46E5"/>
+              </a:spcAft>
+              <a:defRPr b="1" sz="1400">
+                <a:solidFill>
+                  <a:srgbClr val="0F172A"/>
                 </a:solidFill>
                 <a:latin typeface="Arial"/>
               </a:defRPr>
             </a:pPr>
             <a:r>
-              <a:t>Structured Job Board: </a:t>
-            </a:r>
-            <a:r>
-              <a:rPr sz="1500" b="0">
+              <a:t>• Transparent Metadata: </a:t>
+            </a:r>
+            <a:r>
+              <a:rPr b="0" sz="1300">
                 <a:solidFill>
                   <a:srgbClr val="1E293B"/>
                 </a:solidFill>
                 <a:latin typeface="Arial"/>
               </a:rPr>
-              <a:t>Applicants view open vacancies, filter by divisions, check submission deadlines, and follow application progress.</a:t>
+              <a:t>Each job card displays division tags (e.g., CMEC, RIS), location (New Delhi, India), and clear application deadlines.</a:t>
             </a:r>
           </a:p>
           <a:p>
             <a:pPr>
-              <a:spcBef>
+              <a:spcAft>
                 <a:spcPts val="1200"/>
-              </a:spcBef>
-              <a:defRPr sz="1600" b="1">
-                <a:solidFill>
-                  <a:srgbClr val="4F46E5"/>
+              </a:spcAft>
+              <a:defRPr b="1" sz="1400">
+                <a:solidFill>
+                  <a:srgbClr val="0F172A"/>
                 </a:solidFill>
                 <a:latin typeface="Arial"/>
               </a:defRPr>
             </a:pPr>
             <a:r>
-              <a:t>Multi-Degree Academic Fields: </a:t>
-            </a:r>
-            <a:r>
-              <a:rPr sz="1500" b="0">
+              <a:t>• Job-Specific Information: </a:t>
+            </a:r>
+            <a:r>
+              <a:rPr b="0" sz="1300">
                 <a:solidFill>
                   <a:srgbClr val="1E293B"/>
                 </a:solidFill>
                 <a:latin typeface="Arial"/>
               </a:rPr>
-              <a:t>Allows candidate to input multiple educational levels (Undergraduate, Postgraduate, PhD/Doctorate) with uniform structure (University, Degree name/Thesis, Scores, and Passing Year).</a:t>
+              <a:t>Provides short public descriptions to inform prospective applicants prior to starting an application.</a:t>
             </a:r>
           </a:p>
           <a:p>
             <a:pPr>
-              <a:spcBef>
+              <a:spcAft>
                 <a:spcPts val="1200"/>
-              </a:spcBef>
-              <a:defRPr sz="1600" b="1">
-                <a:solidFill>
-                  <a:srgbClr val="4F46E5"/>
+              </a:spcAft>
+              <a:defRPr b="1" sz="1400">
+                <a:solidFill>
+                  <a:srgbClr val="0F172A"/>
                 </a:solidFill>
                 <a:latin typeface="Arial"/>
               </a:defRPr>
             </a:pPr>
             <a:r>
-              <a:t>Work &amp; Publications Tracking: </a:t>
-            </a:r>
-            <a:r>
-              <a:rPr sz="1500" b="0">
+              <a:t>• Frictionless Flow: </a:t>
+            </a:r>
+            <a:r>
+              <a:rPr b="0" sz="1300">
                 <a:solidFill>
                   <a:srgbClr val="1E293B"/>
                 </a:solidFill>
                 <a:latin typeface="Arial"/>
               </a:rPr>
-              <a:t>Dedicated entries for professional work histories and academic contributions (Publications, Book chapters, Research papers).</a:t>
-            </a:r>
-          </a:p>
-          <a:p>
-            <a:pPr>
-              <a:spcBef>
-                <a:spcPts val="1200"/>
-              </a:spcBef>
-              <a:defRPr sz="1600" b="1">
-                <a:solidFill>
-                  <a:srgbClr val="4F46E5"/>
-                </a:solidFill>
-                <a:latin typeface="Arial"/>
-              </a:defRPr>
-            </a:pPr>
-            <a:r>
-              <a:t>Validation at Point of Entry: </a:t>
-            </a:r>
-            <a:r>
-              <a:rPr sz="1500" b="0">
-                <a:solidFill>
-                  <a:srgbClr val="1E293B"/>
-                </a:solidFill>
-                <a:latin typeface="Arial"/>
-              </a:rPr>
-              <a:t>Forces consistent score type selection (CGPA vs. Percentage) and prevents typing errors before submission.</a:t>
-            </a:r>
-          </a:p>
-        </p:txBody>
-      </p:sp>
+              <a:t>A direct 'Apply Now' flow redirects candidates to a structured multiphase application form.</a:t>
+            </a:r>
+          </a:p>
+        </p:txBody>
+      </p:sp>
+      <p:pic>
+        <p:nvPicPr>
+          <p:cNvPr id="4" name="Picture 3" descr="media__1779989599270.png"/>
+          <p:cNvPicPr>
+            <a:picLocks noChangeAspect="1"/>
+          </p:cNvPicPr>
+          <p:nvPr/>
+        </p:nvPicPr>
+        <p:blipFill>
+          <a:blip r:embed="rId2"/>
+          <a:stretch>
+            <a:fillRect/>
+          </a:stretch>
+        </p:blipFill>
+        <p:spPr>
+          <a:xfrm>
+            <a:off x="5760720" y="1463040"/>
+            <a:ext cx="5669280" cy="4389120"/>
+          </a:xfrm>
+          <a:prstGeom prst="rect">
+            <a:avLst/>
+          </a:prstGeom>
+        </p:spPr>
+      </p:pic>
     </p:spTree>
   </p:cSld>
   <p:clrMapOvr>
@@ -3720,7 +3917,7 @@
           <a:lstStyle/>
           <a:p>
             <a:pPr>
-              <a:defRPr sz="3600" b="1">
+              <a:defRPr sz="3200" b="1">
                 <a:solidFill>
                   <a:srgbClr val="0F172A"/>
                 </a:solidFill>
@@ -3728,7 +3925,7 @@
               </a:defRPr>
             </a:pPr>
             <a:r>
-              <a:t>HR Operations &amp; Smarter Filtering</a:t>
+              <a:t>HR Dashboard: Central Vacancy Control</a:t>
             </a:r>
           </a:p>
         </p:txBody>
@@ -3741,8 +3938,8 @@
         </p:nvSpPr>
         <p:spPr>
           <a:xfrm>
-            <a:off x="731520" y="1645920"/>
-            <a:ext cx="10698480" cy="4389120"/>
+            <a:off x="731520" y="1463040"/>
+            <a:ext cx="4754880" cy="4572000"/>
           </a:xfrm>
           <a:prstGeom prst="rect">
             <a:avLst/>
@@ -3750,128 +3947,136 @@
           <a:noFill/>
         </p:spPr>
         <p:txBody>
-          <a:bodyPr wrap="square">
+          <a:bodyPr wrap="square" lIns="0" tIns="0">
             <a:spAutoFit/>
           </a:bodyPr>
           <a:lstStyle/>
           <a:p>
             <a:pPr>
               <a:spcAft>
-                <a:spcPts val="2000"/>
+                <a:spcPts val="1200"/>
               </a:spcAft>
-              <a:defRPr sz="1800">
-                <a:solidFill>
-                  <a:srgbClr val="64748B"/>
+              <a:defRPr b="1" sz="1400">
+                <a:solidFill>
+                  <a:srgbClr val="0F172A"/>
                 </a:solidFill>
                 <a:latin typeface="Arial"/>
               </a:defRPr>
             </a:pPr>
             <a:r>
-              <a:t>Streamlining HR decision-making with direct operational intelligence.</a:t>
+              <a:t>• Administrative Overview: </a:t>
+            </a:r>
+            <a:r>
+              <a:rPr b="0" sz="1300">
+                <a:solidFill>
+                  <a:srgbClr val="1E293B"/>
+                </a:solidFill>
+                <a:latin typeface="Arial"/>
+              </a:rPr>
+              <a:t>HR administrators get a comprehensive birds-eye view of all hiring activities.</a:t>
             </a:r>
           </a:p>
           <a:p>
             <a:pPr>
-              <a:spcBef>
+              <a:spcAft>
                 <a:spcPts val="1200"/>
-              </a:spcBef>
-              <a:defRPr sz="1600" b="1">
-                <a:solidFill>
-                  <a:srgbClr val="4F46E5"/>
+              </a:spcAft>
+              <a:defRPr b="1" sz="1400">
+                <a:solidFill>
+                  <a:srgbClr val="0F172A"/>
                 </a:solidFill>
                 <a:latin typeface="Arial"/>
               </a:defRPr>
             </a:pPr>
             <a:r>
-              <a:t>Job Posting Lifecycle: </a:t>
-            </a:r>
-            <a:r>
-              <a:rPr sz="1500" b="0">
+              <a:t>• Status Counters: </a:t>
+            </a:r>
+            <a:r>
+              <a:rPr b="0" sz="1300">
                 <a:solidFill>
                   <a:srgbClr val="1E293B"/>
                 </a:solidFill>
                 <a:latin typeface="Arial"/>
               </a:rPr>
-              <a:t>Easily create, edit, close, or soft-delete job postings. System automatically closes applications when deadlines are reached.</a:t>
+              <a:t>Top statistics cards summarize Open Positions, Total Applicants (this year), and listings Closing Soon.</a:t>
             </a:r>
           </a:p>
           <a:p>
             <a:pPr>
-              <a:spcBef>
+              <a:spcAft>
                 <a:spcPts val="1200"/>
-              </a:spcBef>
-              <a:defRPr sz="1600" b="1">
-                <a:solidFill>
-                  <a:srgbClr val="4F46E5"/>
+              </a:spcAft>
+              <a:defRPr b="1" sz="1400">
+                <a:solidFill>
+                  <a:srgbClr val="0F172A"/>
                 </a:solidFill>
                 <a:latin typeface="Arial"/>
               </a:defRPr>
             </a:pPr>
             <a:r>
-              <a:t>Instant Specialized Filtering: </a:t>
-            </a:r>
-            <a:r>
-              <a:rPr sz="1500" b="0">
+              <a:t>• Job Postings List: </a:t>
+            </a:r>
+            <a:r>
+              <a:rPr b="0" sz="1300">
                 <a:solidFill>
                   <a:srgbClr val="1E293B"/>
                 </a:solidFill>
                 <a:latin typeface="Arial"/>
               </a:rPr>
-              <a:t>Filter applicants dynamically. Find candidates based on specific criteria (e.g. only Ph.D. degrees, minimum 2 years experience, specific universities, or publication topics) instantly.</a:t>
+              <a:t>A central list displays role titles, divisions, applicant counts, posting dates, deadlines, and statuses (Open/Draft/Closed).</a:t>
             </a:r>
           </a:p>
           <a:p>
             <a:pPr>
-              <a:spcBef>
+              <a:spcAft>
                 <a:spcPts val="1200"/>
-              </a:spcBef>
-              <a:defRPr sz="1600" b="1">
-                <a:solidFill>
-                  <a:srgbClr val="4F46E5"/>
+              </a:spcAft>
+              <a:defRPr b="1" sz="1400">
+                <a:solidFill>
+                  <a:srgbClr val="0F172A"/>
                 </a:solidFill>
                 <a:latin typeface="Arial"/>
               </a:defRPr>
             </a:pPr>
             <a:r>
-              <a:t>Applicant Demographics &amp; Summary: </a:t>
-            </a:r>
-            <a:r>
-              <a:rPr sz="1500" b="0">
+              <a:t>• Actions Panel: </a:t>
+            </a:r>
+            <a:r>
+              <a:rPr b="0" sz="1300">
                 <a:solidFill>
                   <a:srgbClr val="1E293B"/>
                 </a:solidFill>
                 <a:latin typeface="Arial"/>
               </a:rPr>
-              <a:t>HR gets real-time metrics showing total applicants, average experience levels, and gender distribution.</a:t>
-            </a:r>
-          </a:p>
-          <a:p>
-            <a:pPr>
-              <a:spcBef>
-                <a:spcPts val="1200"/>
-              </a:spcBef>
-              <a:defRPr sz="1600" b="1">
-                <a:solidFill>
-                  <a:srgbClr val="4F46E5"/>
-                </a:solidFill>
-                <a:latin typeface="Arial"/>
-              </a:defRPr>
-            </a:pPr>
-            <a:r>
-              <a:t>Operational Sub-Row Indicators: </a:t>
-            </a:r>
-            <a:r>
-              <a:rPr sz="1500" b="0">
-                <a:solidFill>
-                  <a:srgbClr val="1E293B"/>
-                </a:solidFill>
-                <a:latin typeface="Arial"/>
-              </a:rPr>
-              <a:t>Roster cards display key metadata like 'Male • 31 Yrs • Delhi' directly on initial load using fast backend age calculation.</a:t>
-            </a:r>
-          </a:p>
-        </p:txBody>
-      </p:sp>
+              <a:t>Quick access buttons to view applicants, edit job details, or archive postings.</a:t>
+            </a:r>
+          </a:p>
+        </p:txBody>
+      </p:sp>
+      <p:pic>
+        <p:nvPicPr>
+          <p:cNvPr id="4" name="Picture 3" descr="media__1779989675165.png"/>
+          <p:cNvPicPr>
+            <a:picLocks noChangeAspect="1"/>
+          </p:cNvPicPr>
+          <p:nvPr/>
+        </p:nvPicPr>
+        <p:blipFill>
+          <a:blip r:embed="rId2"/>
+          <a:stretch>
+            <a:fillRect/>
+          </a:stretch>
+        </p:blipFill>
+        <p:spPr>
+          <a:xfrm>
+            <a:off x="5760720" y="1463040"/>
+            <a:ext cx="5669280" cy="4389120"/>
+          </a:xfrm>
+          <a:prstGeom prst="rect">
+            <a:avLst/>
+          </a:prstGeom>
+        </p:spPr>
+      </p:pic>
     </p:spTree>
   </p:cSld>
   <p:clrMapOvr>
@@ -3921,7 +4126,7 @@
           <a:lstStyle/>
           <a:p>
             <a:pPr>
-              <a:defRPr sz="3600" b="1">
+              <a:defRPr sz="3200" b="1">
                 <a:solidFill>
                   <a:srgbClr val="0F172A"/>
                 </a:solidFill>
@@ -3929,7 +4134,7 @@
               </a:defRPr>
             </a:pPr>
             <a:r>
-              <a:t>HR Portal: Candidate Dossier Modal</a:t>
+              <a:t>HR Operations: Streamlined Job Creation</a:t>
             </a:r>
           </a:p>
         </p:txBody>
@@ -3942,8 +4147,8 @@
         </p:nvSpPr>
         <p:spPr>
           <a:xfrm>
-            <a:off x="731520" y="1645920"/>
-            <a:ext cx="4572000" cy="4389120"/>
+            <a:off x="731520" y="1463040"/>
+            <a:ext cx="4754880" cy="4572000"/>
           </a:xfrm>
           <a:prstGeom prst="rect">
             <a:avLst/>
@@ -3951,16 +4156,16 @@
           <a:noFill/>
         </p:spPr>
         <p:txBody>
-          <a:bodyPr wrap="square">
+          <a:bodyPr wrap="square" lIns="0" tIns="0">
             <a:spAutoFit/>
           </a:bodyPr>
           <a:lstStyle/>
           <a:p>
             <a:pPr>
               <a:spcAft>
-                <a:spcPts val="1500"/>
+                <a:spcPts val="1200"/>
               </a:spcAft>
-              <a:defRPr sz="2400" b="1">
+              <a:defRPr b="1" sz="1400">
                 <a:solidFill>
                   <a:srgbClr val="0F172A"/>
                 </a:solidFill>
@@ -3968,78 +4173,98 @@
               </a:defRPr>
             </a:pPr>
             <a:r>
-              <a:t>At-a-Glance Professional Profiles</a:t>
+              <a:t>• Simplified Input Layout: </a:t>
+            </a:r>
+            <a:r>
+              <a:rPr b="0" sz="1300">
+                <a:solidFill>
+                  <a:srgbClr val="1E293B"/>
+                </a:solidFill>
+                <a:latin typeface="Arial"/>
+              </a:rPr>
+              <a:t>Create job cards are cleaned up by removing redundant description notes and AI requirements fields.</a:t>
             </a:r>
           </a:p>
           <a:p>
             <a:pPr>
               <a:spcAft>
-                <a:spcPts val="1000"/>
+                <a:spcPts val="1200"/>
               </a:spcAft>
-              <a:defRPr sz="1400">
+              <a:defRPr b="1" sz="1400">
+                <a:solidFill>
+                  <a:srgbClr val="0F172A"/>
+                </a:solidFill>
+                <a:latin typeface="Arial"/>
+              </a:defRPr>
+            </a:pPr>
+            <a:r>
+              <a:t>• Contract &amp; Compensation Settings: </a:t>
+            </a:r>
+            <a:r>
+              <a:rPr b="0" sz="1300">
                 <a:solidFill>
                   <a:srgbClr val="1E293B"/>
                 </a:solidFill>
                 <a:latin typeface="Arial"/>
-              </a:defRPr>
-            </a:pPr>
-            <a:r>
-              <a:t>• Single-click popup dossier: HR reviews applicant details without leaving the tracking list.</a:t>
+              </a:rPr>
+              <a:t>Includes a dedicated configuration card at the bottom to define pay bands and contract constraints.</a:t>
             </a:r>
           </a:p>
           <a:p>
             <a:pPr>
               <a:spcAft>
-                <a:spcPts val="1000"/>
+                <a:spcPts val="1200"/>
               </a:spcAft>
-              <a:defRPr sz="1400">
+              <a:defRPr b="1" sz="1400">
+                <a:solidFill>
+                  <a:srgbClr val="0F172A"/>
+                </a:solidFill>
+                <a:latin typeface="Arial"/>
+              </a:defRPr>
+            </a:pPr>
+            <a:r>
+              <a:t>• Salary Bands: </a:t>
+            </a:r>
+            <a:r>
+              <a:rPr b="0" sz="1300">
                 <a:solidFill>
                   <a:srgbClr val="1E293B"/>
                 </a:solidFill>
                 <a:latin typeface="Arial"/>
-              </a:defRPr>
-            </a:pPr>
-            <a:r>
-              <a:t>• Displays calculated operational age and candidate contact info.</a:t>
+              </a:rPr>
+              <a:t>Set minimum and maximum pay ranges directly using dropdown options.</a:t>
             </a:r>
           </a:p>
           <a:p>
             <a:pPr>
               <a:spcAft>
-                <a:spcPts val="1000"/>
+                <a:spcPts val="1200"/>
               </a:spcAft>
-              <a:defRPr sz="1400">
+              <a:defRPr b="1" sz="1400">
+                <a:solidFill>
+                  <a:srgbClr val="0F172A"/>
+                </a:solidFill>
+                <a:latin typeface="Arial"/>
+              </a:defRPr>
+            </a:pPr>
+            <a:r>
+              <a:t>• Experience Boundaries: </a:t>
+            </a:r>
+            <a:r>
+              <a:rPr b="0" sz="1300">
                 <a:solidFill>
                   <a:srgbClr val="1E293B"/>
                 </a:solidFill>
                 <a:latin typeface="Arial"/>
-              </a:defRPr>
-            </a:pPr>
-            <a:r>
-              <a:t>• Segments data into distinct, readable cards for Higher Education levels, Publications, and Work Experience.</a:t>
-            </a:r>
-          </a:p>
-          <a:p>
-            <a:pPr>
-              <a:spcAft>
-                <a:spcPts val="1000"/>
-              </a:spcAft>
-              <a:defRPr sz="1400">
-                <a:solidFill>
-                  <a:srgbClr val="1E293B"/>
-                </a:solidFill>
-                <a:latin typeface="Arial"/>
-              </a:defRPr>
-            </a:pPr>
-            <a:r>
-              <a:t>• Includes links to LinkedIn, Google Scholar, and direct CV download/preview.</a:t>
+              </a:rPr>
+              <a:t>Specify minimum and maximum experience ranges required for applicants, and define contract years.</a:t>
             </a:r>
           </a:p>
         </p:txBody>
       </p:sp>
       <p:pic>
         <p:nvPicPr>
-          <p:cNvPr id="4" name="Picture 3" descr="media__1779953765396.png"/>
+          <p:cNvPr id="4" name="Picture 3" descr="media__1779989658124.png"/>
           <p:cNvPicPr>
             <a:picLocks noChangeAspect="1"/>
           </p:cNvPicPr>
@@ -4053,8 +4278,8 @@
         </p:blipFill>
         <p:spPr>
           <a:xfrm>
-            <a:off x="5486400" y="1645920"/>
-            <a:ext cx="5943600" cy="4389120"/>
+            <a:off x="5760720" y="1463040"/>
+            <a:ext cx="5669280" cy="4389120"/>
           </a:xfrm>
           <a:prstGeom prst="rect">
             <a:avLst/>
@@ -4110,7 +4335,7 @@
           <a:lstStyle/>
           <a:p>
             <a:pPr>
-              <a:defRPr sz="3600" b="1">
+              <a:defRPr sz="3200" b="1">
                 <a:solidFill>
                   <a:srgbClr val="0F172A"/>
                 </a:solidFill>
@@ -4118,7 +4343,7 @@
               </a:defRPr>
             </a:pPr>
             <a:r>
-              <a:t>Optimized Excel Roster Exports</a:t>
+              <a:t>HR Dashboard: General Talent Analytics</a:t>
             </a:r>
           </a:p>
         </p:txBody>
@@ -4131,8 +4356,8 @@
         </p:nvSpPr>
         <p:spPr>
           <a:xfrm>
-            <a:off x="731520" y="1645920"/>
-            <a:ext cx="3291840" cy="4389120"/>
+            <a:off x="731520" y="1463040"/>
+            <a:ext cx="4754880" cy="4572000"/>
           </a:xfrm>
           <a:prstGeom prst="rect">
             <a:avLst/>
@@ -4140,7 +4365,7 @@
           <a:noFill/>
         </p:spPr>
         <p:txBody>
-          <a:bodyPr wrap="square">
+          <a:bodyPr wrap="square" lIns="0" tIns="0">
             <a:spAutoFit/>
           </a:bodyPr>
           <a:lstStyle/>
@@ -4149,257 +4374,127 @@
               <a:spcAft>
                 <a:spcPts val="1200"/>
               </a:spcAft>
-              <a:defRPr sz="2000" b="1">
-                <a:solidFill>
-                  <a:srgbClr val="4F46E5"/>
+              <a:defRPr b="1" sz="1400">
+                <a:solidFill>
+                  <a:srgbClr val="0F172A"/>
                 </a:solidFill>
                 <a:latin typeface="Arial"/>
               </a:defRPr>
             </a:pPr>
             <a:r>
-              <a:t>Grouped Stacked Rows</a:t>
+              <a:t>• Visual Demographics: </a:t>
+            </a:r>
+            <a:r>
+              <a:rPr b="0" sz="1300">
+                <a:solidFill>
+                  <a:srgbClr val="1E293B"/>
+                </a:solidFill>
+                <a:latin typeface="Arial"/>
+              </a:rPr>
+              <a:t>Presents real-time candidate statistics across the entire system.</a:t>
             </a:r>
           </a:p>
           <a:p>
             <a:pPr>
               <a:spcAft>
-                <a:spcPts val="800"/>
+                <a:spcPts val="1200"/>
               </a:spcAft>
-              <a:defRPr sz="1400">
+              <a:defRPr b="1" sz="1400">
+                <a:solidFill>
+                  <a:srgbClr val="0F172A"/>
+                </a:solidFill>
+                <a:latin typeface="Arial"/>
+              </a:defRPr>
+            </a:pPr>
+            <a:r>
+              <a:t>• Gender Diversity: </a:t>
+            </a:r>
+            <a:r>
+              <a:rPr b="0" sz="1300">
                 <a:solidFill>
                   <a:srgbClr val="1E293B"/>
                 </a:solidFill>
                 <a:latin typeface="Arial"/>
-              </a:defRPr>
-            </a:pPr>
-            <a:r>
-              <a:t>• Solves delimited clumping: Multiple degrees, publications, or work experiences are written as stacked vertical rows mapped to one candidate.</a:t>
+              </a:rPr>
+              <a:t>A donut chart displays male/female distribution of the applicant pool.</a:t>
             </a:r>
           </a:p>
           <a:p>
             <a:pPr>
               <a:spcAft>
-                <a:spcPts val="800"/>
+                <a:spcPts val="1200"/>
               </a:spcAft>
-              <a:defRPr sz="1400">
+              <a:defRPr b="1" sz="1400">
+                <a:solidFill>
+                  <a:srgbClr val="0F172A"/>
+                </a:solidFill>
+                <a:latin typeface="Arial"/>
+              </a:defRPr>
+            </a:pPr>
+            <a:r>
+              <a:t>• Top Talent Hubs: </a:t>
+            </a:r>
+            <a:r>
+              <a:rPr b="0" sz="1300">
                 <a:solidFill>
                   <a:srgbClr val="1E293B"/>
                 </a:solidFill>
                 <a:latin typeface="Arial"/>
-              </a:defRPr>
-            </a:pPr>
-            <a:r>
-              <a:t>• Candidate's primary identifiers (Name, Contact Info, Total Experience) are merged vertically for that applicant's row group.</a:t>
+              </a:rPr>
+              <a:t>Bar charts show geographic distributions, showing which states candidates apply from most (e.g., Tamil Nadu, Delhi, Karnataka).</a:t>
             </a:r>
           </a:p>
           <a:p>
             <a:pPr>
               <a:spcAft>
-                <a:spcPts val="800"/>
+                <a:spcPts val="1200"/>
               </a:spcAft>
-              <a:defRPr sz="1400">
+              <a:defRPr b="1" sz="1400">
+                <a:solidFill>
+                  <a:srgbClr val="0F172A"/>
+                </a:solidFill>
+                <a:latin typeface="Arial"/>
+              </a:defRPr>
+            </a:pPr>
+            <a:r>
+              <a:t>• Pipeline Velocity: </a:t>
+            </a:r>
+            <a:r>
+              <a:rPr b="0" sz="1300">
                 <a:solidFill>
                   <a:srgbClr val="1E293B"/>
                 </a:solidFill>
                 <a:latin typeface="Arial"/>
-              </a:defRPr>
-            </a:pPr>
-            <a:r>
-              <a:t>• Maintains database structure in Excel without breaking automated filters.</a:t>
-            </a:r>
-          </a:p>
-        </p:txBody>
-      </p:sp>
-      <p:sp>
-        <p:nvSpPr>
-          <p:cNvPr id="4" name="TextBox 3"/>
-          <p:cNvSpPr txBox="1"/>
+              </a:rPr>
+              <a:t>A status bar tracks total talent counts alongside shortlisted, selected, and rejected applicants.</a:t>
+            </a:r>
+          </a:p>
+        </p:txBody>
+      </p:sp>
+      <p:pic>
+        <p:nvPicPr>
+          <p:cNvPr id="4" name="Picture 3" descr="media__1779989707679.png"/>
+          <p:cNvPicPr>
+            <a:picLocks noChangeAspect="1"/>
+          </p:cNvPicPr>
           <p:nvPr/>
-        </p:nvSpPr>
+        </p:nvPicPr>
+        <p:blipFill>
+          <a:blip r:embed="rId2"/>
+          <a:stretch>
+            <a:fillRect/>
+          </a:stretch>
+        </p:blipFill>
         <p:spPr>
           <a:xfrm>
-            <a:off x="4389120" y="1645920"/>
-            <a:ext cx="3291840" cy="4389120"/>
+            <a:off x="5760720" y="1463040"/>
+            <a:ext cx="5669280" cy="4389120"/>
           </a:xfrm>
           <a:prstGeom prst="rect">
             <a:avLst/>
           </a:prstGeom>
-          <a:noFill/>
         </p:spPr>
-        <p:txBody>
-          <a:bodyPr wrap="square">
-            <a:spAutoFit/>
-          </a:bodyPr>
-          <a:lstStyle/>
-          <a:p>
-            <a:pPr>
-              <a:spcAft>
-                <a:spcPts val="1200"/>
-              </a:spcAft>
-              <a:defRPr sz="2000" b="1">
-                <a:solidFill>
-                  <a:srgbClr val="4F46E5"/>
-                </a:solidFill>
-                <a:latin typeface="Arial"/>
-              </a:defRPr>
-            </a:pPr>
-            <a:r>
-              <a:t>Visual Layout &amp; Borders</a:t>
-            </a:r>
-          </a:p>
-          <a:p>
-            <a:pPr>
-              <a:spcAft>
-                <a:spcPts val="800"/>
-              </a:spcAft>
-              <a:defRPr sz="1400">
-                <a:solidFill>
-                  <a:srgbClr val="1E293B"/>
-                </a:solidFill>
-                <a:latin typeface="Arial"/>
-              </a:defRPr>
-            </a:pPr>
-            <a:r>
-              <a:t>• Horizontal Boundary Clipping: Text wraps inside cell boundaries and cuts off cleanly instead of spilling over neighboring empty columns.</a:t>
-            </a:r>
-          </a:p>
-          <a:p>
-            <a:pPr>
-              <a:spcAft>
-                <a:spcPts val="800"/>
-              </a:spcAft>
-              <a:defRPr sz="1400">
-                <a:solidFill>
-                  <a:srgbClr val="1E293B"/>
-                </a:solidFill>
-                <a:latin typeface="Arial"/>
-              </a:defRPr>
-            </a:pPr>
-            <a:r>
-              <a:t>• Medium blue vertical borders separate major sections (e.g. Graduation, PG, PhD, Publications, Work).</a:t>
-            </a:r>
-          </a:p>
-          <a:p>
-            <a:pPr>
-              <a:spcAft>
-                <a:spcPts val="800"/>
-              </a:spcAft>
-              <a:defRPr sz="1400">
-                <a:solidFill>
-                  <a:srgbClr val="1E293B"/>
-                </a:solidFill>
-                <a:latin typeface="Arial"/>
-              </a:defRPr>
-            </a:pPr>
-            <a:r>
-              <a:t>• Row height optimization: Single-row applicants have row heights set to 26px, headers to 28px, maintaining vertical rhythm.</a:t>
-            </a:r>
-          </a:p>
-        </p:txBody>
-      </p:sp>
-      <p:sp>
-        <p:nvSpPr>
-          <p:cNvPr id="5" name="TextBox 4"/>
-          <p:cNvSpPr txBox="1"/>
-          <p:nvPr/>
-        </p:nvSpPr>
-        <p:spPr>
-          <a:xfrm>
-            <a:off x="8046720" y="1645920"/>
-            <a:ext cx="3291840" cy="4389120"/>
-          </a:xfrm>
-          <a:prstGeom prst="rect">
-            <a:avLst/>
-          </a:prstGeom>
-          <a:noFill/>
-        </p:spPr>
-        <p:txBody>
-          <a:bodyPr wrap="square">
-            <a:spAutoFit/>
-          </a:bodyPr>
-          <a:lstStyle/>
-          <a:p>
-            <a:pPr>
-              <a:spcAft>
-                <a:spcPts val="1200"/>
-              </a:spcAft>
-              <a:defRPr sz="2000" b="1">
-                <a:solidFill>
-                  <a:srgbClr val="4F46E5"/>
-                </a:solidFill>
-                <a:latin typeface="Arial"/>
-              </a:defRPr>
-            </a:pPr>
-            <a:r>
-              <a:t>Clean Normalization</a:t>
-            </a:r>
-          </a:p>
-          <a:p>
-            <a:pPr>
-              <a:spcAft>
-                <a:spcPts val="800"/>
-              </a:spcAft>
-              <a:defRPr sz="1400">
-                <a:solidFill>
-                  <a:srgbClr val="1E293B"/>
-                </a:solidFill>
-                <a:latin typeface="Arial"/>
-              </a:defRPr>
-            </a:pPr>
-            <a:r>
-              <a:t>• Higher education scores automatically display as '79%' or '8.2 CGPA'.</a:t>
-            </a:r>
-          </a:p>
-          <a:p>
-            <a:pPr>
-              <a:spcAft>
-                <a:spcPts val="800"/>
-              </a:spcAft>
-              <a:defRPr sz="1400">
-                <a:solidFill>
-                  <a:srgbClr val="1E293B"/>
-                </a:solidFill>
-                <a:latin typeface="Arial"/>
-              </a:defRPr>
-            </a:pPr>
-            <a:r>
-              <a:t>• Integer-equivalent scores strip trailing '.0' (renders clean '8 CGPA' and '79%').</a:t>
-            </a:r>
-          </a:p>
-          <a:p>
-            <a:pPr>
-              <a:spcAft>
-                <a:spcPts val="800"/>
-              </a:spcAft>
-              <a:defRPr sz="1400">
-                <a:solidFill>
-                  <a:srgbClr val="1E293B"/>
-                </a:solidFill>
-                <a:latin typeface="Arial"/>
-              </a:defRPr>
-            </a:pPr>
-            <a:r>
-              <a:t>• Class X &amp; XII scores output raw numbers (e.g. '97' or '80.5') with no suffix, matching standard metrics.</a:t>
-            </a:r>
-          </a:p>
-          <a:p>
-            <a:pPr>
-              <a:spcAft>
-                <a:spcPts val="800"/>
-              </a:spcAft>
-              <a:defRPr sz="1400">
-                <a:solidFill>
-                  <a:srgbClr val="1E293B"/>
-                </a:solidFill>
-                <a:latin typeface="Arial"/>
-              </a:defRPr>
-            </a:pPr>
-            <a:r>
-              <a:t>• Confidentiality: Candidacy status columns are excluded from final report sheets.</a:t>
-            </a:r>
-          </a:p>
-        </p:txBody>
-      </p:sp>
+      </p:pic>
     </p:spTree>
   </p:cSld>
   <p:clrMapOvr>
@@ -4414,7 +4509,7 @@
     <p:bg>
       <p:bgPr>
         <a:solidFill>
-          <a:srgbClr val="0F172A"/>
+          <a:srgbClr val="F8FAFC"/>
         </a:solidFill>
         <a:effectLst/>
       </p:bgPr>
@@ -4449,15 +4544,15 @@
           <a:lstStyle/>
           <a:p>
             <a:pPr>
-              <a:defRPr sz="3600" b="1">
-                <a:solidFill>
-                  <a:srgbClr val="FFFFFF"/>
+              <a:defRPr sz="3200" b="1">
+                <a:solidFill>
+                  <a:srgbClr val="0F172A"/>
                 </a:solidFill>
                 <a:latin typeface="Arial"/>
               </a:defRPr>
             </a:pPr>
             <a:r>
-              <a:t>Strategic Value Add &amp; Benefits</a:t>
+              <a:t>Roster Analytics &amp; Specialized Filtering</a:t>
             </a:r>
           </a:p>
         </p:txBody>
@@ -4470,8 +4565,8 @@
         </p:nvSpPr>
         <p:spPr>
           <a:xfrm>
-            <a:off x="731520" y="1645920"/>
-            <a:ext cx="10698480" cy="4389120"/>
+            <a:off x="731520" y="1463040"/>
+            <a:ext cx="4754880" cy="4572000"/>
           </a:xfrm>
           <a:prstGeom prst="rect">
             <a:avLst/>
@@ -4479,113 +4574,527 @@
           <a:noFill/>
         </p:spPr>
         <p:txBody>
+          <a:bodyPr wrap="square" lIns="0" tIns="0">
+            <a:spAutoFit/>
+          </a:bodyPr>
+          <a:lstStyle/>
+          <a:p>
+            <a:pPr>
+              <a:spcAft>
+                <a:spcPts val="1200"/>
+              </a:spcAft>
+              <a:defRPr b="1" sz="1400">
+                <a:solidFill>
+                  <a:srgbClr val="0F172A"/>
+                </a:solidFill>
+                <a:latin typeface="Arial"/>
+              </a:defRPr>
+            </a:pPr>
+            <a:r>
+              <a:t>• Role-Specific Metrics: </a:t>
+            </a:r>
+            <a:r>
+              <a:rPr b="0" sz="1300">
+                <a:solidFill>
+                  <a:srgbClr val="1E293B"/>
+                </a:solidFill>
+                <a:latin typeface="Arial"/>
+              </a:rPr>
+              <a:t>Provides demographic, geographic, and highest degree distributions specifically for the active job listing.</a:t>
+            </a:r>
+          </a:p>
+          <a:p>
+            <a:pPr>
+              <a:spcAft>
+                <a:spcPts val="1200"/>
+              </a:spcAft>
+              <a:defRPr b="1" sz="1400">
+                <a:solidFill>
+                  <a:srgbClr val="0F172A"/>
+                </a:solidFill>
+                <a:latin typeface="Arial"/>
+              </a:defRPr>
+            </a:pPr>
+            <a:r>
+              <a:t>• Degree Seniority: </a:t>
+            </a:r>
+            <a:r>
+              <a:rPr b="0" sz="1300">
+                <a:solidFill>
+                  <a:srgbClr val="1E293B"/>
+                </a:solidFill>
+                <a:latin typeface="Arial"/>
+              </a:rPr>
+              <a:t>Instantly visualizes Ph.D., Masters, and Bachelors ratios in the applicant pool.</a:t>
+            </a:r>
+          </a:p>
+          <a:p>
+            <a:pPr>
+              <a:spcAft>
+                <a:spcPts val="1200"/>
+              </a:spcAft>
+              <a:defRPr b="1" sz="1400">
+                <a:solidFill>
+                  <a:srgbClr val="0F172A"/>
+                </a:solidFill>
+                <a:latin typeface="Arial"/>
+              </a:defRPr>
+            </a:pPr>
+            <a:r>
+              <a:t>• Candidate Filters: </a:t>
+            </a:r>
+            <a:r>
+              <a:rPr b="0" sz="1300">
+                <a:solidFill>
+                  <a:srgbClr val="1E293B"/>
+                </a:solidFill>
+                <a:latin typeface="Arial"/>
+              </a:rPr>
+              <a:t>Advanced search cards allow HR to filter candidates based on biographical details, early academics (Class X/XII), higher education degrees, work history, and publication fields.</a:t>
+            </a:r>
+          </a:p>
+          <a:p>
+            <a:pPr>
+              <a:spcAft>
+                <a:spcPts val="1200"/>
+              </a:spcAft>
+              <a:defRPr b="1" sz="1400">
+                <a:solidFill>
+                  <a:srgbClr val="0F172A"/>
+                </a:solidFill>
+                <a:latin typeface="Arial"/>
+              </a:defRPr>
+            </a:pPr>
+            <a:r>
+              <a:t>• Instant Shortlisting: </a:t>
+            </a:r>
+            <a:r>
+              <a:rPr b="0" sz="1300">
+                <a:solidFill>
+                  <a:srgbClr val="1E293B"/>
+                </a:solidFill>
+                <a:latin typeface="Arial"/>
+              </a:rPr>
+              <a:t>Enables HR to search through hundreds of profiles in seconds to find exact matches.</a:t>
+            </a:r>
+          </a:p>
+        </p:txBody>
+      </p:sp>
+      <p:pic>
+        <p:nvPicPr>
+          <p:cNvPr id="4" name="Picture 3" descr="media__1779989728466.png"/>
+          <p:cNvPicPr>
+            <a:picLocks noChangeAspect="1"/>
+          </p:cNvPicPr>
+          <p:nvPr/>
+        </p:nvPicPr>
+        <p:blipFill>
+          <a:blip r:embed="rId2"/>
+          <a:stretch>
+            <a:fillRect/>
+          </a:stretch>
+        </p:blipFill>
+        <p:spPr>
+          <a:xfrm>
+            <a:off x="5760720" y="1463040"/>
+            <a:ext cx="5669280" cy="4389120"/>
+          </a:xfrm>
+          <a:prstGeom prst="rect">
+            <a:avLst/>
+          </a:prstGeom>
+        </p:spPr>
+      </p:pic>
+    </p:spTree>
+  </p:cSld>
+  <p:clrMapOvr>
+    <a:masterClrMapping/>
+  </p:clrMapOvr>
+</p:sld>
+</file>
+
+<file path=ppt/slides/slide8.xml><?xml version="1.0" encoding="utf-8"?>
+<p:sld xmlns:a="http://schemas.openxmlformats.org/drawingml/2006/main" xmlns:p="http://schemas.openxmlformats.org/presentationml/2006/main" xmlns:r="http://schemas.openxmlformats.org/officeDocument/2006/relationships">
+  <p:cSld>
+    <p:bg>
+      <p:bgPr>
+        <a:solidFill>
+          <a:srgbClr val="F8FAFC"/>
+        </a:solidFill>
+        <a:effectLst/>
+      </p:bgPr>
+    </p:bg>
+    <p:spTree>
+      <p:nvGrpSpPr>
+        <p:cNvPr id="1" name=""/>
+        <p:cNvGrpSpPr/>
+        <p:nvPr/>
+      </p:nvGrpSpPr>
+      <p:grpSpPr/>
+      <p:sp>
+        <p:nvSpPr>
+          <p:cNvPr id="2" name="TextBox 1"/>
+          <p:cNvSpPr txBox="1"/>
+          <p:nvPr/>
+        </p:nvSpPr>
+        <p:spPr>
+          <a:xfrm>
+            <a:off x="731520" y="457200"/>
+            <a:ext cx="10698480" cy="731520"/>
+          </a:xfrm>
+          <a:prstGeom prst="rect">
+            <a:avLst/>
+          </a:prstGeom>
+          <a:noFill/>
+        </p:spPr>
+        <p:txBody>
+          <a:bodyPr wrap="square" lIns="0" tIns="0">
+            <a:spAutoFit/>
+          </a:bodyPr>
+          <a:lstStyle/>
+          <a:p>
+            <a:pPr>
+              <a:defRPr sz="3200" b="1">
+                <a:solidFill>
+                  <a:srgbClr val="0F172A"/>
+                </a:solidFill>
+                <a:latin typeface="Arial"/>
+              </a:defRPr>
+            </a:pPr>
+            <a:r>
+              <a:t>HR Portal: Candidate Dossier Modal</a:t>
+            </a:r>
+          </a:p>
+        </p:txBody>
+      </p:sp>
+      <p:sp>
+        <p:nvSpPr>
+          <p:cNvPr id="3" name="TextBox 2"/>
+          <p:cNvSpPr txBox="1"/>
+          <p:nvPr/>
+        </p:nvSpPr>
+        <p:spPr>
+          <a:xfrm>
+            <a:off x="731520" y="1371600"/>
+            <a:ext cx="10698480" cy="731520"/>
+          </a:xfrm>
+          <a:prstGeom prst="rect">
+            <a:avLst/>
+          </a:prstGeom>
+          <a:noFill/>
+        </p:spPr>
+        <p:txBody>
           <a:bodyPr wrap="square">
             <a:spAutoFit/>
           </a:bodyPr>
           <a:lstStyle/>
-          <a:p/>
           <a:p>
             <a:pPr>
-              <a:spcBef>
-                <a:spcPts val="1800"/>
-              </a:spcBef>
-              <a:defRPr sz="1600" b="1">
-                <a:solidFill>
-                  <a:srgbClr val="C2CDDB"/>
+              <a:defRPr sz="1500">
+                <a:solidFill>
+                  <a:srgbClr val="64748B"/>
                 </a:solidFill>
                 <a:latin typeface="Arial"/>
               </a:defRPr>
             </a:pPr>
             <a:r>
-              <a:t>Time Saved in Review: </a:t>
-            </a:r>
-            <a:r>
-              <a:rPr sz="1500" b="0">
-                <a:solidFill>
-                  <a:srgbClr val="E2E8F0"/>
+              <a:t>Modular Candidate Dossier popup showing top overview metrics (left) and scrolled detailed profile view (right).</a:t>
+            </a:r>
+          </a:p>
+        </p:txBody>
+      </p:sp>
+      <p:pic>
+        <p:nvPicPr>
+          <p:cNvPr id="4" name="Picture 3" descr="media__1779989857660.png"/>
+          <p:cNvPicPr>
+            <a:picLocks noChangeAspect="1"/>
+          </p:cNvPicPr>
+          <p:nvPr/>
+        </p:nvPicPr>
+        <p:blipFill>
+          <a:blip r:embed="rId2"/>
+          <a:stretch>
+            <a:fillRect/>
+          </a:stretch>
+        </p:blipFill>
+        <p:spPr>
+          <a:xfrm>
+            <a:off x="731520" y="2011680"/>
+            <a:ext cx="5120640" cy="3840480"/>
+          </a:xfrm>
+          <a:prstGeom prst="rect">
+            <a:avLst/>
+          </a:prstGeom>
+        </p:spPr>
+      </p:pic>
+      <p:pic>
+        <p:nvPicPr>
+          <p:cNvPr id="5" name="Picture 4" descr="media__1779989869625.png"/>
+          <p:cNvPicPr>
+            <a:picLocks noChangeAspect="1"/>
+          </p:cNvPicPr>
+          <p:nvPr/>
+        </p:nvPicPr>
+        <p:blipFill>
+          <a:blip r:embed="rId3"/>
+          <a:stretch>
+            <a:fillRect/>
+          </a:stretch>
+        </p:blipFill>
+        <p:spPr>
+          <a:xfrm>
+            <a:off x="6217920" y="2011680"/>
+            <a:ext cx="5120640" cy="3840480"/>
+          </a:xfrm>
+          <a:prstGeom prst="rect">
+            <a:avLst/>
+          </a:prstGeom>
+        </p:spPr>
+      </p:pic>
+      <p:sp>
+        <p:nvSpPr>
+          <p:cNvPr id="6" name="TextBox 5"/>
+          <p:cNvSpPr txBox="1"/>
+          <p:nvPr/>
+        </p:nvSpPr>
+        <p:spPr>
+          <a:xfrm>
+            <a:off x="731520" y="5943600"/>
+            <a:ext cx="10698480" cy="457200"/>
+          </a:xfrm>
+          <a:prstGeom prst="rect">
+            <a:avLst/>
+          </a:prstGeom>
+          <a:noFill/>
+        </p:spPr>
+        <p:txBody>
+          <a:bodyPr wrap="none">
+            <a:spAutoFit/>
+          </a:bodyPr>
+          <a:lstStyle/>
+          <a:p>
+            <a:pPr>
+              <a:defRPr sz="1300" b="1">
+                <a:solidFill>
+                  <a:srgbClr val="4F46E5"/>
+                </a:solidFill>
+                <a:latin typeface="Arial"/>
+              </a:defRPr>
+            </a:pPr>
+            <a:r>
+              <a:t>• Visual academic cards (Ph.D. in purple, Masters in blue)  • Dynamic rollups (UG: 8.6 | PG: 77% | XII: 91.3%)  • Blue 'OK' close button in footer</a:t>
+            </a:r>
+          </a:p>
+        </p:txBody>
+      </p:sp>
+    </p:spTree>
+  </p:cSld>
+  <p:clrMapOvr>
+    <a:masterClrMapping/>
+  </p:clrMapOvr>
+</p:sld>
+</file>
+
+<file path=ppt/slides/slide9.xml><?xml version="1.0" encoding="utf-8"?>
+<p:sld xmlns:a="http://schemas.openxmlformats.org/drawingml/2006/main" xmlns:p="http://schemas.openxmlformats.org/presentationml/2006/main" xmlns:r="http://schemas.openxmlformats.org/officeDocument/2006/relationships">
+  <p:cSld>
+    <p:bg>
+      <p:bgPr>
+        <a:solidFill>
+          <a:srgbClr val="F8FAFC"/>
+        </a:solidFill>
+        <a:effectLst/>
+      </p:bgPr>
+    </p:bg>
+    <p:spTree>
+      <p:nvGrpSpPr>
+        <p:cNvPr id="1" name=""/>
+        <p:cNvGrpSpPr/>
+        <p:nvPr/>
+      </p:nvGrpSpPr>
+      <p:grpSpPr/>
+      <p:sp>
+        <p:nvSpPr>
+          <p:cNvPr id="2" name="TextBox 1"/>
+          <p:cNvSpPr txBox="1"/>
+          <p:nvPr/>
+        </p:nvSpPr>
+        <p:spPr>
+          <a:xfrm>
+            <a:off x="731520" y="457200"/>
+            <a:ext cx="10698480" cy="731520"/>
+          </a:xfrm>
+          <a:prstGeom prst="rect">
+            <a:avLst/>
+          </a:prstGeom>
+          <a:noFill/>
+        </p:spPr>
+        <p:txBody>
+          <a:bodyPr wrap="square" lIns="0" tIns="0">
+            <a:spAutoFit/>
+          </a:bodyPr>
+          <a:lstStyle/>
+          <a:p>
+            <a:pPr>
+              <a:defRPr sz="3200" b="1">
+                <a:solidFill>
+                  <a:srgbClr val="0F172A"/>
+                </a:solidFill>
+                <a:latin typeface="Arial"/>
+              </a:defRPr>
+            </a:pPr>
+            <a:r>
+              <a:t>Roster Exports: Clean Reports Generation</a:t>
+            </a:r>
+          </a:p>
+        </p:txBody>
+      </p:sp>
+      <p:sp>
+        <p:nvSpPr>
+          <p:cNvPr id="3" name="TextBox 2"/>
+          <p:cNvSpPr txBox="1"/>
+          <p:nvPr/>
+        </p:nvSpPr>
+        <p:spPr>
+          <a:xfrm>
+            <a:off x="731520" y="1463040"/>
+            <a:ext cx="4754880" cy="4572000"/>
+          </a:xfrm>
+          <a:prstGeom prst="rect">
+            <a:avLst/>
+          </a:prstGeom>
+          <a:noFill/>
+        </p:spPr>
+        <p:txBody>
+          <a:bodyPr wrap="square" lIns="0" tIns="0">
+            <a:spAutoFit/>
+          </a:bodyPr>
+          <a:lstStyle/>
+          <a:p>
+            <a:pPr>
+              <a:spcAft>
+                <a:spcPts val="1200"/>
+              </a:spcAft>
+              <a:defRPr b="1" sz="1400">
+                <a:solidFill>
+                  <a:srgbClr val="0F172A"/>
+                </a:solidFill>
+                <a:latin typeface="Arial"/>
+              </a:defRPr>
+            </a:pPr>
+            <a:r>
+              <a:t>• Multiple Formats: </a:t>
+            </a:r>
+            <a:r>
+              <a:rPr b="0" sz="1300">
+                <a:solidFill>
+                  <a:srgbClr val="1E293B"/>
                 </a:solidFill>
                 <a:latin typeface="Arial"/>
               </a:rPr>
-              <a:t>Hiring managers can scan and review candidate histories in a single, well-styled spreadsheet. No manual data alignment or formatting is required.</a:t>
+              <a:t>Provides HR with flexible export formats depending on the target audience.</a:t>
             </a:r>
           </a:p>
           <a:p>
             <a:pPr>
-              <a:spcBef>
-                <a:spcPts val="1800"/>
-              </a:spcBef>
-              <a:defRPr sz="1600" b="1">
-                <a:solidFill>
-                  <a:srgbClr val="C2CDDB"/>
+              <a:spcAft>
+                <a:spcPts val="1200"/>
+              </a:spcAft>
+              <a:defRPr b="1" sz="1400">
+                <a:solidFill>
+                  <a:srgbClr val="0F172A"/>
                 </a:solidFill>
                 <a:latin typeface="Arial"/>
               </a:defRPr>
             </a:pPr>
             <a:r>
-              <a:t>Elimination of Data Gaps: </a:t>
-            </a:r>
-            <a:r>
-              <a:rPr sz="1500" b="0">
-                <a:solidFill>
-                  <a:srgbClr val="E2E8F0"/>
+              <a:t>• Detailed Excel (.xlsx): </a:t>
+            </a:r>
+            <a:r>
+              <a:rPr b="0" sz="1300">
+                <a:solidFill>
+                  <a:srgbClr val="1E293B"/>
                 </a:solidFill>
                 <a:latin typeface="Arial"/>
               </a:rPr>
-              <a:t>Structured intake fields and background calculations ensure candidate information is complete, clean, and consistent from day one.</a:t>
+              <a:t>Solves comma-clumping. Generates grouped stacked rows for candidates with multiple degrees, merging basic candidate details vertically.</a:t>
             </a:r>
           </a:p>
           <a:p>
             <a:pPr>
-              <a:spcBef>
-                <a:spcPts val="1800"/>
-              </a:spcBef>
-              <a:defRPr sz="1600" b="1">
-                <a:solidFill>
-                  <a:srgbClr val="C2CDDB"/>
+              <a:spcAft>
+                <a:spcPts val="1200"/>
+              </a:spcAft>
+              <a:defRPr b="1" sz="1400">
+                <a:solidFill>
+                  <a:srgbClr val="0F172A"/>
                 </a:solidFill>
                 <a:latin typeface="Arial"/>
               </a:defRPr>
             </a:pPr>
             <a:r>
-              <a:t>Enhanced Decision Support: </a:t>
-            </a:r>
-            <a:r>
-              <a:rPr sz="1500" b="0">
-                <a:solidFill>
-                  <a:srgbClr val="E2E8F0"/>
+              <a:t>• Standardized Summary (.xlsx): </a:t>
+            </a:r>
+            <a:r>
+              <a:rPr b="0" sz="1300">
+                <a:solidFill>
+                  <a:srgbClr val="1E293B"/>
                 </a:solidFill>
                 <a:latin typeface="Arial"/>
               </a:rPr>
-              <a:t>Advanced filters allow instant shortlisting of candidates matching high-level requirements (e.g., finding all applicants with PhD qualifications and specific research experience).</a:t>
+              <a:t>Provides a condensed one-candidate-per-row summary table containing formatted 'Degree (University)' combinations.</a:t>
             </a:r>
           </a:p>
           <a:p>
             <a:pPr>
-              <a:spcBef>
-                <a:spcPts val="1800"/>
-              </a:spcBef>
-              <a:defRPr sz="1600" b="1">
-                <a:solidFill>
-                  <a:srgbClr val="C2CDDB"/>
+              <a:spcAft>
+                <a:spcPts val="1200"/>
+              </a:spcAft>
+              <a:defRPr b="1" sz="1400">
+                <a:solidFill>
+                  <a:srgbClr val="0F172A"/>
                 </a:solidFill>
                 <a:latin typeface="Arial"/>
               </a:defRPr>
             </a:pPr>
             <a:r>
-              <a:t>Ready-to-Present Formats: </a:t>
-            </a:r>
-            <a:r>
-              <a:rPr sz="1500" b="0">
-                <a:solidFill>
-                  <a:srgbClr val="E2E8F0"/>
+              <a:t>• Clean Score Formatting: </a:t>
+            </a:r>
+            <a:r>
+              <a:rPr b="0" sz="1300">
+                <a:solidFill>
+                  <a:srgbClr val="1E293B"/>
                 </a:solidFill>
                 <a:latin typeface="Arial"/>
               </a:rPr>
-              <a:t>Reports are styled with proper dividers, clipped text, and formatted scores, making them ready to share with senior management and board members immediately.</a:t>
-            </a:r>
-          </a:p>
-        </p:txBody>
-      </p:sp>
+              <a:t>Universally formats scores as '79%' or '8.2 CGPA', removes trailing '.0' decimals for integers, and leaves X and XII as raw numbers.</a:t>
+            </a:r>
+          </a:p>
+        </p:txBody>
+      </p:sp>
+      <p:pic>
+        <p:nvPicPr>
+          <p:cNvPr id="4" name="Picture 3" descr="media__1779989923219.png"/>
+          <p:cNvPicPr>
+            <a:picLocks noChangeAspect="1"/>
+          </p:cNvPicPr>
+          <p:nvPr/>
+        </p:nvPicPr>
+        <p:blipFill>
+          <a:blip r:embed="rId2"/>
+          <a:stretch>
+            <a:fillRect/>
+          </a:stretch>
+        </p:blipFill>
+        <p:spPr>
+          <a:xfrm>
+            <a:off x="5760720" y="1463040"/>
+            <a:ext cx="5669280" cy="4389120"/>
+          </a:xfrm>
+          <a:prstGeom prst="rect">
+            <a:avLst/>
+          </a:prstGeom>
+        </p:spPr>
+      </p:pic>
     </p:spTree>
   </p:cSld>
   <p:clrMapOvr>

</xml_diff>

<commit_message>
docs: finalize presentation deck content to be crisp and executive-ready
</commit_message>
<xml_diff>
--- a/resources/HR_Portal_Presentation.pptx
+++ b/resources/HR_Portal_Presentation.pptx
@@ -3136,7 +3136,7 @@
               </a:defRPr>
             </a:pPr>
             <a:r>
-              <a:t>RIS Recruitment Portal &amp; Smart Roster</a:t>
+              <a:t>RIS Smart Recruitment &amp; Roster System</a:t>
             </a:r>
           </a:p>
           <a:p>
@@ -3152,7 +3152,7 @@
               </a:defRPr>
             </a:pPr>
             <a:r>
-              <a:t>Streamlining candidate experiences, structured job creations, and database-accurate exports</a:t>
+              <a:t>Standardizing candidate intake, operational vacancy control, and structured Excel reporting</a:t>
             </a:r>
           </a:p>
           <a:p>
@@ -3168,7 +3168,7 @@
               </a:defRPr>
             </a:pPr>
             <a:r>
-              <a:t>Operational Overview &amp; Live Features Walkthrough</a:t>
+              <a:t>Executive Briefing  •  Solutions &amp; System Walkthrough</a:t>
             </a:r>
           </a:p>
         </p:txBody>
@@ -3230,7 +3230,7 @@
               </a:defRPr>
             </a:pPr>
             <a:r>
-              <a:t>Smart Recruitment Portal: Key Takeaways</a:t>
+              <a:t>Smart Recruitment Portal: Operational Impact</a:t>
             </a:r>
           </a:p>
         </p:txBody>
@@ -3279,7 +3279,7 @@
                 </a:solidFill>
                 <a:latin typeface="Arial"/>
               </a:rPr>
-              <a:t>HR and hiring managers scan, filter, and review candidates directly from the portal, eliminating manual CV tracking files.</a:t>
+              <a:t>Managers review candidates directly from the portal, eliminating manual CV tracking and administrative overhead.</a:t>
             </a:r>
           </a:p>
           <a:p>
@@ -3295,7 +3295,7 @@
               </a:defRPr>
             </a:pPr>
             <a:r>
-              <a:t>Elimination of Data Gaps: </a:t>
+              <a:t>Standardized Candidate Data: </a:t>
             </a:r>
             <a:r>
               <a:rPr sz="1500" b="0">
@@ -3304,7 +3304,7 @@
                 </a:solidFill>
                 <a:latin typeface="Arial"/>
               </a:rPr>
-              <a:t>Structured inputs and form validations ensure candidate information is complete, clean, and database-aligned on submission.</a:t>
+              <a:t>Dynamic form validations ensure applicant details are clean and complete on submission.</a:t>
             </a:r>
           </a:p>
           <a:p>
@@ -3345,7 +3345,7 @@
               </a:defRPr>
             </a:pPr>
             <a:r>
-              <a:t>Confidential &amp; Board Ready: </a:t>
+              <a:t>Board Room Ready: </a:t>
             </a:r>
             <a:r>
               <a:rPr sz="1500" b="0">
@@ -3354,7 +3354,7 @@
                 </a:solidFill>
                 <a:latin typeface="Arial"/>
               </a:rPr>
-              <a:t>Roster filters, search functionality, and standardized exports are structured to be shared directly with senior board members and stakeholders.</a:t>
+              <a:t>Roster filters, dossier popups, and standardized exports are structured to be shared directly with senior board members and stakeholders.</a:t>
             </a:r>
           </a:p>
         </p:txBody>
@@ -3416,7 +3416,7 @@
               </a:defRPr>
             </a:pPr>
             <a:r>
-              <a:t>The Operational Problem We Solved</a:t>
+              <a:t>The Legacy Challenge: The Data &amp; Roster Bottleneck</a:t>
             </a:r>
           </a:p>
         </p:txBody>
@@ -3446,7 +3446,7 @@
             <a:pPr>
               <a:defRPr sz="1400" b="1">
                 <a:solidFill>
-                  <a:srgbClr val="EF4444"/>
+                  <a:srgbClr val="DC2626"/>
                 </a:solidFill>
                 <a:latin typeface="Arial"/>
               </a:defRPr>
@@ -3471,7 +3471,7 @@
               </a:defRPr>
             </a:pPr>
             <a:r>
-              <a:t>Messy Data &amp; Loss of Focus</a:t>
+              <a:t>Data Scrawl &amp; Manual Review</a:t>
             </a:r>
           </a:p>
           <a:p>
@@ -3487,7 +3487,7 @@
               </a:defRPr>
             </a:pPr>
             <a:r>
-              <a:t>• Qualifications, publications, and works clumped into single cells with commas, breaking searchability.</a:t>
+              <a:t>• Multiple degrees and research works clumped into single cells with commas, blocking automated analysis.</a:t>
             </a:r>
           </a:p>
           <a:p>
@@ -3503,7 +3503,7 @@
               </a:defRPr>
             </a:pPr>
             <a:r>
-              <a:t>• Spreadsheets stretching infinitely to the right with empty column chains (UG1, UG2, Work1, Work2), making rosters unreadable.</a:t>
+              <a:t>• Spreadsheets stretching infinitely to the right with redundant columns, causing horizontal scrolling fatigue.</a:t>
             </a:r>
           </a:p>
           <a:p>
@@ -3519,7 +3519,7 @@
               </a:defRPr>
             </a:pPr>
             <a:r>
-              <a:t>• Scores formatted inconsistently (mix of '9.0 CGPA', '79.0 Percentage', and default 0.0 entries).</a:t>
+              <a:t>• Inconsistent score formats (CGPAs vs. percentages) making comparison difficult.</a:t>
             </a:r>
           </a:p>
           <a:p>
@@ -3535,7 +3535,7 @@
               </a:defRPr>
             </a:pPr>
             <a:r>
-              <a:t>• Manual resume downloading and copy-pasting causing hiring delays.</a:t>
+              <a:t>• Manual resume downloads and alignment causing long hiring delays.</a:t>
             </a:r>
           </a:p>
         </p:txBody>
@@ -3565,7 +3565,7 @@
             <a:pPr>
               <a:defRPr sz="1400" b="1">
                 <a:solidFill>
-                  <a:srgbClr val="22C55E"/>
+                  <a:srgbClr val="16A34A"/>
                 </a:solidFill>
                 <a:latin typeface="Arial"/>
               </a:defRPr>
@@ -3590,7 +3590,7 @@
               </a:defRPr>
             </a:pPr>
             <a:r>
-              <a:t>Clean Intake to Clean Output</a:t>
+              <a:t>Structured Intake to Clean Output</a:t>
             </a:r>
           </a:p>
           <a:p>
@@ -3606,7 +3606,7 @@
               </a:defRPr>
             </a:pPr>
             <a:r>
-              <a:t>• Structured Application Intake: Candidates input individual degrees, scores, and timelines dynamically.</a:t>
+              <a:t>• Standardized Intake: Candidates input individual degrees, scores, and timelines dynamically at source.</a:t>
             </a:r>
           </a:p>
           <a:p>
@@ -3622,7 +3622,7 @@
               </a:defRPr>
             </a:pPr>
             <a:r>
-              <a:t>• Operational HR Dashboards: Instantly review applicant lists, apply filters, and access dossier profile sheets.</a:t>
+              <a:t>• HR Control Centers: Instantly filter active roles, review metrics, and open dossier profile views.</a:t>
             </a:r>
           </a:p>
           <a:p>
@@ -3638,7 +3638,7 @@
               </a:defRPr>
             </a:pPr>
             <a:r>
-              <a:t>• Grouped Stacked Excel Roster: Candidate qualifications are stacked vertically with merged basic details.</a:t>
+              <a:t>• Stacked Roster Layouts: Candidate details are stacked vertically with merged basic details.</a:t>
             </a:r>
           </a:p>
           <a:p>
@@ -3654,7 +3654,7 @@
               </a:defRPr>
             </a:pPr>
             <a:r>
-              <a:t>• Strict score normalization (clean '%' and 'CGPA' suffixes, stripping trailing decimals).</a:t>
+              <a:t>• Score Normalization: Auto-formats scores to clean percentages ('79%') or CGPA ('8 CGPA') on download.</a:t>
             </a:r>
           </a:p>
         </p:txBody>
@@ -3716,7 +3716,7 @@
               </a:defRPr>
             </a:pPr>
             <a:r>
-              <a:t>Candidate Interface: Open Positions Board</a:t>
+              <a:t>Candidate Interface: Structured Job Board</a:t>
             </a:r>
           </a:p>
         </p:txBody>
@@ -3729,8 +3729,8 @@
         </p:nvSpPr>
         <p:spPr>
           <a:xfrm>
-            <a:off x="731520" y="1463040"/>
-            <a:ext cx="4754880" cy="4572000"/>
+            <a:off x="731520" y="1371600"/>
+            <a:ext cx="4937760" cy="4572000"/>
           </a:xfrm>
           <a:prstGeom prst="rect">
             <a:avLst/>
@@ -3764,7 +3764,7 @@
                 </a:solidFill>
                 <a:latin typeface="Arial"/>
               </a:rPr>
-              <a:t>Candidates land on a clean, modern interface listing open vacancies at RIS.</a:t>
+              <a:t>Applicants access a clean web interface listing open opportunities at RIS.</a:t>
             </a:r>
           </a:p>
           <a:p>
@@ -3780,7 +3780,7 @@
               </a:defRPr>
             </a:pPr>
             <a:r>
-              <a:t>• Transparent Metadata: </a:t>
+              <a:t>• Transparent Information: </a:t>
             </a:r>
             <a:r>
               <a:rPr b="0" sz="1300">
@@ -3789,7 +3789,7 @@
                 </a:solidFill>
                 <a:latin typeface="Arial"/>
               </a:rPr>
-              <a:t>Each job card displays division tags (e.g., CMEC, RIS), location (New Delhi, India), and clear application deadlines.</a:t>
+              <a:t>Displays role titles, division tags (e.g. CMEC, DAKSHIN), locations, and submission deadlines.</a:t>
             </a:r>
           </a:p>
           <a:p>
@@ -3805,7 +3805,7 @@
               </a:defRPr>
             </a:pPr>
             <a:r>
-              <a:t>• Job-Specific Information: </a:t>
+              <a:t>• Clear Scope: </a:t>
             </a:r>
             <a:r>
               <a:rPr b="0" sz="1300">
@@ -3814,7 +3814,7 @@
                 </a:solidFill>
                 <a:latin typeface="Arial"/>
               </a:rPr>
-              <a:t>Provides short public descriptions to inform prospective applicants prior to starting an application.</a:t>
+              <a:t>Provides concise public descriptions to inform prospective applicants prior to starting an application.</a:t>
             </a:r>
           </a:p>
           <a:p>
@@ -3839,7 +3839,7 @@
                 </a:solidFill>
                 <a:latin typeface="Arial"/>
               </a:rPr>
-              <a:t>A direct 'Apply Now' flow redirects candidates to a structured multiphase application form.</a:t>
+              <a:t>Direct redirection to a structured application form to ensure candidate details are captured correctly.</a:t>
             </a:r>
           </a:p>
         </p:txBody>
@@ -3860,8 +3860,8 @@
         </p:blipFill>
         <p:spPr>
           <a:xfrm>
-            <a:off x="5760720" y="1463040"/>
-            <a:ext cx="5669280" cy="4389120"/>
+            <a:off x="5943600" y="1371600"/>
+            <a:ext cx="5486400" cy="4389120"/>
           </a:xfrm>
           <a:prstGeom prst="rect">
             <a:avLst/>
@@ -3925,7 +3925,7 @@
               </a:defRPr>
             </a:pPr>
             <a:r>
-              <a:t>HR Dashboard: Central Vacancy Control</a:t>
+              <a:t>HR Dashboard: Central Roster Management</a:t>
             </a:r>
           </a:p>
         </p:txBody>
@@ -3938,8 +3938,8 @@
         </p:nvSpPr>
         <p:spPr>
           <a:xfrm>
-            <a:off x="731520" y="1463040"/>
-            <a:ext cx="4754880" cy="4572000"/>
+            <a:off x="731520" y="1371600"/>
+            <a:ext cx="4937760" cy="4572000"/>
           </a:xfrm>
           <a:prstGeom prst="rect">
             <a:avLst/>
@@ -3964,7 +3964,7 @@
               </a:defRPr>
             </a:pPr>
             <a:r>
-              <a:t>• Administrative Overview: </a:t>
+              <a:t>• Real-Time Tracking: </a:t>
             </a:r>
             <a:r>
               <a:rPr b="0" sz="1300">
@@ -3973,7 +3973,7 @@
                 </a:solidFill>
                 <a:latin typeface="Arial"/>
               </a:rPr>
-              <a:t>HR administrators get a comprehensive birds-eye view of all hiring activities.</a:t>
+              <a:t>HR administrators get a comprehensive overview of active vacancies and applicant volumes.</a:t>
             </a:r>
           </a:p>
           <a:p>
@@ -3989,7 +3989,7 @@
               </a:defRPr>
             </a:pPr>
             <a:r>
-              <a:t>• Status Counters: </a:t>
+              <a:t>• Dashboard Statistics: </a:t>
             </a:r>
             <a:r>
               <a:rPr b="0" sz="1300">
@@ -3998,7 +3998,7 @@
                 </a:solidFill>
                 <a:latin typeface="Arial"/>
               </a:rPr>
-              <a:t>Top statistics cards summarize Open Positions, Total Applicants (this year), and listings Closing Soon.</a:t>
+              <a:t>Top-level summary cards display Open Positions, Total Applicants (this year), and roles Closing Soon.</a:t>
             </a:r>
           </a:p>
           <a:p>
@@ -4014,7 +4014,7 @@
               </a:defRPr>
             </a:pPr>
             <a:r>
-              <a:t>• Job Postings List: </a:t>
+              <a:t>• Status Columns: </a:t>
             </a:r>
             <a:r>
               <a:rPr b="0" sz="1300">
@@ -4023,7 +4023,7 @@
                 </a:solidFill>
                 <a:latin typeface="Arial"/>
               </a:rPr>
-              <a:t>A central list displays role titles, divisions, applicant counts, posting dates, deadlines, and statuses (Open/Draft/Closed).</a:t>
+              <a:t>Central table showing active vacancies, divisions, applicant numbers, posted dates, and deadlines.</a:t>
             </a:r>
           </a:p>
           <a:p>
@@ -4039,7 +4039,7 @@
               </a:defRPr>
             </a:pPr>
             <a:r>
-              <a:t>• Actions Panel: </a:t>
+              <a:t>• Direct Operations: </a:t>
             </a:r>
             <a:r>
               <a:rPr b="0" sz="1300">
@@ -4048,7 +4048,7 @@
                 </a:solidFill>
                 <a:latin typeface="Arial"/>
               </a:rPr>
-              <a:t>Quick access buttons to view applicants, edit job details, or archive postings.</a:t>
+              <a:t>Quick access links to view applicants, edit job listings, or archive roles.</a:t>
             </a:r>
           </a:p>
         </p:txBody>
@@ -4069,8 +4069,8 @@
         </p:blipFill>
         <p:spPr>
           <a:xfrm>
-            <a:off x="5760720" y="1463040"/>
-            <a:ext cx="5669280" cy="4389120"/>
+            <a:off x="5943600" y="1371600"/>
+            <a:ext cx="5486400" cy="4389120"/>
           </a:xfrm>
           <a:prstGeom prst="rect">
             <a:avLst/>
@@ -4134,7 +4134,7 @@
               </a:defRPr>
             </a:pPr>
             <a:r>
-              <a:t>HR Operations: Streamlined Job Creation</a:t>
+              <a:t>HR Operations: Standardized Vacancy Control</a:t>
             </a:r>
           </a:p>
         </p:txBody>
@@ -4147,8 +4147,8 @@
         </p:nvSpPr>
         <p:spPr>
           <a:xfrm>
-            <a:off x="731520" y="1463040"/>
-            <a:ext cx="4754880" cy="4572000"/>
+            <a:off x="731520" y="1371600"/>
+            <a:ext cx="4937760" cy="4572000"/>
           </a:xfrm>
           <a:prstGeom prst="rect">
             <a:avLst/>
@@ -4173,7 +4173,7 @@
               </a:defRPr>
             </a:pPr>
             <a:r>
-              <a:t>• Simplified Input Layout: </a:t>
+              <a:t>• Structured Input Forms: </a:t>
             </a:r>
             <a:r>
               <a:rPr b="0" sz="1300">
@@ -4182,7 +4182,7 @@
                 </a:solidFill>
                 <a:latin typeface="Arial"/>
               </a:rPr>
-              <a:t>Create job cards are cleaned up by removing redundant description notes and AI requirements fields.</a:t>
+              <a:t>Clean job creation modal with simplified fields to prevent layout clutter.</a:t>
             </a:r>
           </a:p>
           <a:p>
@@ -4198,7 +4198,7 @@
               </a:defRPr>
             </a:pPr>
             <a:r>
-              <a:t>• Contract &amp; Compensation Settings: </a:t>
+              <a:t>• Compensation Settings: </a:t>
             </a:r>
             <a:r>
               <a:rPr b="0" sz="1300">
@@ -4207,7 +4207,7 @@
                 </a:solidFill>
                 <a:latin typeface="Arial"/>
               </a:rPr>
-              <a:t>Includes a dedicated configuration card at the bottom to define pay bands and contract constraints.</a:t>
+              <a:t>Dedicated contract and compensation settings panel to manage role boundaries.</a:t>
             </a:r>
           </a:p>
           <a:p>
@@ -4223,7 +4223,7 @@
               </a:defRPr>
             </a:pPr>
             <a:r>
-              <a:t>• Salary Bands: </a:t>
+              <a:t>• Predefined Pay Bands: </a:t>
             </a:r>
             <a:r>
               <a:rPr b="0" sz="1300">
@@ -4232,7 +4232,7 @@
                 </a:solidFill>
                 <a:latin typeface="Arial"/>
               </a:rPr>
-              <a:t>Set minimum and maximum pay ranges directly using dropdown options.</a:t>
+              <a:t>Set minimum and maximum pay expectations directly via dropdown selectors.</a:t>
             </a:r>
           </a:p>
           <a:p>
@@ -4248,7 +4248,7 @@
               </a:defRPr>
             </a:pPr>
             <a:r>
-              <a:t>• Experience Boundaries: </a:t>
+              <a:t>• Experience Requirements: </a:t>
             </a:r>
             <a:r>
               <a:rPr b="0" sz="1300">
@@ -4257,7 +4257,7 @@
                 </a:solidFill>
                 <a:latin typeface="Arial"/>
               </a:rPr>
-              <a:t>Specify minimum and maximum experience ranges required for applicants, and define contract years.</a:t>
+              <a:t>Enforce minimum and maximum experience levels required, and set contract durations.</a:t>
             </a:r>
           </a:p>
         </p:txBody>
@@ -4278,8 +4278,8 @@
         </p:blipFill>
         <p:spPr>
           <a:xfrm>
-            <a:off x="5760720" y="1463040"/>
-            <a:ext cx="5669280" cy="4389120"/>
+            <a:off x="5943600" y="1371600"/>
+            <a:ext cx="5486400" cy="4389120"/>
           </a:xfrm>
           <a:prstGeom prst="rect">
             <a:avLst/>
@@ -4343,7 +4343,7 @@
               </a:defRPr>
             </a:pPr>
             <a:r>
-              <a:t>HR Dashboard: General Talent Analytics</a:t>
+              <a:t>HR Dashboard: System Talent Analytics</a:t>
             </a:r>
           </a:p>
         </p:txBody>
@@ -4356,8 +4356,8 @@
         </p:nvSpPr>
         <p:spPr>
           <a:xfrm>
-            <a:off x="731520" y="1463040"/>
-            <a:ext cx="4754880" cy="4572000"/>
+            <a:off x="731520" y="1371600"/>
+            <a:ext cx="4937760" cy="4572000"/>
           </a:xfrm>
           <a:prstGeom prst="rect">
             <a:avLst/>
@@ -4382,7 +4382,7 @@
               </a:defRPr>
             </a:pPr>
             <a:r>
-              <a:t>• Visual Demographics: </a:t>
+              <a:t>• Operational Metrics: </a:t>
             </a:r>
             <a:r>
               <a:rPr b="0" sz="1300">
@@ -4391,7 +4391,7 @@
                 </a:solidFill>
                 <a:latin typeface="Arial"/>
               </a:rPr>
-              <a:t>Presents real-time candidate statistics across the entire system.</a:t>
+              <a:t>Presents visual candidate demographics across the system automatically.</a:t>
             </a:r>
           </a:p>
           <a:p>
@@ -4416,7 +4416,7 @@
                 </a:solidFill>
                 <a:latin typeface="Arial"/>
               </a:rPr>
-              <a:t>A donut chart displays male/female distribution of the applicant pool.</a:t>
+              <a:t>A donut chart maps the gender balance of the active applicant pool.</a:t>
             </a:r>
           </a:p>
           <a:p>
@@ -4441,7 +4441,7 @@
                 </a:solidFill>
                 <a:latin typeface="Arial"/>
               </a:rPr>
-              <a:t>Bar charts show geographic distributions, showing which states candidates apply from most (e.g., Tamil Nadu, Delhi, Karnataka).</a:t>
+              <a:t>Visualizes geographic distribution, showing top applicant states at a glance.</a:t>
             </a:r>
           </a:p>
           <a:p>
@@ -4457,7 +4457,7 @@
               </a:defRPr>
             </a:pPr>
             <a:r>
-              <a:t>• Pipeline Velocity: </a:t>
+              <a:t>• Hiring Pipeline Velocity: </a:t>
             </a:r>
             <a:r>
               <a:rPr b="0" sz="1300">
@@ -4466,7 +4466,7 @@
                 </a:solidFill>
                 <a:latin typeface="Arial"/>
               </a:rPr>
-              <a:t>A status bar tracks total talent counts alongside shortlisted, selected, and rejected applicants.</a:t>
+              <a:t>Tracks total applications against shortlists and selections dynamically.</a:t>
             </a:r>
           </a:p>
         </p:txBody>
@@ -4487,8 +4487,8 @@
         </p:blipFill>
         <p:spPr>
           <a:xfrm>
-            <a:off x="5760720" y="1463040"/>
-            <a:ext cx="5669280" cy="4389120"/>
+            <a:off x="5943600" y="1371600"/>
+            <a:ext cx="5486400" cy="4389120"/>
           </a:xfrm>
           <a:prstGeom prst="rect">
             <a:avLst/>
@@ -4552,7 +4552,7 @@
               </a:defRPr>
             </a:pPr>
             <a:r>
-              <a:t>Roster Analytics &amp; Specialized Filtering</a:t>
+              <a:t>Roster Analytics &amp; Multivariate Filters</a:t>
             </a:r>
           </a:p>
         </p:txBody>
@@ -4565,8 +4565,8 @@
         </p:nvSpPr>
         <p:spPr>
           <a:xfrm>
-            <a:off x="731520" y="1463040"/>
-            <a:ext cx="4754880" cy="4572000"/>
+            <a:off x="731520" y="1371600"/>
+            <a:ext cx="4937760" cy="4572000"/>
           </a:xfrm>
           <a:prstGeom prst="rect">
             <a:avLst/>
@@ -4591,7 +4591,7 @@
               </a:defRPr>
             </a:pPr>
             <a:r>
-              <a:t>• Role-Specific Metrics: </a:t>
+              <a:t>• Vacancy Deep-Dive: </a:t>
             </a:r>
             <a:r>
               <a:rPr b="0" sz="1300">
@@ -4600,7 +4600,7 @@
                 </a:solidFill>
                 <a:latin typeface="Arial"/>
               </a:rPr>
-              <a:t>Provides demographic, geographic, and highest degree distributions specifically for the active job listing.</a:t>
+              <a:t>Displays demographic and seniority distributions tailored to the selected job posting.</a:t>
             </a:r>
           </a:p>
           <a:p>
@@ -4616,7 +4616,7 @@
               </a:defRPr>
             </a:pPr>
             <a:r>
-              <a:t>• Degree Seniority: </a:t>
+              <a:t>• Seniority Ratios: </a:t>
             </a:r>
             <a:r>
               <a:rPr b="0" sz="1300">
@@ -4625,7 +4625,7 @@
                 </a:solidFill>
                 <a:latin typeface="Arial"/>
               </a:rPr>
-              <a:t>Instantly visualizes Ph.D., Masters, and Bachelors ratios in the applicant pool.</a:t>
+              <a:t>Visualizes the distribution of Ph.D., Masters, and Bachelors degrees in the pool.</a:t>
             </a:r>
           </a:p>
           <a:p>
@@ -4641,7 +4641,7 @@
               </a:defRPr>
             </a:pPr>
             <a:r>
-              <a:t>• Candidate Filters: </a:t>
+              <a:t>• Advanced Filters: </a:t>
             </a:r>
             <a:r>
               <a:rPr b="0" sz="1300">
@@ -4650,7 +4650,7 @@
                 </a:solidFill>
                 <a:latin typeface="Arial"/>
               </a:rPr>
-              <a:t>Advanced search cards allow HR to filter candidates based on biographical details, early academics (Class X/XII), higher education degrees, work history, and publication fields.</a:t>
+              <a:t>Isolate candidate subsets instantly using biographical, academic, experience, and publication filters.</a:t>
             </a:r>
           </a:p>
           <a:p>
@@ -4666,7 +4666,7 @@
               </a:defRPr>
             </a:pPr>
             <a:r>
-              <a:t>• Instant Shortlisting: </a:t>
+              <a:t>• No Decision Lag: </a:t>
             </a:r>
             <a:r>
               <a:rPr b="0" sz="1300">
@@ -4675,7 +4675,7 @@
                 </a:solidFill>
                 <a:latin typeface="Arial"/>
               </a:rPr>
-              <a:t>Enables HR to search through hundreds of profiles in seconds to find exact matches.</a:t>
+              <a:t>Enables HR to search through hundreds of profiles in seconds without opening individual resumes.</a:t>
             </a:r>
           </a:p>
         </p:txBody>
@@ -4696,8 +4696,8 @@
         </p:blipFill>
         <p:spPr>
           <a:xfrm>
-            <a:off x="5760720" y="1463040"/>
-            <a:ext cx="5669280" cy="4389120"/>
+            <a:off x="5943600" y="1371600"/>
+            <a:ext cx="5486400" cy="4389120"/>
           </a:xfrm>
           <a:prstGeom prst="rect">
             <a:avLst/>
@@ -4761,7 +4761,7 @@
               </a:defRPr>
             </a:pPr>
             <a:r>
-              <a:t>HR Portal: Candidate Dossier Modal</a:t>
+              <a:t>Candidate Dossier: 360-Degree Profile View</a:t>
             </a:r>
           </a:p>
         </p:txBody>
@@ -4797,7 +4797,7 @@
               </a:defRPr>
             </a:pPr>
             <a:r>
-              <a:t>Modular Candidate Dossier popup showing top overview metrics (left) and scrolled detailed profile view (right).</a:t>
+              <a:t>Review candidate profiles instantly in a modular, color-coded dossier modal without opening separate files.</a:t>
             </a:r>
           </a:p>
         </p:txBody>
@@ -4881,7 +4881,7 @@
               </a:defRPr>
             </a:pPr>
             <a:r>
-              <a:t>• Visual academic cards (Ph.D. in purple, Masters in blue)  • Dynamic rollups (UG: 8.6 | PG: 77% | XII: 91.3%)  • Blue 'OK' close button in footer</a:t>
+              <a:t>• Quick Profile Rollups  • Color-Coded Academic Levels  • Timeline Experience Views  • Clean Close Layout</a:t>
             </a:r>
           </a:p>
         </p:txBody>
@@ -4956,8 +4956,8 @@
         </p:nvSpPr>
         <p:spPr>
           <a:xfrm>
-            <a:off x="731520" y="1463040"/>
-            <a:ext cx="4754880" cy="4572000"/>
+            <a:off x="731520" y="1371600"/>
+            <a:ext cx="4937760" cy="4572000"/>
           </a:xfrm>
           <a:prstGeom prst="rect">
             <a:avLst/>
@@ -4982,7 +4982,7 @@
               </a:defRPr>
             </a:pPr>
             <a:r>
-              <a:t>• Multiple Formats: </a:t>
+              <a:t>• Flexible Formats: </a:t>
             </a:r>
             <a:r>
               <a:rPr b="0" sz="1300">
@@ -4991,7 +4991,7 @@
                 </a:solidFill>
                 <a:latin typeface="Arial"/>
               </a:rPr>
-              <a:t>Provides HR with flexible export formats depending on the target audience.</a:t>
+              <a:t>Download candidate data tailored to the requirements of the review committee.</a:t>
             </a:r>
           </a:p>
           <a:p>
@@ -5007,7 +5007,7 @@
               </a:defRPr>
             </a:pPr>
             <a:r>
-              <a:t>• Detailed Excel (.xlsx): </a:t>
+              <a:t>• Detailed Grouped Excel: </a:t>
             </a:r>
             <a:r>
               <a:rPr b="0" sz="1300">
@@ -5016,7 +5016,7 @@
                 </a:solidFill>
                 <a:latin typeface="Arial"/>
               </a:rPr>
-              <a:t>Solves comma-clumping. Generates grouped stacked rows for candidates with multiple degrees, merging basic candidate details vertically.</a:t>
+              <a:t>Candidate qualifications are stacked vertically with basic details merged, keeping layouts clean.</a:t>
             </a:r>
           </a:p>
           <a:p>
@@ -5032,7 +5032,7 @@
               </a:defRPr>
             </a:pPr>
             <a:r>
-              <a:t>• Standardized Summary (.xlsx): </a:t>
+              <a:t>• Standardized Summary: </a:t>
             </a:r>
             <a:r>
               <a:rPr b="0" sz="1300">
@@ -5041,7 +5041,7 @@
                 </a:solidFill>
                 <a:latin typeface="Arial"/>
               </a:rPr>
-              <a:t>Provides a condensed one-candidate-per-row summary table containing formatted 'Degree (University)' combinations.</a:t>
+              <a:t>Generates condensed reports displaying degrees and latest roles inline (e.g. 'Degree (University)').</a:t>
             </a:r>
           </a:p>
           <a:p>
@@ -5057,7 +5057,7 @@
               </a:defRPr>
             </a:pPr>
             <a:r>
-              <a:t>• Clean Score Formatting: </a:t>
+              <a:t>• Clean Score Normalization: </a:t>
             </a:r>
             <a:r>
               <a:rPr b="0" sz="1300">
@@ -5066,7 +5066,7 @@
                 </a:solidFill>
                 <a:latin typeface="Arial"/>
               </a:rPr>
-              <a:t>Universally formats scores as '79%' or '8.2 CGPA', removes trailing '.0' decimals for integers, and leaves X and XII as raw numbers.</a:t>
+              <a:t>Automatically formats higher education scores ('79%' or '8 CGPA'), stripping trailing '.0' decimals.</a:t>
             </a:r>
           </a:p>
         </p:txBody>
@@ -5087,8 +5087,8 @@
         </p:blipFill>
         <p:spPr>
           <a:xfrm>
-            <a:off x="5760720" y="1463040"/>
-            <a:ext cx="5669280" cy="4389120"/>
+            <a:off x="5943600" y="1371600"/>
+            <a:ext cx="5486400" cy="4389120"/>
           </a:xfrm>
           <a:prstGeom prst="rect">
             <a:avLst/>

</xml_diff>

<commit_message>
feat: restructure degree inputs into split dropdown/specialization fields and remove extracurriculars
</commit_message>
<xml_diff>
--- a/resources/HR_Portal_Presentation.pptx
+++ b/resources/HR_Portal_Presentation.pptx
@@ -5,18 +5,18 @@
     <p:sldMasterId id="2147483648" r:id="rId1"/>
   </p:sldMasterIdLst>
   <p:sldIdLst>
-    <p:sldId id="256" r:id="rId7"/>
-    <p:sldId id="257" r:id="rId8"/>
-    <p:sldId id="258" r:id="rId9"/>
-    <p:sldId id="259" r:id="rId10"/>
-    <p:sldId id="260" r:id="rId11"/>
-    <p:sldId id="261" r:id="rId12"/>
-    <p:sldId id="262" r:id="rId13"/>
-    <p:sldId id="263" r:id="rId14"/>
-    <p:sldId id="264" r:id="rId15"/>
-    <p:sldId id="265" r:id="rId16"/>
+    <p:sldId id="256" r:id="rId2"/>
+    <p:sldId id="257" r:id="rId3"/>
+    <p:sldId id="258" r:id="rId4"/>
+    <p:sldId id="259" r:id="rId5"/>
+    <p:sldId id="260" r:id="rId6"/>
+    <p:sldId id="261" r:id="rId7"/>
+    <p:sldId id="262" r:id="rId8"/>
+    <p:sldId id="263" r:id="rId9"/>
+    <p:sldId id="264" r:id="rId10"/>
+    <p:sldId id="265" r:id="rId11"/>
   </p:sldIdLst>
-  <p:sldSz cx="12191695" cy="6858000" type="screen4x3"/>
+  <p:sldSz cx="12192000" cy="6858000"/>
   <p:notesSz cx="6858000" cy="9144000"/>
   <p:defaultTextStyle>
     <a:defPPr>
@@ -113,6 +113,22 @@
       </a:defRPr>
     </a:lvl9pPr>
   </p:defaultTextStyle>
+  <p:extLst>
+    <p:ext uri="{EFAFB233-063F-42B5-8137-9DF3F51BA10A}">
+      <p15:sldGuideLst xmlns:p15="http://schemas.microsoft.com/office/powerpoint/2012/main">
+        <p15:guide id="1" orient="horz" pos="2160">
+          <p15:clr>
+            <a:srgbClr val="A4A3A4"/>
+          </p15:clr>
+        </p15:guide>
+        <p15:guide id="2" pos="2880">
+          <p15:clr>
+            <a:srgbClr val="A4A3A4"/>
+          </p15:clr>
+        </p15:guide>
+      </p15:sldGuideLst>
+    </p:ext>
+  </p:extLst>
 </p:presentation>
 </file>
 
@@ -154,10 +170,9 @@
           <a:lstStyle/>
           <a:p>
             <a:r>
-              <a:rPr lang="en-US" smtClean="0"/>
+              <a:rPr lang="en-US"/>
               <a:t>Click to edit Master title style</a:t>
             </a:r>
-            <a:endParaRPr lang="en-US"/>
           </a:p>
         </p:txBody>
       </p:sp>
@@ -273,10 +288,9 @@
           </a:lstStyle>
           <a:p>
             <a:r>
-              <a:rPr lang="en-US" smtClean="0"/>
+              <a:rPr lang="en-US"/>
               <a:t>Click to edit Master subtitle style</a:t>
             </a:r>
-            <a:endParaRPr lang="en-US"/>
           </a:p>
         </p:txBody>
       </p:sp>
@@ -297,7 +311,7 @@
           <a:p>
             <a:fld id="{5BCAD085-E8A6-8845-BD4E-CB4CCA059FC4}" type="datetimeFigureOut">
               <a:rPr lang="en-US" smtClean="0"/>
-              <a:t>1/27/13</a:t>
+              <a:t>5/28/2026</a:t>
             </a:fld>
             <a:endParaRPr lang="en-US"/>
           </a:p>
@@ -391,10 +405,9 @@
           <a:lstStyle/>
           <a:p>
             <a:r>
-              <a:rPr lang="en-US" smtClean="0"/>
+              <a:rPr lang="en-US"/>
               <a:t>Click to edit Master title style</a:t>
             </a:r>
-            <a:endParaRPr lang="en-US"/>
           </a:p>
         </p:txBody>
       </p:sp>
@@ -415,38 +428,37 @@
           <a:p>
             <a:pPr lvl="0"/>
             <a:r>
-              <a:rPr lang="en-US" smtClean="0"/>
+              <a:rPr lang="en-US"/>
               <a:t>Click to edit Master text styles</a:t>
             </a:r>
           </a:p>
           <a:p>
             <a:pPr lvl="1"/>
             <a:r>
-              <a:rPr lang="en-US" smtClean="0"/>
+              <a:rPr lang="en-US"/>
               <a:t>Second level</a:t>
             </a:r>
           </a:p>
           <a:p>
             <a:pPr lvl="2"/>
             <a:r>
-              <a:rPr lang="en-US" smtClean="0"/>
+              <a:rPr lang="en-US"/>
               <a:t>Third level</a:t>
             </a:r>
           </a:p>
           <a:p>
             <a:pPr lvl="3"/>
             <a:r>
-              <a:rPr lang="en-US" smtClean="0"/>
+              <a:rPr lang="en-US"/>
               <a:t>Fourth level</a:t>
             </a:r>
           </a:p>
           <a:p>
             <a:pPr lvl="4"/>
             <a:r>
-              <a:rPr lang="en-US" smtClean="0"/>
+              <a:rPr lang="en-US"/>
               <a:t>Fifth level</a:t>
             </a:r>
-            <a:endParaRPr lang="en-US"/>
           </a:p>
         </p:txBody>
       </p:sp>
@@ -467,7 +479,7 @@
           <a:p>
             <a:fld id="{5BCAD085-E8A6-8845-BD4E-CB4CCA059FC4}" type="datetimeFigureOut">
               <a:rPr lang="en-US" smtClean="0"/>
-              <a:t>1/27/13</a:t>
+              <a:t>5/28/2026</a:t>
             </a:fld>
             <a:endParaRPr lang="en-US"/>
           </a:p>
@@ -566,10 +578,9 @@
           <a:lstStyle/>
           <a:p>
             <a:r>
-              <a:rPr lang="en-US" smtClean="0"/>
+              <a:rPr lang="en-US"/>
               <a:t>Click to edit Master title style</a:t>
             </a:r>
-            <a:endParaRPr lang="en-US"/>
           </a:p>
         </p:txBody>
       </p:sp>
@@ -595,38 +606,37 @@
           <a:p>
             <a:pPr lvl="0"/>
             <a:r>
-              <a:rPr lang="en-US" smtClean="0"/>
+              <a:rPr lang="en-US"/>
               <a:t>Click to edit Master text styles</a:t>
             </a:r>
           </a:p>
           <a:p>
             <a:pPr lvl="1"/>
             <a:r>
-              <a:rPr lang="en-US" smtClean="0"/>
+              <a:rPr lang="en-US"/>
               <a:t>Second level</a:t>
             </a:r>
           </a:p>
           <a:p>
             <a:pPr lvl="2"/>
             <a:r>
-              <a:rPr lang="en-US" smtClean="0"/>
+              <a:rPr lang="en-US"/>
               <a:t>Third level</a:t>
             </a:r>
           </a:p>
           <a:p>
             <a:pPr lvl="3"/>
             <a:r>
-              <a:rPr lang="en-US" smtClean="0"/>
+              <a:rPr lang="en-US"/>
               <a:t>Fourth level</a:t>
             </a:r>
           </a:p>
           <a:p>
             <a:pPr lvl="4"/>
             <a:r>
-              <a:rPr lang="en-US" smtClean="0"/>
+              <a:rPr lang="en-US"/>
               <a:t>Fifth level</a:t>
             </a:r>
-            <a:endParaRPr lang="en-US"/>
           </a:p>
         </p:txBody>
       </p:sp>
@@ -647,7 +657,7 @@
           <a:p>
             <a:fld id="{5BCAD085-E8A6-8845-BD4E-CB4CCA059FC4}" type="datetimeFigureOut">
               <a:rPr lang="en-US" smtClean="0"/>
-              <a:t>1/27/13</a:t>
+              <a:t>5/28/2026</a:t>
             </a:fld>
             <a:endParaRPr lang="en-US"/>
           </a:p>
@@ -741,10 +751,9 @@
           <a:lstStyle/>
           <a:p>
             <a:r>
-              <a:rPr lang="en-US" smtClean="0"/>
+              <a:rPr lang="en-US"/>
               <a:t>Click to edit Master title style</a:t>
             </a:r>
-            <a:endParaRPr lang="en-US"/>
           </a:p>
         </p:txBody>
       </p:sp>
@@ -765,38 +774,37 @@
           <a:p>
             <a:pPr lvl="0"/>
             <a:r>
-              <a:rPr lang="en-US" smtClean="0"/>
+              <a:rPr lang="en-US"/>
               <a:t>Click to edit Master text styles</a:t>
             </a:r>
           </a:p>
           <a:p>
             <a:pPr lvl="1"/>
             <a:r>
-              <a:rPr lang="en-US" smtClean="0"/>
+              <a:rPr lang="en-US"/>
               <a:t>Second level</a:t>
             </a:r>
           </a:p>
           <a:p>
             <a:pPr lvl="2"/>
             <a:r>
-              <a:rPr lang="en-US" smtClean="0"/>
+              <a:rPr lang="en-US"/>
               <a:t>Third level</a:t>
             </a:r>
           </a:p>
           <a:p>
             <a:pPr lvl="3"/>
             <a:r>
-              <a:rPr lang="en-US" smtClean="0"/>
+              <a:rPr lang="en-US"/>
               <a:t>Fourth level</a:t>
             </a:r>
           </a:p>
           <a:p>
             <a:pPr lvl="4"/>
             <a:r>
-              <a:rPr lang="en-US" smtClean="0"/>
+              <a:rPr lang="en-US"/>
               <a:t>Fifth level</a:t>
             </a:r>
-            <a:endParaRPr lang="en-US"/>
           </a:p>
         </p:txBody>
       </p:sp>
@@ -817,7 +825,7 @@
           <a:p>
             <a:fld id="{5BCAD085-E8A6-8845-BD4E-CB4CCA059FC4}" type="datetimeFigureOut">
               <a:rPr lang="en-US" smtClean="0"/>
-              <a:t>1/27/13</a:t>
+              <a:t>5/28/2026</a:t>
             </a:fld>
             <a:endParaRPr lang="en-US"/>
           </a:p>
@@ -920,10 +928,9 @@
           </a:lstStyle>
           <a:p>
             <a:r>
-              <a:rPr lang="en-US" smtClean="0"/>
+              <a:rPr lang="en-US"/>
               <a:t>Click to edit Master title style</a:t>
             </a:r>
-            <a:endParaRPr lang="en-US"/>
           </a:p>
         </p:txBody>
       </p:sp>
@@ -1040,7 +1047,7 @@
           <a:p>
             <a:pPr lvl="0"/>
             <a:r>
-              <a:rPr lang="en-US" smtClean="0"/>
+              <a:rPr lang="en-US"/>
               <a:t>Click to edit Master text styles</a:t>
             </a:r>
           </a:p>
@@ -1063,7 +1070,7 @@
           <a:p>
             <a:fld id="{5BCAD085-E8A6-8845-BD4E-CB4CCA059FC4}" type="datetimeFigureOut">
               <a:rPr lang="en-US" smtClean="0"/>
-              <a:t>1/27/13</a:t>
+              <a:t>5/28/2026</a:t>
             </a:fld>
             <a:endParaRPr lang="en-US"/>
           </a:p>
@@ -1157,10 +1164,9 @@
           <a:lstStyle/>
           <a:p>
             <a:r>
-              <a:rPr lang="en-US" smtClean="0"/>
+              <a:rPr lang="en-US"/>
               <a:t>Click to edit Master title style</a:t>
             </a:r>
-            <a:endParaRPr lang="en-US"/>
           </a:p>
         </p:txBody>
       </p:sp>
@@ -1214,38 +1220,37 @@
           <a:p>
             <a:pPr lvl="0"/>
             <a:r>
-              <a:rPr lang="en-US" smtClean="0"/>
+              <a:rPr lang="en-US"/>
               <a:t>Click to edit Master text styles</a:t>
             </a:r>
           </a:p>
           <a:p>
             <a:pPr lvl="1"/>
             <a:r>
-              <a:rPr lang="en-US" smtClean="0"/>
+              <a:rPr lang="en-US"/>
               <a:t>Second level</a:t>
             </a:r>
           </a:p>
           <a:p>
             <a:pPr lvl="2"/>
             <a:r>
-              <a:rPr lang="en-US" smtClean="0"/>
+              <a:rPr lang="en-US"/>
               <a:t>Third level</a:t>
             </a:r>
           </a:p>
           <a:p>
             <a:pPr lvl="3"/>
             <a:r>
-              <a:rPr lang="en-US" smtClean="0"/>
+              <a:rPr lang="en-US"/>
               <a:t>Fourth level</a:t>
             </a:r>
           </a:p>
           <a:p>
             <a:pPr lvl="4"/>
             <a:r>
-              <a:rPr lang="en-US" smtClean="0"/>
+              <a:rPr lang="en-US"/>
               <a:t>Fifth level</a:t>
             </a:r>
-            <a:endParaRPr lang="en-US"/>
           </a:p>
         </p:txBody>
       </p:sp>
@@ -1299,38 +1304,37 @@
           <a:p>
             <a:pPr lvl="0"/>
             <a:r>
-              <a:rPr lang="en-US" smtClean="0"/>
+              <a:rPr lang="en-US"/>
               <a:t>Click to edit Master text styles</a:t>
             </a:r>
           </a:p>
           <a:p>
             <a:pPr lvl="1"/>
             <a:r>
-              <a:rPr lang="en-US" smtClean="0"/>
+              <a:rPr lang="en-US"/>
               <a:t>Second level</a:t>
             </a:r>
           </a:p>
           <a:p>
             <a:pPr lvl="2"/>
             <a:r>
-              <a:rPr lang="en-US" smtClean="0"/>
+              <a:rPr lang="en-US"/>
               <a:t>Third level</a:t>
             </a:r>
           </a:p>
           <a:p>
             <a:pPr lvl="3"/>
             <a:r>
-              <a:rPr lang="en-US" smtClean="0"/>
+              <a:rPr lang="en-US"/>
               <a:t>Fourth level</a:t>
             </a:r>
           </a:p>
           <a:p>
             <a:pPr lvl="4"/>
             <a:r>
-              <a:rPr lang="en-US" smtClean="0"/>
+              <a:rPr lang="en-US"/>
               <a:t>Fifth level</a:t>
             </a:r>
-            <a:endParaRPr lang="en-US"/>
           </a:p>
         </p:txBody>
       </p:sp>
@@ -1351,7 +1355,7 @@
           <a:p>
             <a:fld id="{5BCAD085-E8A6-8845-BD4E-CB4CCA059FC4}" type="datetimeFigureOut">
               <a:rPr lang="en-US" smtClean="0"/>
-              <a:t>1/27/13</a:t>
+              <a:t>5/28/2026</a:t>
             </a:fld>
             <a:endParaRPr lang="en-US"/>
           </a:p>
@@ -1449,10 +1453,9 @@
           </a:lstStyle>
           <a:p>
             <a:r>
-              <a:rPr lang="en-US" smtClean="0"/>
+              <a:rPr lang="en-US"/>
               <a:t>Click to edit Master title style</a:t>
             </a:r>
-            <a:endParaRPr lang="en-US"/>
           </a:p>
         </p:txBody>
       </p:sp>
@@ -1515,7 +1518,7 @@
           <a:p>
             <a:pPr lvl="0"/>
             <a:r>
-              <a:rPr lang="en-US" smtClean="0"/>
+              <a:rPr lang="en-US"/>
               <a:t>Click to edit Master text styles</a:t>
             </a:r>
           </a:p>
@@ -1571,38 +1574,37 @@
           <a:p>
             <a:pPr lvl="0"/>
             <a:r>
-              <a:rPr lang="en-US" smtClean="0"/>
+              <a:rPr lang="en-US"/>
               <a:t>Click to edit Master text styles</a:t>
             </a:r>
           </a:p>
           <a:p>
             <a:pPr lvl="1"/>
             <a:r>
-              <a:rPr lang="en-US" smtClean="0"/>
+              <a:rPr lang="en-US"/>
               <a:t>Second level</a:t>
             </a:r>
           </a:p>
           <a:p>
             <a:pPr lvl="2"/>
             <a:r>
-              <a:rPr lang="en-US" smtClean="0"/>
+              <a:rPr lang="en-US"/>
               <a:t>Third level</a:t>
             </a:r>
           </a:p>
           <a:p>
             <a:pPr lvl="3"/>
             <a:r>
-              <a:rPr lang="en-US" smtClean="0"/>
+              <a:rPr lang="en-US"/>
               <a:t>Fourth level</a:t>
             </a:r>
           </a:p>
           <a:p>
             <a:pPr lvl="4"/>
             <a:r>
-              <a:rPr lang="en-US" smtClean="0"/>
+              <a:rPr lang="en-US"/>
               <a:t>Fifth level</a:t>
             </a:r>
-            <a:endParaRPr lang="en-US"/>
           </a:p>
         </p:txBody>
       </p:sp>
@@ -1665,7 +1667,7 @@
           <a:p>
             <a:pPr lvl="0"/>
             <a:r>
-              <a:rPr lang="en-US" smtClean="0"/>
+              <a:rPr lang="en-US"/>
               <a:t>Click to edit Master text styles</a:t>
             </a:r>
           </a:p>
@@ -1721,38 +1723,37 @@
           <a:p>
             <a:pPr lvl="0"/>
             <a:r>
-              <a:rPr lang="en-US" smtClean="0"/>
+              <a:rPr lang="en-US"/>
               <a:t>Click to edit Master text styles</a:t>
             </a:r>
           </a:p>
           <a:p>
             <a:pPr lvl="1"/>
             <a:r>
-              <a:rPr lang="en-US" smtClean="0"/>
+              <a:rPr lang="en-US"/>
               <a:t>Second level</a:t>
             </a:r>
           </a:p>
           <a:p>
             <a:pPr lvl="2"/>
             <a:r>
-              <a:rPr lang="en-US" smtClean="0"/>
+              <a:rPr lang="en-US"/>
               <a:t>Third level</a:t>
             </a:r>
           </a:p>
           <a:p>
             <a:pPr lvl="3"/>
             <a:r>
-              <a:rPr lang="en-US" smtClean="0"/>
+              <a:rPr lang="en-US"/>
               <a:t>Fourth level</a:t>
             </a:r>
           </a:p>
           <a:p>
             <a:pPr lvl="4"/>
             <a:r>
-              <a:rPr lang="en-US" smtClean="0"/>
+              <a:rPr lang="en-US"/>
               <a:t>Fifth level</a:t>
             </a:r>
-            <a:endParaRPr lang="en-US"/>
           </a:p>
         </p:txBody>
       </p:sp>
@@ -1773,7 +1774,7 @@
           <a:p>
             <a:fld id="{5BCAD085-E8A6-8845-BD4E-CB4CCA059FC4}" type="datetimeFigureOut">
               <a:rPr lang="en-US" smtClean="0"/>
-              <a:t>1/27/13</a:t>
+              <a:t>5/28/2026</a:t>
             </a:fld>
             <a:endParaRPr lang="en-US"/>
           </a:p>
@@ -1867,10 +1868,9 @@
           <a:lstStyle/>
           <a:p>
             <a:r>
-              <a:rPr lang="en-US" smtClean="0"/>
+              <a:rPr lang="en-US"/>
               <a:t>Click to edit Master title style</a:t>
             </a:r>
-            <a:endParaRPr lang="en-US"/>
           </a:p>
         </p:txBody>
       </p:sp>
@@ -1891,7 +1891,7 @@
           <a:p>
             <a:fld id="{5BCAD085-E8A6-8845-BD4E-CB4CCA059FC4}" type="datetimeFigureOut">
               <a:rPr lang="en-US" smtClean="0"/>
-              <a:t>1/27/13</a:t>
+              <a:t>5/28/2026</a:t>
             </a:fld>
             <a:endParaRPr lang="en-US"/>
           </a:p>
@@ -1986,7 +1986,7 @@
           <a:p>
             <a:fld id="{5BCAD085-E8A6-8845-BD4E-CB4CCA059FC4}" type="datetimeFigureOut">
               <a:rPr lang="en-US" smtClean="0"/>
-              <a:t>1/27/13</a:t>
+              <a:t>5/28/2026</a:t>
             </a:fld>
             <a:endParaRPr lang="en-US"/>
           </a:p>
@@ -2089,10 +2089,9 @@
           </a:lstStyle>
           <a:p>
             <a:r>
-              <a:rPr lang="en-US" smtClean="0"/>
+              <a:rPr lang="en-US"/>
               <a:t>Click to edit Master title style</a:t>
             </a:r>
-            <a:endParaRPr lang="en-US"/>
           </a:p>
         </p:txBody>
       </p:sp>
@@ -2146,38 +2145,37 @@
           <a:p>
             <a:pPr lvl="0"/>
             <a:r>
-              <a:rPr lang="en-US" smtClean="0"/>
+              <a:rPr lang="en-US"/>
               <a:t>Click to edit Master text styles</a:t>
             </a:r>
           </a:p>
           <a:p>
             <a:pPr lvl="1"/>
             <a:r>
-              <a:rPr lang="en-US" smtClean="0"/>
+              <a:rPr lang="en-US"/>
               <a:t>Second level</a:t>
             </a:r>
           </a:p>
           <a:p>
             <a:pPr lvl="2"/>
             <a:r>
-              <a:rPr lang="en-US" smtClean="0"/>
+              <a:rPr lang="en-US"/>
               <a:t>Third level</a:t>
             </a:r>
           </a:p>
           <a:p>
             <a:pPr lvl="3"/>
             <a:r>
-              <a:rPr lang="en-US" smtClean="0"/>
+              <a:rPr lang="en-US"/>
               <a:t>Fourth level</a:t>
             </a:r>
           </a:p>
           <a:p>
             <a:pPr lvl="4"/>
             <a:r>
-              <a:rPr lang="en-US" smtClean="0"/>
+              <a:rPr lang="en-US"/>
               <a:t>Fifth level</a:t>
             </a:r>
-            <a:endParaRPr lang="en-US"/>
           </a:p>
         </p:txBody>
       </p:sp>
@@ -2240,7 +2238,7 @@
           <a:p>
             <a:pPr lvl="0"/>
             <a:r>
-              <a:rPr lang="en-US" smtClean="0"/>
+              <a:rPr lang="en-US"/>
               <a:t>Click to edit Master text styles</a:t>
             </a:r>
           </a:p>
@@ -2263,7 +2261,7 @@
           <a:p>
             <a:fld id="{5BCAD085-E8A6-8845-BD4E-CB4CCA059FC4}" type="datetimeFigureOut">
               <a:rPr lang="en-US" smtClean="0"/>
-              <a:t>1/27/13</a:t>
+              <a:t>5/28/2026</a:t>
             </a:fld>
             <a:endParaRPr lang="en-US"/>
           </a:p>
@@ -2366,10 +2364,9 @@
           </a:lstStyle>
           <a:p>
             <a:r>
-              <a:rPr lang="en-US" smtClean="0"/>
+              <a:rPr lang="en-US"/>
               <a:t>Click to edit Master title style</a:t>
             </a:r>
-            <a:endParaRPr lang="en-US"/>
           </a:p>
         </p:txBody>
       </p:sp>
@@ -2493,7 +2490,7 @@
           <a:p>
             <a:pPr lvl="0"/>
             <a:r>
-              <a:rPr lang="en-US" smtClean="0"/>
+              <a:rPr lang="en-US"/>
               <a:t>Click to edit Master text styles</a:t>
             </a:r>
           </a:p>
@@ -2516,7 +2513,7 @@
           <a:p>
             <a:fld id="{5BCAD085-E8A6-8845-BD4E-CB4CCA059FC4}" type="datetimeFigureOut">
               <a:rPr lang="en-US" smtClean="0"/>
-              <a:t>1/27/13</a:t>
+              <a:t>5/28/2026</a:t>
             </a:fld>
             <a:endParaRPr lang="en-US"/>
           </a:p>
@@ -2625,10 +2622,9 @@
           <a:lstStyle/>
           <a:p>
             <a:r>
-              <a:rPr lang="en-US" smtClean="0"/>
+              <a:rPr lang="en-US"/>
               <a:t>Click to edit Master title style</a:t>
             </a:r>
-            <a:endParaRPr lang="en-US"/>
           </a:p>
         </p:txBody>
       </p:sp>
@@ -2659,38 +2655,37 @@
           <a:p>
             <a:pPr lvl="0"/>
             <a:r>
-              <a:rPr lang="en-US" smtClean="0"/>
+              <a:rPr lang="en-US"/>
               <a:t>Click to edit Master text styles</a:t>
             </a:r>
           </a:p>
           <a:p>
             <a:pPr lvl="1"/>
             <a:r>
-              <a:rPr lang="en-US" smtClean="0"/>
+              <a:rPr lang="en-US"/>
               <a:t>Second level</a:t>
             </a:r>
           </a:p>
           <a:p>
             <a:pPr lvl="2"/>
             <a:r>
-              <a:rPr lang="en-US" smtClean="0"/>
+              <a:rPr lang="en-US"/>
               <a:t>Third level</a:t>
             </a:r>
           </a:p>
           <a:p>
             <a:pPr lvl="3"/>
             <a:r>
-              <a:rPr lang="en-US" smtClean="0"/>
+              <a:rPr lang="en-US"/>
               <a:t>Fourth level</a:t>
             </a:r>
           </a:p>
           <a:p>
             <a:pPr lvl="4"/>
             <a:r>
-              <a:rPr lang="en-US" smtClean="0"/>
+              <a:rPr lang="en-US"/>
               <a:t>Fifth level</a:t>
             </a:r>
-            <a:endParaRPr lang="en-US"/>
           </a:p>
         </p:txBody>
       </p:sp>
@@ -2729,7 +2724,7 @@
           <a:p>
             <a:fld id="{5BCAD085-E8A6-8845-BD4E-CB4CCA059FC4}" type="datetimeFigureOut">
               <a:rPr lang="en-US" smtClean="0"/>
-              <a:t>1/27/13</a:t>
+              <a:t>5/28/2026</a:t>
             </a:fld>
             <a:endParaRPr lang="en-US"/>
           </a:p>
@@ -3088,7 +3083,7 @@
 </file>
 
 <file path=ppt/slides/slide1.xml><?xml version="1.0" encoding="utf-8"?>
-<p:sld xmlns:a="http://schemas.openxmlformats.org/drawingml/2006/main" xmlns:p="http://schemas.openxmlformats.org/presentationml/2006/main" xmlns:r="http://schemas.openxmlformats.org/officeDocument/2006/relationships">
+<p:sld xmlns:a="http://schemas.openxmlformats.org/drawingml/2006/main" xmlns:r="http://schemas.openxmlformats.org/officeDocument/2006/relationships" xmlns:p="http://schemas.openxmlformats.org/presentationml/2006/main">
   <p:cSld>
     <p:bg>
       <p:bgPr>
@@ -3104,7 +3099,14 @@
         <p:cNvGrpSpPr/>
         <p:nvPr/>
       </p:nvGrpSpPr>
-      <p:grpSpPr/>
+      <p:grpSpPr>
+        <a:xfrm>
+          <a:off x="0" y="0"/>
+          <a:ext cx="0" cy="0"/>
+          <a:chOff x="0" y="0"/>
+          <a:chExt cx="0" cy="0"/>
+        </a:xfrm>
+      </p:grpSpPr>
       <p:sp>
         <p:nvSpPr>
           <p:cNvPr id="2" name="TextBox 1"/>
@@ -3114,7 +3116,7 @@
         <p:spPr>
           <a:xfrm>
             <a:off x="914400" y="2011680"/>
-            <a:ext cx="10332720" cy="1828800"/>
+            <a:ext cx="10332720" cy="2787943"/>
           </a:xfrm>
           <a:prstGeom prst="rect">
             <a:avLst/>
@@ -3136,8 +3138,14 @@
               </a:defRPr>
             </a:pPr>
             <a:r>
-              <a:t>RIS Smart Recruitment &amp; Roster System</a:t>
-            </a:r>
+              <a:rPr dirty="0"/>
+              <a:t>RIS </a:t>
+            </a:r>
+            <a:r>
+              <a:rPr lang="en-IN" dirty="0"/>
+              <a:t>Recruitment Portal</a:t>
+            </a:r>
+            <a:endParaRPr dirty="0"/>
           </a:p>
           <a:p>
             <a:pPr>
@@ -3152,6 +3160,7 @@
               </a:defRPr>
             </a:pPr>
             <a:r>
+              <a:rPr dirty="0"/>
               <a:t>Standardizing candidate intake, operational vacancy control, and structured Excel reporting</a:t>
             </a:r>
           </a:p>
@@ -3168,6 +3177,7 @@
               </a:defRPr>
             </a:pPr>
             <a:r>
+              <a:rPr dirty="0"/>
               <a:t>Executive Briefing  •  Solutions &amp; System Walkthrough</a:t>
             </a:r>
           </a:p>
@@ -3182,7 +3192,7 @@
 </file>
 
 <file path=ppt/slides/slide10.xml><?xml version="1.0" encoding="utf-8"?>
-<p:sld xmlns:a="http://schemas.openxmlformats.org/drawingml/2006/main" xmlns:p="http://schemas.openxmlformats.org/presentationml/2006/main" xmlns:r="http://schemas.openxmlformats.org/officeDocument/2006/relationships">
+<p:sld xmlns:a="http://schemas.openxmlformats.org/drawingml/2006/main" xmlns:r="http://schemas.openxmlformats.org/officeDocument/2006/relationships" xmlns:p="http://schemas.openxmlformats.org/presentationml/2006/main">
   <p:cSld>
     <p:bg>
       <p:bgPr>
@@ -3198,7 +3208,14 @@
         <p:cNvGrpSpPr/>
         <p:nvPr/>
       </p:nvGrpSpPr>
-      <p:grpSpPr/>
+      <p:grpSpPr>
+        <a:xfrm>
+          <a:off x="0" y="0"/>
+          <a:ext cx="0" cy="0"/>
+          <a:chOff x="0" y="0"/>
+          <a:chExt cx="0" cy="0"/>
+        </a:xfrm>
+      </p:grpSpPr>
       <p:sp>
         <p:nvSpPr>
           <p:cNvPr id="2" name="TextBox 1"/>
@@ -3207,8 +3224,8 @@
         </p:nvSpPr>
         <p:spPr>
           <a:xfrm>
-            <a:off x="731520" y="457200"/>
-            <a:ext cx="10698480" cy="731520"/>
+            <a:off x="4029356" y="846945"/>
+            <a:ext cx="10698480" cy="538609"/>
           </a:xfrm>
           <a:prstGeom prst="rect">
             <a:avLst/>
@@ -3230,7 +3247,8 @@
               </a:defRPr>
             </a:pPr>
             <a:r>
-              <a:t>Smart Recruitment Portal: Operational Impact</a:t>
+              <a:rPr dirty="0"/>
+              <a:t>Operational Impact</a:t>
             </a:r>
           </a:p>
         </p:txBody>
@@ -3244,7 +3262,7 @@
         <p:spPr>
           <a:xfrm>
             <a:off x="731520" y="1645920"/>
-            <a:ext cx="10698480" cy="4389120"/>
+            <a:ext cx="10698480" cy="2508379"/>
           </a:xfrm>
           <a:prstGeom prst="rect">
             <a:avLst/>
@@ -3256,7 +3274,9 @@
             <a:spAutoFit/>
           </a:bodyPr>
           <a:lstStyle/>
-          <a:p/>
+          <a:p>
+            <a:endParaRPr sz="3200" dirty="0"/>
+          </a:p>
           <a:p>
             <a:pPr>
               <a:spcBef>
@@ -3270,16 +3290,35 @@
               </a:defRPr>
             </a:pPr>
             <a:r>
+              <a:rPr dirty="0"/>
               <a:t>Time Saved in Review: </a:t>
             </a:r>
             <a:r>
-              <a:rPr sz="1500" b="0">
+              <a:rPr b="0" dirty="0">
                 <a:solidFill>
                   <a:srgbClr val="E2E8F0"/>
                 </a:solidFill>
                 <a:latin typeface="Arial"/>
               </a:rPr>
-              <a:t>Managers review candidates directly from the portal, eliminating manual CV tracking and administrative overhead.</a:t>
+              <a:t>Managers </a:t>
+            </a:r>
+            <a:r>
+              <a:rPr lang="en-IN" b="0" dirty="0">
+                <a:solidFill>
+                  <a:srgbClr val="E2E8F0"/>
+                </a:solidFill>
+                <a:latin typeface="Arial"/>
+              </a:rPr>
+              <a:t>can now </a:t>
+            </a:r>
+            <a:r>
+              <a:rPr b="0" dirty="0">
+                <a:solidFill>
+                  <a:srgbClr val="E2E8F0"/>
+                </a:solidFill>
+                <a:latin typeface="Arial"/>
+              </a:rPr>
+              <a:t>review candidates directly from the portal, eliminating manual CV tracking and administrative overhead.</a:t>
             </a:r>
           </a:p>
           <a:p>
@@ -3295,10 +3334,11 @@
               </a:defRPr>
             </a:pPr>
             <a:r>
+              <a:rPr dirty="0"/>
               <a:t>Standardized Candidate Data: </a:t>
             </a:r>
             <a:r>
-              <a:rPr sz="1500" b="0">
+              <a:rPr b="0" dirty="0">
                 <a:solidFill>
                   <a:srgbClr val="E2E8F0"/>
                 </a:solidFill>
@@ -3320,42 +3360,51 @@
               </a:defRPr>
             </a:pPr>
             <a:r>
+              <a:rPr dirty="0"/>
               <a:t>Advanced Roster Exports: </a:t>
             </a:r>
             <a:r>
-              <a:rPr sz="1500" b="0">
+              <a:rPr b="0" dirty="0">
                 <a:solidFill>
                   <a:srgbClr val="E2E8F0"/>
                 </a:solidFill>
                 <a:latin typeface="Arial"/>
               </a:rPr>
-              <a:t>Generates presentation-ready spreadsheets with grouped stacked layouts, visual border dividers, and clean academic score normalization.</a:t>
-            </a:r>
-          </a:p>
-          <a:p>
-            <a:pPr>
-              <a:spcBef>
-                <a:spcPts val="1800"/>
-              </a:spcBef>
-              <a:defRPr sz="1600" b="1">
-                <a:solidFill>
-                  <a:srgbClr val="C2CDDB"/>
-                </a:solidFill>
-                <a:latin typeface="Arial"/>
-              </a:defRPr>
-            </a:pPr>
-            <a:r>
-              <a:t>Board Room Ready: </a:t>
-            </a:r>
-            <a:r>
-              <a:rPr sz="1500" b="0">
+              <a:t>Generates presentation-ready spreadsheets with </a:t>
+            </a:r>
+            <a:r>
+              <a:rPr lang="en-IN" b="0" dirty="0">
                 <a:solidFill>
                   <a:srgbClr val="E2E8F0"/>
                 </a:solidFill>
                 <a:latin typeface="Arial"/>
               </a:rPr>
-              <a:t>Roster filters, dossier popups, and standardized exports are structured to be shared directly with senior board members and stakeholders.</a:t>
-            </a:r>
+              <a:t>organized </a:t>
+            </a:r>
+            <a:r>
+              <a:rPr b="0" dirty="0">
+                <a:solidFill>
+                  <a:srgbClr val="E2E8F0"/>
+                </a:solidFill>
+                <a:latin typeface="Arial"/>
+              </a:rPr>
+              <a:t>layouts</a:t>
+            </a:r>
+            <a:r>
+              <a:rPr lang="en-IN" b="0" dirty="0">
+                <a:solidFill>
+                  <a:srgbClr val="E2E8F0"/>
+                </a:solidFill>
+                <a:latin typeface="Arial"/>
+              </a:rPr>
+              <a:t>.</a:t>
+            </a:r>
+            <a:endParaRPr b="0" dirty="0">
+              <a:solidFill>
+                <a:srgbClr val="E2E8F0"/>
+              </a:solidFill>
+              <a:latin typeface="Arial"/>
+            </a:endParaRPr>
           </a:p>
         </p:txBody>
       </p:sp>
@@ -3368,7 +3417,7 @@
 </file>
 
 <file path=ppt/slides/slide2.xml><?xml version="1.0" encoding="utf-8"?>
-<p:sld xmlns:a="http://schemas.openxmlformats.org/drawingml/2006/main" xmlns:p="http://schemas.openxmlformats.org/presentationml/2006/main" xmlns:r="http://schemas.openxmlformats.org/officeDocument/2006/relationships">
+<p:sld xmlns:a="http://schemas.openxmlformats.org/drawingml/2006/main" xmlns:r="http://schemas.openxmlformats.org/officeDocument/2006/relationships" xmlns:p="http://schemas.openxmlformats.org/presentationml/2006/main">
   <p:cSld>
     <p:bg>
       <p:bgPr>
@@ -3384,7 +3433,63 @@
         <p:cNvGrpSpPr/>
         <p:nvPr/>
       </p:nvGrpSpPr>
-      <p:grpSpPr/>
+      <p:grpSpPr>
+        <a:xfrm>
+          <a:off x="0" y="0"/>
+          <a:ext cx="0" cy="0"/>
+          <a:chOff x="0" y="0"/>
+          <a:chExt cx="0" cy="0"/>
+        </a:xfrm>
+      </p:grpSpPr>
+      <p:sp>
+        <p:nvSpPr>
+          <p:cNvPr id="5" name="Rectangle 4">
+            <a:extLst>
+              <a:ext uri="{FF2B5EF4-FFF2-40B4-BE49-F238E27FC236}">
+                <a16:creationId xmlns:a16="http://schemas.microsoft.com/office/drawing/2014/main" id="{0AC65899-7CCF-5FA9-BBCA-1C4F814943F3}"/>
+              </a:ext>
+            </a:extLst>
+          </p:cNvPr>
+          <p:cNvSpPr/>
+          <p:nvPr/>
+        </p:nvSpPr>
+        <p:spPr>
+          <a:xfrm>
+            <a:off x="0" y="0"/>
+            <a:ext cx="13835921" cy="1188720"/>
+          </a:xfrm>
+          <a:prstGeom prst="rect">
+            <a:avLst/>
+          </a:prstGeom>
+          <a:solidFill>
+            <a:schemeClr val="tx2">
+              <a:lumMod val="50000"/>
+            </a:schemeClr>
+          </a:solidFill>
+        </p:spPr>
+        <p:style>
+          <a:lnRef idx="1">
+            <a:schemeClr val="accent1"/>
+          </a:lnRef>
+          <a:fillRef idx="3">
+            <a:schemeClr val="accent1"/>
+          </a:fillRef>
+          <a:effectRef idx="2">
+            <a:schemeClr val="accent1"/>
+          </a:effectRef>
+          <a:fontRef idx="minor">
+            <a:schemeClr val="lt1"/>
+          </a:fontRef>
+        </p:style>
+        <p:txBody>
+          <a:bodyPr rtlCol="0" anchor="ctr"/>
+          <a:lstStyle/>
+          <a:p>
+            <a:pPr algn="ctr"/>
+            <a:endParaRPr lang="en-IN"/>
+          </a:p>
+        </p:txBody>
+      </p:sp>
       <p:sp>
         <p:nvSpPr>
           <p:cNvPr id="2" name="TextBox 1"/>
@@ -3394,7 +3499,7 @@
         <p:spPr>
           <a:xfrm>
             <a:off x="731520" y="457200"/>
-            <a:ext cx="10698480" cy="731520"/>
+            <a:ext cx="10698480" cy="538609"/>
           </a:xfrm>
           <a:prstGeom prst="rect">
             <a:avLst/>
@@ -3416,6 +3521,11 @@
               </a:defRPr>
             </a:pPr>
             <a:r>
+              <a:rPr dirty="0">
+                <a:solidFill>
+                  <a:schemeClr val="bg1"/>
+                </a:solidFill>
+              </a:rPr>
               <a:t>The Legacy Challenge: The Data &amp; Roster Bottleneck</a:t>
             </a:r>
           </a:p>
@@ -3430,7 +3540,7 @@
         <p:spPr>
           <a:xfrm>
             <a:off x="731520" y="1645920"/>
-            <a:ext cx="5120640" cy="4389120"/>
+            <a:ext cx="5120640" cy="3721532"/>
           </a:xfrm>
           <a:prstGeom prst="rect">
             <a:avLst/>
@@ -3452,6 +3562,7 @@
               </a:defRPr>
             </a:pPr>
             <a:r>
+              <a:rPr sz="1600" dirty="0"/>
               <a:t>THE RECRUITMENT BOTTLENECK</a:t>
             </a:r>
           </a:p>
@@ -3471,6 +3582,7 @@
               </a:defRPr>
             </a:pPr>
             <a:r>
+              <a:rPr sz="2800" dirty="0"/>
               <a:t>Data Scrawl &amp; Manual Review</a:t>
             </a:r>
           </a:p>
@@ -3487,6 +3599,7 @@
               </a:defRPr>
             </a:pPr>
             <a:r>
+              <a:rPr sz="1600" dirty="0"/>
               <a:t>• Multiple degrees and research works clumped into single cells with commas, blocking automated analysis.</a:t>
             </a:r>
           </a:p>
@@ -3503,6 +3616,7 @@
               </a:defRPr>
             </a:pPr>
             <a:r>
+              <a:rPr sz="1600" dirty="0"/>
               <a:t>• Spreadsheets stretching infinitely to the right with redundant columns, causing horizontal scrolling fatigue.</a:t>
             </a:r>
           </a:p>
@@ -3519,22 +3633,7 @@
               </a:defRPr>
             </a:pPr>
             <a:r>
-              <a:t>• Inconsistent score formats (CGPAs vs. percentages) making comparison difficult.</a:t>
-            </a:r>
-          </a:p>
-          <a:p>
-            <a:pPr>
-              <a:spcAft>
-                <a:spcPts val="1000"/>
-              </a:spcAft>
-              <a:defRPr sz="1400">
-                <a:solidFill>
-                  <a:srgbClr val="1E293B"/>
-                </a:solidFill>
-                <a:latin typeface="Arial"/>
-              </a:defRPr>
-            </a:pPr>
-            <a:r>
+              <a:rPr sz="1600" dirty="0"/>
               <a:t>• Manual resume downloads and alignment causing long hiring delays.</a:t>
             </a:r>
           </a:p>
@@ -3548,8 +3647,8 @@
         </p:nvSpPr>
         <p:spPr>
           <a:xfrm>
-            <a:off x="6217920" y="1645920"/>
-            <a:ext cx="5120640" cy="4389120"/>
+            <a:off x="6217919" y="1645920"/>
+            <a:ext cx="5384467" cy="3475310"/>
           </a:xfrm>
           <a:prstGeom prst="rect">
             <a:avLst/>
@@ -3571,6 +3670,7 @@
               </a:defRPr>
             </a:pPr>
             <a:r>
+              <a:rPr sz="1600" dirty="0"/>
               <a:t>THE INTEGRATED PORTAL APPROACH</a:t>
             </a:r>
           </a:p>
@@ -3590,6 +3690,7 @@
               </a:defRPr>
             </a:pPr>
             <a:r>
+              <a:rPr sz="2800" dirty="0"/>
               <a:t>Structured Intake to Clean Output</a:t>
             </a:r>
           </a:p>
@@ -3606,8 +3707,14 @@
               </a:defRPr>
             </a:pPr>
             <a:r>
+              <a:rPr sz="1600" dirty="0"/>
               <a:t>• Standardized Intake: Candidates input individual degrees, scores, and timelines dynamically at source.</a:t>
             </a:r>
+            <a:r>
+              <a:rPr lang="en-IN" sz="1600" dirty="0"/>
+              <a:t> Uses a custom-made database for the backend.</a:t>
+            </a:r>
+            <a:endParaRPr sz="1600" dirty="0"/>
           </a:p>
           <a:p>
             <a:pPr>
@@ -3622,6 +3729,7 @@
               </a:defRPr>
             </a:pPr>
             <a:r>
+              <a:rPr sz="1600" dirty="0"/>
               <a:t>• HR Control Centers: Instantly filter active roles, review metrics, and open dossier profile views.</a:t>
             </a:r>
           </a:p>
@@ -3638,24 +3746,14 @@
               </a:defRPr>
             </a:pPr>
             <a:r>
-              <a:t>• Stacked Roster Layouts: Candidate details are stacked vertically with merged basic details.</a:t>
-            </a:r>
-          </a:p>
-          <a:p>
-            <a:pPr>
-              <a:spcAft>
-                <a:spcPts val="1000"/>
-              </a:spcAft>
-              <a:defRPr sz="1400">
-                <a:solidFill>
-                  <a:srgbClr val="1E293B"/>
-                </a:solidFill>
-                <a:latin typeface="Arial"/>
-              </a:defRPr>
-            </a:pPr>
-            <a:r>
-              <a:t>• Score Normalization: Auto-formats scores to clean percentages ('79%') or CGPA ('8 CGPA') on download.</a:t>
-            </a:r>
+              <a:rPr sz="1600" dirty="0"/>
+              <a:t>• Candidate details are </a:t>
+            </a:r>
+            <a:r>
+              <a:rPr lang="en-IN" sz="1600" dirty="0"/>
+              <a:t>now properly displayed in spreadsheets, making filtration and screening easier.</a:t>
+            </a:r>
+            <a:endParaRPr sz="1600" dirty="0"/>
           </a:p>
         </p:txBody>
       </p:sp>
@@ -3668,7 +3766,7 @@
 </file>
 
 <file path=ppt/slides/slide3.xml><?xml version="1.0" encoding="utf-8"?>
-<p:sld xmlns:a="http://schemas.openxmlformats.org/drawingml/2006/main" xmlns:p="http://schemas.openxmlformats.org/presentationml/2006/main" xmlns:r="http://schemas.openxmlformats.org/officeDocument/2006/relationships">
+<p:sld xmlns:a="http://schemas.openxmlformats.org/drawingml/2006/main" xmlns:r="http://schemas.openxmlformats.org/officeDocument/2006/relationships" xmlns:p="http://schemas.openxmlformats.org/presentationml/2006/main">
   <p:cSld>
     <p:bg>
       <p:bgPr>
@@ -3684,7 +3782,14 @@
         <p:cNvGrpSpPr/>
         <p:nvPr/>
       </p:nvGrpSpPr>
-      <p:grpSpPr/>
+      <p:grpSpPr>
+        <a:xfrm>
+          <a:off x="0" y="0"/>
+          <a:ext cx="0" cy="0"/>
+          <a:chOff x="0" y="0"/>
+          <a:chExt cx="0" cy="0"/>
+        </a:xfrm>
+      </p:grpSpPr>
       <p:sp>
         <p:nvSpPr>
           <p:cNvPr id="2" name="TextBox 1"/>
@@ -3729,8 +3834,8 @@
         </p:nvSpPr>
         <p:spPr>
           <a:xfrm>
-            <a:off x="731520" y="1371600"/>
-            <a:ext cx="4937760" cy="4572000"/>
+            <a:off x="521658" y="2513364"/>
+            <a:ext cx="4937760" cy="1831271"/>
           </a:xfrm>
           <a:prstGeom prst="rect">
             <a:avLst/>
@@ -3747,7 +3852,7 @@
               <a:spcAft>
                 <a:spcPts val="1200"/>
               </a:spcAft>
-              <a:defRPr b="1" sz="1400">
+              <a:defRPr sz="1400" b="1">
                 <a:solidFill>
                   <a:srgbClr val="0F172A"/>
                 </a:solidFill>
@@ -3755,10 +3860,11 @@
               </a:defRPr>
             </a:pPr>
             <a:r>
-              <a:t>• Explore Opportunities: </a:t>
-            </a:r>
-            <a:r>
-              <a:rPr b="0" sz="1300">
+              <a:rPr lang="en-IN" dirty="0"/>
+              <a:t>• </a:t>
+            </a:r>
+            <a:r>
+              <a:rPr sz="1600" b="0" dirty="0">
                 <a:solidFill>
                   <a:srgbClr val="1E293B"/>
                 </a:solidFill>
@@ -3772,7 +3878,7 @@
               <a:spcAft>
                 <a:spcPts val="1200"/>
               </a:spcAft>
-              <a:defRPr b="1" sz="1400">
+              <a:defRPr sz="1400" b="1">
                 <a:solidFill>
                   <a:srgbClr val="0F172A"/>
                 </a:solidFill>
@@ -3780,16 +3886,17 @@
               </a:defRPr>
             </a:pPr>
             <a:r>
-              <a:t>• Transparent Information: </a:t>
-            </a:r>
-            <a:r>
-              <a:rPr b="0" sz="1300">
+              <a:rPr dirty="0"/>
+              <a:t>• </a:t>
+            </a:r>
+            <a:r>
+              <a:rPr sz="1600" b="0" dirty="0">
                 <a:solidFill>
                   <a:srgbClr val="1E293B"/>
                 </a:solidFill>
                 <a:latin typeface="Arial"/>
               </a:rPr>
-              <a:t>Displays role titles, division tags (e.g. CMEC, DAKSHIN), locations, and submission deadlines.</a:t>
+              <a:t>Provides concise public descriptions to inform prospective applicants prior to starting an application.</a:t>
             </a:r>
           </a:p>
           <a:p>
@@ -3797,7 +3904,7 @@
               <a:spcAft>
                 <a:spcPts val="1200"/>
               </a:spcAft>
-              <a:defRPr b="1" sz="1400">
+              <a:defRPr sz="1400" b="1">
                 <a:solidFill>
                   <a:srgbClr val="0F172A"/>
                 </a:solidFill>
@@ -3805,35 +3912,11 @@
               </a:defRPr>
             </a:pPr>
             <a:r>
-              <a:t>• Clear Scope: </a:t>
-            </a:r>
-            <a:r>
-              <a:rPr b="0" sz="1300">
-                <a:solidFill>
-                  <a:srgbClr val="1E293B"/>
-                </a:solidFill>
-                <a:latin typeface="Arial"/>
-              </a:rPr>
-              <a:t>Provides concise public descriptions to inform prospective applicants prior to starting an application.</a:t>
-            </a:r>
-          </a:p>
-          <a:p>
-            <a:pPr>
-              <a:spcAft>
-                <a:spcPts val="1200"/>
-              </a:spcAft>
-              <a:defRPr b="1" sz="1400">
-                <a:solidFill>
-                  <a:srgbClr val="0F172A"/>
-                </a:solidFill>
-                <a:latin typeface="Arial"/>
-              </a:defRPr>
-            </a:pPr>
-            <a:r>
-              <a:t>• Frictionless Flow: </a:t>
-            </a:r>
-            <a:r>
-              <a:rPr b="0" sz="1300">
+              <a:rPr dirty="0"/>
+              <a:t>• </a:t>
+            </a:r>
+            <a:r>
+              <a:rPr sz="1600" b="0" dirty="0">
                 <a:solidFill>
                   <a:srgbClr val="1E293B"/>
                 </a:solidFill>
@@ -3854,14 +3937,15 @@
         </p:nvPicPr>
         <p:blipFill>
           <a:blip r:embed="rId2"/>
+          <a:srcRect l="2779" r="3415"/>
           <a:stretch>
             <a:fillRect/>
           </a:stretch>
         </p:blipFill>
         <p:spPr>
           <a:xfrm>
-            <a:off x="5943600" y="1371600"/>
-            <a:ext cx="5486400" cy="4389120"/>
+            <a:off x="5437499" y="1319135"/>
+            <a:ext cx="6644573" cy="3851273"/>
           </a:xfrm>
           <a:prstGeom prst="rect">
             <a:avLst/>
@@ -3877,7 +3961,7 @@
 </file>
 
 <file path=ppt/slides/slide4.xml><?xml version="1.0" encoding="utf-8"?>
-<p:sld xmlns:a="http://schemas.openxmlformats.org/drawingml/2006/main" xmlns:p="http://schemas.openxmlformats.org/presentationml/2006/main" xmlns:r="http://schemas.openxmlformats.org/officeDocument/2006/relationships">
+<p:sld xmlns:a="http://schemas.openxmlformats.org/drawingml/2006/main" xmlns:r="http://schemas.openxmlformats.org/officeDocument/2006/relationships" xmlns:p="http://schemas.openxmlformats.org/presentationml/2006/main">
   <p:cSld>
     <p:bg>
       <p:bgPr>
@@ -3893,7 +3977,14 @@
         <p:cNvGrpSpPr/>
         <p:nvPr/>
       </p:nvGrpSpPr>
-      <p:grpSpPr/>
+      <p:grpSpPr>
+        <a:xfrm>
+          <a:off x="0" y="0"/>
+          <a:ext cx="0" cy="0"/>
+          <a:chOff x="0" y="0"/>
+          <a:chExt cx="0" cy="0"/>
+        </a:xfrm>
+      </p:grpSpPr>
       <p:sp>
         <p:nvSpPr>
           <p:cNvPr id="2" name="TextBox 1"/>
@@ -3938,8 +4029,8 @@
         </p:nvSpPr>
         <p:spPr>
           <a:xfrm>
-            <a:off x="731520" y="1371600"/>
-            <a:ext cx="4937760" cy="4572000"/>
+            <a:off x="566628" y="1371600"/>
+            <a:ext cx="4937760" cy="2477601"/>
           </a:xfrm>
           <a:prstGeom prst="rect">
             <a:avLst/>
@@ -3956,7 +4047,7 @@
               <a:spcAft>
                 <a:spcPts val="1200"/>
               </a:spcAft>
-              <a:defRPr b="1" sz="1400">
+              <a:defRPr sz="1400" b="1">
                 <a:solidFill>
                   <a:srgbClr val="0F172A"/>
                 </a:solidFill>
@@ -3964,10 +4055,11 @@
               </a:defRPr>
             </a:pPr>
             <a:r>
-              <a:t>• Real-Time Tracking: </a:t>
-            </a:r>
-            <a:r>
-              <a:rPr b="0" sz="1300">
+              <a:rPr dirty="0"/>
+              <a:t>• </a:t>
+            </a:r>
+            <a:r>
+              <a:rPr sz="1600" b="0" dirty="0">
                 <a:solidFill>
                   <a:srgbClr val="1E293B"/>
                 </a:solidFill>
@@ -3981,7 +4073,7 @@
               <a:spcAft>
                 <a:spcPts val="1200"/>
               </a:spcAft>
-              <a:defRPr b="1" sz="1400">
+              <a:defRPr sz="1400" b="1">
                 <a:solidFill>
                   <a:srgbClr val="0F172A"/>
                 </a:solidFill>
@@ -3989,10 +4081,11 @@
               </a:defRPr>
             </a:pPr>
             <a:r>
-              <a:t>• Dashboard Statistics: </a:t>
-            </a:r>
-            <a:r>
-              <a:rPr b="0" sz="1300">
+              <a:rPr dirty="0"/>
+              <a:t>• </a:t>
+            </a:r>
+            <a:r>
+              <a:rPr sz="1600" b="0" dirty="0">
                 <a:solidFill>
                   <a:srgbClr val="1E293B"/>
                 </a:solidFill>
@@ -4006,7 +4099,7 @@
               <a:spcAft>
                 <a:spcPts val="1200"/>
               </a:spcAft>
-              <a:defRPr b="1" sz="1400">
+              <a:defRPr sz="1400" b="1">
                 <a:solidFill>
                   <a:srgbClr val="0F172A"/>
                 </a:solidFill>
@@ -4014,10 +4107,11 @@
               </a:defRPr>
             </a:pPr>
             <a:r>
-              <a:t>• Status Columns: </a:t>
-            </a:r>
-            <a:r>
-              <a:rPr b="0" sz="1300">
+              <a:rPr dirty="0"/>
+              <a:t>• </a:t>
+            </a:r>
+            <a:r>
+              <a:rPr sz="1600" b="0" dirty="0">
                 <a:solidFill>
                   <a:srgbClr val="1E293B"/>
                 </a:solidFill>
@@ -4031,7 +4125,7 @@
               <a:spcAft>
                 <a:spcPts val="1200"/>
               </a:spcAft>
-              <a:defRPr b="1" sz="1400">
+              <a:defRPr sz="1400" b="1">
                 <a:solidFill>
                   <a:srgbClr val="0F172A"/>
                 </a:solidFill>
@@ -4039,10 +4133,11 @@
               </a:defRPr>
             </a:pPr>
             <a:r>
-              <a:t>• Direct Operations: </a:t>
-            </a:r>
-            <a:r>
-              <a:rPr b="0" sz="1300">
+              <a:rPr dirty="0"/>
+              <a:t>• </a:t>
+            </a:r>
+            <a:r>
+              <a:rPr sz="1600" b="0" dirty="0">
                 <a:solidFill>
                   <a:srgbClr val="1E293B"/>
                 </a:solidFill>
@@ -4069,8 +4164,8 @@
         </p:blipFill>
         <p:spPr>
           <a:xfrm>
-            <a:off x="5943600" y="1371600"/>
-            <a:ext cx="5486400" cy="4389120"/>
+            <a:off x="5648692" y="1188720"/>
+            <a:ext cx="6253498" cy="3877955"/>
           </a:xfrm>
           <a:prstGeom prst="rect">
             <a:avLst/>
@@ -4086,7 +4181,7 @@
 </file>
 
 <file path=ppt/slides/slide5.xml><?xml version="1.0" encoding="utf-8"?>
-<p:sld xmlns:a="http://schemas.openxmlformats.org/drawingml/2006/main" xmlns:p="http://schemas.openxmlformats.org/presentationml/2006/main" xmlns:r="http://schemas.openxmlformats.org/officeDocument/2006/relationships">
+<p:sld xmlns:a="http://schemas.openxmlformats.org/drawingml/2006/main" xmlns:r="http://schemas.openxmlformats.org/officeDocument/2006/relationships" xmlns:p="http://schemas.openxmlformats.org/presentationml/2006/main">
   <p:cSld>
     <p:bg>
       <p:bgPr>
@@ -4102,7 +4197,14 @@
         <p:cNvGrpSpPr/>
         <p:nvPr/>
       </p:nvGrpSpPr>
-      <p:grpSpPr/>
+      <p:grpSpPr>
+        <a:xfrm>
+          <a:off x="0" y="0"/>
+          <a:ext cx="0" cy="0"/>
+          <a:chOff x="0" y="0"/>
+          <a:chExt cx="0" cy="0"/>
+        </a:xfrm>
+      </p:grpSpPr>
       <p:sp>
         <p:nvSpPr>
           <p:cNvPr id="2" name="TextBox 1"/>
@@ -4112,7 +4214,7 @@
         <p:spPr>
           <a:xfrm>
             <a:off x="731520" y="457200"/>
-            <a:ext cx="10698480" cy="731520"/>
+            <a:ext cx="10698480" cy="538609"/>
           </a:xfrm>
           <a:prstGeom prst="rect">
             <a:avLst/>
@@ -4134,131 +4236,14 @@
               </a:defRPr>
             </a:pPr>
             <a:r>
-              <a:t>HR Operations: Standardized Vacancy Control</a:t>
-            </a:r>
-          </a:p>
-        </p:txBody>
-      </p:sp>
-      <p:sp>
-        <p:nvSpPr>
-          <p:cNvPr id="3" name="TextBox 2"/>
-          <p:cNvSpPr txBox="1"/>
-          <p:nvPr/>
-        </p:nvSpPr>
-        <p:spPr>
-          <a:xfrm>
-            <a:off x="731520" y="1371600"/>
-            <a:ext cx="4937760" cy="4572000"/>
-          </a:xfrm>
-          <a:prstGeom prst="rect">
-            <a:avLst/>
-          </a:prstGeom>
-          <a:noFill/>
-        </p:spPr>
-        <p:txBody>
-          <a:bodyPr wrap="square" lIns="0" tIns="0">
-            <a:spAutoFit/>
-          </a:bodyPr>
-          <a:lstStyle/>
-          <a:p>
-            <a:pPr>
-              <a:spcAft>
-                <a:spcPts val="1200"/>
-              </a:spcAft>
-              <a:defRPr b="1" sz="1400">
-                <a:solidFill>
-                  <a:srgbClr val="0F172A"/>
-                </a:solidFill>
-                <a:latin typeface="Arial"/>
-              </a:defRPr>
-            </a:pPr>
-            <a:r>
-              <a:t>• Structured Input Forms: </a:t>
-            </a:r>
-            <a:r>
-              <a:rPr b="0" sz="1300">
-                <a:solidFill>
-                  <a:srgbClr val="1E293B"/>
-                </a:solidFill>
-                <a:latin typeface="Arial"/>
-              </a:rPr>
-              <a:t>Clean job creation modal with simplified fields to prevent layout clutter.</a:t>
-            </a:r>
-          </a:p>
-          <a:p>
-            <a:pPr>
-              <a:spcAft>
-                <a:spcPts val="1200"/>
-              </a:spcAft>
-              <a:defRPr b="1" sz="1400">
-                <a:solidFill>
-                  <a:srgbClr val="0F172A"/>
-                </a:solidFill>
-                <a:latin typeface="Arial"/>
-              </a:defRPr>
-            </a:pPr>
-            <a:r>
-              <a:t>• Compensation Settings: </a:t>
-            </a:r>
-            <a:r>
-              <a:rPr b="0" sz="1300">
-                <a:solidFill>
-                  <a:srgbClr val="1E293B"/>
-                </a:solidFill>
-                <a:latin typeface="Arial"/>
-              </a:rPr>
-              <a:t>Dedicated contract and compensation settings panel to manage role boundaries.</a:t>
-            </a:r>
-          </a:p>
-          <a:p>
-            <a:pPr>
-              <a:spcAft>
-                <a:spcPts val="1200"/>
-              </a:spcAft>
-              <a:defRPr b="1" sz="1400">
-                <a:solidFill>
-                  <a:srgbClr val="0F172A"/>
-                </a:solidFill>
-                <a:latin typeface="Arial"/>
-              </a:defRPr>
-            </a:pPr>
-            <a:r>
-              <a:t>• Predefined Pay Bands: </a:t>
-            </a:r>
-            <a:r>
-              <a:rPr b="0" sz="1300">
-                <a:solidFill>
-                  <a:srgbClr val="1E293B"/>
-                </a:solidFill>
-                <a:latin typeface="Arial"/>
-              </a:rPr>
-              <a:t>Set minimum and maximum pay expectations directly via dropdown selectors.</a:t>
-            </a:r>
-          </a:p>
-          <a:p>
-            <a:pPr>
-              <a:spcAft>
-                <a:spcPts val="1200"/>
-              </a:spcAft>
-              <a:defRPr b="1" sz="1400">
-                <a:solidFill>
-                  <a:srgbClr val="0F172A"/>
-                </a:solidFill>
-                <a:latin typeface="Arial"/>
-              </a:defRPr>
-            </a:pPr>
-            <a:r>
-              <a:t>• Experience Requirements: </a:t>
-            </a:r>
-            <a:r>
-              <a:rPr b="0" sz="1300">
-                <a:solidFill>
-                  <a:srgbClr val="1E293B"/>
-                </a:solidFill>
-                <a:latin typeface="Arial"/>
-              </a:rPr>
-              <a:t>Enforce minimum and maximum experience levels required, and set contract durations.</a:t>
-            </a:r>
+              <a:rPr dirty="0"/>
+              <a:t>HR Operations: </a:t>
+            </a:r>
+            <a:r>
+              <a:rPr lang="en-IN" dirty="0"/>
+              <a:t>Easy Job Posting Creation</a:t>
+            </a:r>
+            <a:endParaRPr dirty="0"/>
           </a:p>
         </p:txBody>
       </p:sp>
@@ -4272,14 +4257,45 @@
         </p:nvPicPr>
         <p:blipFill>
           <a:blip r:embed="rId2"/>
+          <a:srcRect l="11396" r="13975"/>
           <a:stretch>
             <a:fillRect/>
           </a:stretch>
         </p:blipFill>
         <p:spPr>
           <a:xfrm>
-            <a:off x="5943600" y="1371600"/>
-            <a:ext cx="5486400" cy="4389120"/>
+            <a:off x="6392881" y="1252605"/>
+            <a:ext cx="5037119" cy="5148195"/>
+          </a:xfrm>
+          <a:prstGeom prst="rect">
+            <a:avLst/>
+          </a:prstGeom>
+        </p:spPr>
+      </p:pic>
+      <p:pic>
+        <p:nvPicPr>
+          <p:cNvPr id="6" name="Picture 5">
+            <a:extLst>
+              <a:ext uri="{FF2B5EF4-FFF2-40B4-BE49-F238E27FC236}">
+                <a16:creationId xmlns:a16="http://schemas.microsoft.com/office/drawing/2014/main" id="{552EABBE-7FE5-A9B2-5D00-F69E4BE3CC09}"/>
+              </a:ext>
+            </a:extLst>
+          </p:cNvPr>
+          <p:cNvPicPr>
+            <a:picLocks noChangeAspect="1"/>
+          </p:cNvPicPr>
+          <p:nvPr/>
+        </p:nvPicPr>
+        <p:blipFill>
+          <a:blip r:embed="rId3"/>
+          <a:stretch>
+            <a:fillRect/>
+          </a:stretch>
+        </p:blipFill>
+        <p:spPr>
+          <a:xfrm>
+            <a:off x="395738" y="1371600"/>
+            <a:ext cx="5685022" cy="4772404"/>
           </a:xfrm>
           <a:prstGeom prst="rect">
             <a:avLst/>
@@ -4295,7 +4311,7 @@
 </file>
 
 <file path=ppt/slides/slide6.xml><?xml version="1.0" encoding="utf-8"?>
-<p:sld xmlns:a="http://schemas.openxmlformats.org/drawingml/2006/main" xmlns:p="http://schemas.openxmlformats.org/presentationml/2006/main" xmlns:r="http://schemas.openxmlformats.org/officeDocument/2006/relationships">
+<p:sld xmlns:a="http://schemas.openxmlformats.org/drawingml/2006/main" xmlns:r="http://schemas.openxmlformats.org/officeDocument/2006/relationships" xmlns:p="http://schemas.openxmlformats.org/presentationml/2006/main">
   <p:cSld>
     <p:bg>
       <p:bgPr>
@@ -4311,7 +4327,14 @@
         <p:cNvGrpSpPr/>
         <p:nvPr/>
       </p:nvGrpSpPr>
-      <p:grpSpPr/>
+      <p:grpSpPr>
+        <a:xfrm>
+          <a:off x="0" y="0"/>
+          <a:ext cx="0" cy="0"/>
+          <a:chOff x="0" y="0"/>
+          <a:chExt cx="0" cy="0"/>
+        </a:xfrm>
+      </p:grpSpPr>
       <p:sp>
         <p:nvSpPr>
           <p:cNvPr id="2" name="TextBox 1"/>
@@ -4321,7 +4344,7 @@
         <p:spPr>
           <a:xfrm>
             <a:off x="731520" y="457200"/>
-            <a:ext cx="10698480" cy="731520"/>
+            <a:ext cx="10698480" cy="538609"/>
           </a:xfrm>
           <a:prstGeom prst="rect">
             <a:avLst/>
@@ -4343,7 +4366,16 @@
               </a:defRPr>
             </a:pPr>
             <a:r>
-              <a:t>HR Dashboard: System Talent Analytics</a:t>
+              <a:rPr dirty="0"/>
+              <a:t>HR Dashboard: </a:t>
+            </a:r>
+            <a:r>
+              <a:rPr lang="en-IN" dirty="0"/>
+              <a:t>Global </a:t>
+            </a:r>
+            <a:r>
+              <a:rPr dirty="0"/>
+              <a:t>Analytics</a:t>
             </a:r>
           </a:p>
         </p:txBody>
@@ -4357,7 +4389,7 @@
         <p:spPr>
           <a:xfrm>
             <a:off x="731520" y="1371600"/>
-            <a:ext cx="4937760" cy="4572000"/>
+            <a:ext cx="4937760" cy="1985159"/>
           </a:xfrm>
           <a:prstGeom prst="rect">
             <a:avLst/>
@@ -4374,7 +4406,7 @@
               <a:spcAft>
                 <a:spcPts val="1200"/>
               </a:spcAft>
-              <a:defRPr b="1" sz="1400">
+              <a:defRPr sz="1400" b="1">
                 <a:solidFill>
                   <a:srgbClr val="0F172A"/>
                 </a:solidFill>
@@ -4382,10 +4414,11 @@
               </a:defRPr>
             </a:pPr>
             <a:r>
-              <a:t>• Operational Metrics: </a:t>
-            </a:r>
-            <a:r>
-              <a:rPr b="0" sz="1300">
+              <a:rPr sz="1600" dirty="0"/>
+              <a:t>• </a:t>
+            </a:r>
+            <a:r>
+              <a:rPr b="0" dirty="0">
                 <a:solidFill>
                   <a:srgbClr val="1E293B"/>
                 </a:solidFill>
@@ -4393,13 +4426,19 @@
               </a:rPr>
               <a:t>Presents visual candidate demographics across the system automatically.</a:t>
             </a:r>
+            <a:endParaRPr lang="en-IN" b="0" dirty="0">
+              <a:solidFill>
+                <a:srgbClr val="1E293B"/>
+              </a:solidFill>
+              <a:latin typeface="Arial"/>
+            </a:endParaRPr>
           </a:p>
           <a:p>
             <a:pPr>
               <a:spcAft>
                 <a:spcPts val="1200"/>
               </a:spcAft>
-              <a:defRPr b="1" sz="1400">
+              <a:defRPr sz="1400" b="1">
                 <a:solidFill>
                   <a:srgbClr val="0F172A"/>
                 </a:solidFill>
@@ -4407,16 +4446,17 @@
               </a:defRPr>
             </a:pPr>
             <a:r>
-              <a:t>• Gender Diversity: </a:t>
-            </a:r>
-            <a:r>
-              <a:rPr b="0" sz="1300">
+              <a:rPr lang="en-US" sz="1600" dirty="0"/>
+              <a:t>• </a:t>
+            </a:r>
+            <a:r>
+              <a:rPr lang="en-US" b="0" dirty="0">
                 <a:solidFill>
                   <a:srgbClr val="1E293B"/>
                 </a:solidFill>
                 <a:latin typeface="Arial"/>
               </a:rPr>
-              <a:t>A donut chart maps the gender balance of the active applicant pool.</a:t>
+              <a:t>A donut chart maps the gender balance of the active applicant pool. A bar chart visualizes geographic distribution, showing top applicant states at a glance.</a:t>
             </a:r>
           </a:p>
           <a:p>
@@ -4424,7 +4464,7 @@
               <a:spcAft>
                 <a:spcPts val="1200"/>
               </a:spcAft>
-              <a:defRPr b="1" sz="1400">
+              <a:defRPr sz="1400" b="1">
                 <a:solidFill>
                   <a:srgbClr val="0F172A"/>
                 </a:solidFill>
@@ -4432,35 +4472,11 @@
               </a:defRPr>
             </a:pPr>
             <a:r>
-              <a:t>• Top Talent Hubs: </a:t>
-            </a:r>
-            <a:r>
-              <a:rPr b="0" sz="1300">
-                <a:solidFill>
-                  <a:srgbClr val="1E293B"/>
-                </a:solidFill>
-                <a:latin typeface="Arial"/>
-              </a:rPr>
-              <a:t>Visualizes geographic distribution, showing top applicant states at a glance.</a:t>
-            </a:r>
-          </a:p>
-          <a:p>
-            <a:pPr>
-              <a:spcAft>
-                <a:spcPts val="1200"/>
-              </a:spcAft>
-              <a:defRPr b="1" sz="1400">
-                <a:solidFill>
-                  <a:srgbClr val="0F172A"/>
-                </a:solidFill>
-                <a:latin typeface="Arial"/>
-              </a:defRPr>
-            </a:pPr>
-            <a:r>
+              <a:rPr lang="en-US" sz="1600" dirty="0"/>
               <a:t>• Hiring Pipeline Velocity: </a:t>
             </a:r>
             <a:r>
-              <a:rPr b="0" sz="1300">
+              <a:rPr lang="en-US" b="0" dirty="0">
                 <a:solidFill>
                   <a:srgbClr val="1E293B"/>
                 </a:solidFill>
@@ -4487,8 +4503,8 @@
         </p:blipFill>
         <p:spPr>
           <a:xfrm>
-            <a:off x="5943600" y="1371600"/>
-            <a:ext cx="5486400" cy="4389120"/>
+            <a:off x="5943599" y="1528996"/>
+            <a:ext cx="5883639" cy="4231723"/>
           </a:xfrm>
           <a:prstGeom prst="rect">
             <a:avLst/>
@@ -4504,7 +4520,7 @@
 </file>
 
 <file path=ppt/slides/slide7.xml><?xml version="1.0" encoding="utf-8"?>
-<p:sld xmlns:a="http://schemas.openxmlformats.org/drawingml/2006/main" xmlns:p="http://schemas.openxmlformats.org/presentationml/2006/main" xmlns:r="http://schemas.openxmlformats.org/officeDocument/2006/relationships">
+<p:sld xmlns:a="http://schemas.openxmlformats.org/drawingml/2006/main" xmlns:r="http://schemas.openxmlformats.org/officeDocument/2006/relationships" xmlns:p="http://schemas.openxmlformats.org/presentationml/2006/main">
   <p:cSld>
     <p:bg>
       <p:bgPr>
@@ -4520,7 +4536,14 @@
         <p:cNvGrpSpPr/>
         <p:nvPr/>
       </p:nvGrpSpPr>
-      <p:grpSpPr/>
+      <p:grpSpPr>
+        <a:xfrm>
+          <a:off x="0" y="0"/>
+          <a:ext cx="0" cy="0"/>
+          <a:chOff x="0" y="0"/>
+          <a:chExt cx="0" cy="0"/>
+        </a:xfrm>
+      </p:grpSpPr>
       <p:sp>
         <p:nvSpPr>
           <p:cNvPr id="2" name="TextBox 1"/>
@@ -4565,8 +4588,8 @@
         </p:nvSpPr>
         <p:spPr>
           <a:xfrm>
-            <a:off x="731520" y="1371600"/>
-            <a:ext cx="4937760" cy="4572000"/>
+            <a:off x="379751" y="2313310"/>
+            <a:ext cx="4937760" cy="2231380"/>
           </a:xfrm>
           <a:prstGeom prst="rect">
             <a:avLst/>
@@ -4583,7 +4606,7 @@
               <a:spcAft>
                 <a:spcPts val="1200"/>
               </a:spcAft>
-              <a:defRPr b="1" sz="1400">
+              <a:defRPr sz="1400" b="1">
                 <a:solidFill>
                   <a:srgbClr val="0F172A"/>
                 </a:solidFill>
@@ -4591,10 +4614,11 @@
               </a:defRPr>
             </a:pPr>
             <a:r>
-              <a:t>• Vacancy Deep-Dive: </a:t>
-            </a:r>
-            <a:r>
-              <a:rPr b="0" sz="1300">
+              <a:rPr sz="1600" dirty="0"/>
+              <a:t>• </a:t>
+            </a:r>
+            <a:r>
+              <a:rPr b="0" dirty="0">
                 <a:solidFill>
                   <a:srgbClr val="1E293B"/>
                 </a:solidFill>
@@ -4608,7 +4632,7 @@
               <a:spcAft>
                 <a:spcPts val="1200"/>
               </a:spcAft>
-              <a:defRPr b="1" sz="1400">
+              <a:defRPr sz="1400" b="1">
                 <a:solidFill>
                   <a:srgbClr val="0F172A"/>
                 </a:solidFill>
@@ -4616,16 +4640,17 @@
               </a:defRPr>
             </a:pPr>
             <a:r>
-              <a:t>• Seniority Ratios: </a:t>
-            </a:r>
-            <a:r>
-              <a:rPr b="0" sz="1300">
+              <a:rPr sz="1600" dirty="0"/>
+              <a:t>• Advanced Filters: </a:t>
+            </a:r>
+            <a:r>
+              <a:rPr b="0" dirty="0">
                 <a:solidFill>
                   <a:srgbClr val="1E293B"/>
                 </a:solidFill>
                 <a:latin typeface="Arial"/>
               </a:rPr>
-              <a:t>Visualizes the distribution of Ph.D., Masters, and Bachelors degrees in the pool.</a:t>
+              <a:t>Isolate candidate subsets instantly using biographical, academic, experience, and publication filters.</a:t>
             </a:r>
           </a:p>
           <a:p>
@@ -4633,7 +4658,7 @@
               <a:spcAft>
                 <a:spcPts val="1200"/>
               </a:spcAft>
-              <a:defRPr b="1" sz="1400">
+              <a:defRPr sz="1400" b="1">
                 <a:solidFill>
                   <a:srgbClr val="0F172A"/>
                 </a:solidFill>
@@ -4641,41 +4666,26 @@
               </a:defRPr>
             </a:pPr>
             <a:r>
-              <a:t>• Advanced Filters: </a:t>
-            </a:r>
-            <a:r>
-              <a:rPr b="0" sz="1300">
+              <a:rPr sz="1600" dirty="0"/>
+              <a:t>• No Decision Lag: </a:t>
+            </a:r>
+            <a:r>
+              <a:rPr sz="1600" b="0" dirty="0">
                 <a:solidFill>
                   <a:srgbClr val="1E293B"/>
                 </a:solidFill>
                 <a:latin typeface="Arial"/>
               </a:rPr>
-              <a:t>Isolate candidate subsets instantly using biographical, academic, experience, and publication filters.</a:t>
-            </a:r>
-          </a:p>
-          <a:p>
-            <a:pPr>
-              <a:spcAft>
-                <a:spcPts val="1200"/>
-              </a:spcAft>
-              <a:defRPr b="1" sz="1400">
-                <a:solidFill>
-                  <a:srgbClr val="0F172A"/>
-                </a:solidFill>
-                <a:latin typeface="Arial"/>
-              </a:defRPr>
-            </a:pPr>
-            <a:r>
-              <a:t>• No Decision Lag: </a:t>
-            </a:r>
-            <a:r>
-              <a:rPr b="0" sz="1300">
+              <a:t>Enables</a:t>
+            </a:r>
+            <a:r>
+              <a:rPr b="0" dirty="0">
                 <a:solidFill>
                   <a:srgbClr val="1E293B"/>
                 </a:solidFill>
                 <a:latin typeface="Arial"/>
               </a:rPr>
-              <a:t>Enables HR to search through hundreds of profiles in seconds without opening individual resumes.</a:t>
+              <a:t> HR to search through hundreds of profiles in seconds without opening individual resumes.</a:t>
             </a:r>
           </a:p>
         </p:txBody>
@@ -4696,8 +4706,8 @@
         </p:blipFill>
         <p:spPr>
           <a:xfrm>
-            <a:off x="5943600" y="1371600"/>
-            <a:ext cx="5486400" cy="4389120"/>
+            <a:off x="5317511" y="1334216"/>
+            <a:ext cx="6494738" cy="4426503"/>
           </a:xfrm>
           <a:prstGeom prst="rect">
             <a:avLst/>
@@ -4713,7 +4723,7 @@
 </file>
 
 <file path=ppt/slides/slide8.xml><?xml version="1.0" encoding="utf-8"?>
-<p:sld xmlns:a="http://schemas.openxmlformats.org/drawingml/2006/main" xmlns:p="http://schemas.openxmlformats.org/presentationml/2006/main" xmlns:r="http://schemas.openxmlformats.org/officeDocument/2006/relationships">
+<p:sld xmlns:a="http://schemas.openxmlformats.org/drawingml/2006/main" xmlns:r="http://schemas.openxmlformats.org/officeDocument/2006/relationships" xmlns:p="http://schemas.openxmlformats.org/presentationml/2006/main">
   <p:cSld>
     <p:bg>
       <p:bgPr>
@@ -4729,7 +4739,14 @@
         <p:cNvGrpSpPr/>
         <p:nvPr/>
       </p:nvGrpSpPr>
-      <p:grpSpPr/>
+      <p:grpSpPr>
+        <a:xfrm>
+          <a:off x="0" y="0"/>
+          <a:ext cx="0" cy="0"/>
+          <a:chOff x="0" y="0"/>
+          <a:chExt cx="0" cy="0"/>
+        </a:xfrm>
+      </p:grpSpPr>
       <p:sp>
         <p:nvSpPr>
           <p:cNvPr id="2" name="TextBox 1"/>
@@ -4761,6 +4778,7 @@
               </a:defRPr>
             </a:pPr>
             <a:r>
+              <a:rPr dirty="0"/>
               <a:t>Candidate Dossier: 360-Degree Profile View</a:t>
             </a:r>
           </a:p>
@@ -4895,7 +4913,7 @@
 </file>
 
 <file path=ppt/slides/slide9.xml><?xml version="1.0" encoding="utf-8"?>
-<p:sld xmlns:a="http://schemas.openxmlformats.org/drawingml/2006/main" xmlns:p="http://schemas.openxmlformats.org/presentationml/2006/main" xmlns:r="http://schemas.openxmlformats.org/officeDocument/2006/relationships">
+<p:sld xmlns:a="http://schemas.openxmlformats.org/drawingml/2006/main" xmlns:r="http://schemas.openxmlformats.org/officeDocument/2006/relationships" xmlns:p="http://schemas.openxmlformats.org/presentationml/2006/main">
   <p:cSld>
     <p:bg>
       <p:bgPr>
@@ -4911,7 +4929,14 @@
         <p:cNvGrpSpPr/>
         <p:nvPr/>
       </p:nvGrpSpPr>
-      <p:grpSpPr/>
+      <p:grpSpPr>
+        <a:xfrm>
+          <a:off x="0" y="0"/>
+          <a:ext cx="0" cy="0"/>
+          <a:chOff x="0" y="0"/>
+          <a:chExt cx="0" cy="0"/>
+        </a:xfrm>
+      </p:grpSpPr>
       <p:sp>
         <p:nvSpPr>
           <p:cNvPr id="2" name="TextBox 1"/>
@@ -4921,7 +4946,7 @@
         <p:spPr>
           <a:xfrm>
             <a:off x="731520" y="457200"/>
-            <a:ext cx="10698480" cy="731520"/>
+            <a:ext cx="10698480" cy="538609"/>
           </a:xfrm>
           <a:prstGeom prst="rect">
             <a:avLst/>
@@ -4943,7 +4968,16 @@
               </a:defRPr>
             </a:pPr>
             <a:r>
-              <a:t>Roster Exports: Clean Reports Generation</a:t>
+              <a:rPr dirty="0"/>
+              <a:t>Clean Report</a:t>
+            </a:r>
+            <a:r>
+              <a:rPr lang="en-IN" dirty="0"/>
+              <a:t> </a:t>
+            </a:r>
+            <a:r>
+              <a:rPr dirty="0"/>
+              <a:t>Generation</a:t>
             </a:r>
           </a:p>
         </p:txBody>
@@ -4957,7 +4991,7 @@
         <p:spPr>
           <a:xfrm>
             <a:off x="731520" y="1371600"/>
-            <a:ext cx="4937760" cy="4572000"/>
+            <a:ext cx="4937760" cy="538609"/>
           </a:xfrm>
           <a:prstGeom prst="rect">
             <a:avLst/>
@@ -4974,7 +5008,7 @@
               <a:spcAft>
                 <a:spcPts val="1200"/>
               </a:spcAft>
-              <a:defRPr b="1" sz="1400">
+              <a:defRPr sz="1400" b="1">
                 <a:solidFill>
                   <a:srgbClr val="0F172A"/>
                 </a:solidFill>
@@ -4982,91 +5016,17 @@
               </a:defRPr>
             </a:pPr>
             <a:r>
-              <a:t>• Flexible Formats: </a:t>
-            </a:r>
-            <a:r>
-              <a:rPr b="0" sz="1300">
+              <a:rPr dirty="0"/>
+              <a:t>• </a:t>
+            </a:r>
+            <a:r>
+              <a:rPr sz="1600" b="0" dirty="0">
                 <a:solidFill>
                   <a:srgbClr val="1E293B"/>
                 </a:solidFill>
                 <a:latin typeface="Arial"/>
               </a:rPr>
               <a:t>Download candidate data tailored to the requirements of the review committee.</a:t>
-            </a:r>
-          </a:p>
-          <a:p>
-            <a:pPr>
-              <a:spcAft>
-                <a:spcPts val="1200"/>
-              </a:spcAft>
-              <a:defRPr b="1" sz="1400">
-                <a:solidFill>
-                  <a:srgbClr val="0F172A"/>
-                </a:solidFill>
-                <a:latin typeface="Arial"/>
-              </a:defRPr>
-            </a:pPr>
-            <a:r>
-              <a:t>• Detailed Grouped Excel: </a:t>
-            </a:r>
-            <a:r>
-              <a:rPr b="0" sz="1300">
-                <a:solidFill>
-                  <a:srgbClr val="1E293B"/>
-                </a:solidFill>
-                <a:latin typeface="Arial"/>
-              </a:rPr>
-              <a:t>Candidate qualifications are stacked vertically with basic details merged, keeping layouts clean.</a:t>
-            </a:r>
-          </a:p>
-          <a:p>
-            <a:pPr>
-              <a:spcAft>
-                <a:spcPts val="1200"/>
-              </a:spcAft>
-              <a:defRPr b="1" sz="1400">
-                <a:solidFill>
-                  <a:srgbClr val="0F172A"/>
-                </a:solidFill>
-                <a:latin typeface="Arial"/>
-              </a:defRPr>
-            </a:pPr>
-            <a:r>
-              <a:t>• Standardized Summary: </a:t>
-            </a:r>
-            <a:r>
-              <a:rPr b="0" sz="1300">
-                <a:solidFill>
-                  <a:srgbClr val="1E293B"/>
-                </a:solidFill>
-                <a:latin typeface="Arial"/>
-              </a:rPr>
-              <a:t>Generates condensed reports displaying degrees and latest roles inline (e.g. 'Degree (University)').</a:t>
-            </a:r>
-          </a:p>
-          <a:p>
-            <a:pPr>
-              <a:spcAft>
-                <a:spcPts val="1200"/>
-              </a:spcAft>
-              <a:defRPr b="1" sz="1400">
-                <a:solidFill>
-                  <a:srgbClr val="0F172A"/>
-                </a:solidFill>
-                <a:latin typeface="Arial"/>
-              </a:defRPr>
-            </a:pPr>
-            <a:r>
-              <a:t>• Clean Score Normalization: </a:t>
-            </a:r>
-            <a:r>
-              <a:rPr b="0" sz="1300">
-                <a:solidFill>
-                  <a:srgbClr val="1E293B"/>
-                </a:solidFill>
-                <a:latin typeface="Arial"/>
-              </a:rPr>
-              <a:t>Automatically formats higher education scores ('79%' or '8 CGPA'), stripping trailing '.0' decimals.</a:t>
             </a:r>
           </a:p>
         </p:txBody>

</xml_diff>